<commit_message>
docs: pdfs de cronograma, guiones de sesion y apuntes maquetados tema 3
</commit_message>
<xml_diff>
--- a/Temas EB/Sesiones EB/Sesion 05/Sesion 05 - La Curva de Beveridge y Emparejamiento Laboral.pptx
+++ b/Temas EB/Sesiones EB/Sesion 05/Sesion 05 - La Curva de Beveridge y Emparejamiento Laboral.pptx
@@ -12,16 +12,17 @@
     <p:sldId id="260" r:id="rId6"/>
     <p:sldId id="261" r:id="rId7"/>
     <p:sldId id="262" r:id="rId8"/>
-    <p:sldId id="272" r:id="rId22"/>
-    <p:sldId id="263" r:id="rId9"/>
-    <p:sldId id="264" r:id="rId10"/>
-    <p:sldId id="265" r:id="rId11"/>
-    <p:sldId id="266" r:id="rId12"/>
-    <p:sldId id="267" r:id="rId13"/>
-    <p:sldId id="268" r:id="rId14"/>
-    <p:sldId id="269" r:id="rId15"/>
-    <p:sldId id="270" r:id="rId16"/>
-    <p:sldId id="271" r:id="rId17"/>
+    <p:sldId id="272" r:id="rId9"/>
+    <p:sldId id="265" r:id="rId10"/>
+    <p:sldId id="263" r:id="rId11"/>
+    <p:sldId id="264" r:id="rId12"/>
+    <p:sldId id="273" r:id="rId13"/>
+    <p:sldId id="266" r:id="rId14"/>
+    <p:sldId id="267" r:id="rId15"/>
+    <p:sldId id="268" r:id="rId16"/>
+    <p:sldId id="269" r:id="rId17"/>
+    <p:sldId id="270" r:id="rId18"/>
+    <p:sldId id="271" r:id="rId19"/>
   </p:sldIdLst>
   <p:sldSz cx="12192000" cy="6858000"/>
   <p:notesSz cx="6858000" cy="9144000"/>
@@ -3442,7 +3443,7 @@
               </a:defRPr>
             </a:pPr>
             <a:r>
-              <a:t>BLOQUE 3.5 · EVIDENCIA EMPÍRICA (AMPLIACIÓN L1)</a:t>
+              <a:t>BLOQUE 3 · TEORÍA Y DIAGNÓSTICO</a:t>
             </a:r>
           </a:p>
         </p:txBody>
@@ -3478,7 +3479,7 @@
               </a:defRPr>
             </a:pPr>
             <a:r>
-              <a:t>La Curva de Beveridge en España (1980–2024)</a:t>
+              <a:t>Geometría de Beveridge: Movimientos vs. Desplazamientos</a:t>
             </a:r>
           </a:p>
         </p:txBody>
@@ -3514,7 +3515,7 @@
               </a:defRPr>
             </a:pPr>
             <a:r>
-              <a:t>Figura 1.9 oficial de los apuntes: análisis de las tres fases históricas macroeconómicas</a:t>
+              <a:t>Epígrafe 6.2 oficial: la distinción analítica entre ciclo económico y desajuste estructural</a:t>
             </a:r>
           </a:p>
         </p:txBody>
@@ -3610,45 +3611,21 @@
               </a:defRPr>
             </a:pPr>
             <a:r>
-              <a:t>11 / 17</a:t>
-            </a:r>
-          </a:p>
-        </p:txBody>
-      </p:sp>
-      <p:pic>
-        <p:nvPicPr>
-          <p:cNvPr id="8" name="Picture 7" descr="curva_beveridge_dual.png"/>
-          <p:cNvPicPr>
-            <a:picLocks noChangeAspect="1"/>
-          </p:cNvPicPr>
-          <p:nvPr/>
-        </p:nvPicPr>
-        <p:blipFill>
-          <a:blip r:embed="rId3"/>
-          <a:stretch>
-            <a:fillRect/>
-          </a:stretch>
-        </p:blipFill>
+              <a:t>9 / 17</a:t>
+            </a:r>
+          </a:p>
+        </p:txBody>
+      </p:sp>
+      <p:sp>
+        <p:nvSpPr>
+          <p:cNvPr id="8" name="Rounded Rectangle 7"/>
+          <p:cNvSpPr/>
+          <p:nvPr/>
+        </p:nvSpPr>
         <p:spPr>
           <a:xfrm>
             <a:off x="548640" y="1645920"/>
-            <a:ext cx="6217920" cy="4389120"/>
-          </a:xfrm>
-          <a:prstGeom prst="rect">
-            <a:avLst/>
-          </a:prstGeom>
-        </p:spPr>
-      </p:pic>
-      <p:sp>
-        <p:nvSpPr>
-          <p:cNvPr id="9" name="Rounded Rectangle 8"/>
-          <p:cNvSpPr/>
-          <p:nvPr/>
-        </p:nvSpPr>
-        <p:spPr>
-          <a:xfrm>
-            <a:off x="6949440" y="1645920"/>
-            <a:ext cx="4663440" cy="4389120"/>
+            <a:ext cx="5394960" cy="4389120"/>
           </a:xfrm>
           <a:prstGeom prst="roundRect">
             <a:avLst/>
@@ -3658,7 +3635,7 @@
           </a:solidFill>
           <a:ln w="19050">
             <a:solidFill>
-              <a:srgbClr val="76927A"/>
+              <a:srgbClr val="DCE5DF"/>
             </a:solidFill>
           </a:ln>
         </p:spPr>
@@ -3677,14 +3654,14 @@
           </a:fontRef>
         </p:style>
         <p:txBody>
-          <a:bodyPr wrap="square" lIns="228600" tIns="182880" rIns="228600" rtlCol="0" anchor="ctr"/>
+          <a:bodyPr wrap="square" lIns="228600" tIns="201168" rIns="228600" rtlCol="0" anchor="ctr"/>
           <a:lstStyle/>
           <a:p>
             <a:pPr algn="ctr">
               <a:spcAft>
                 <a:spcPts val="1000"/>
               </a:spcAft>
-              <a:defRPr sz="1500" b="1">
+              <a:defRPr sz="1600" b="1">
                 <a:solidFill>
                   <a:srgbClr val="113927"/>
                 </a:solidFill>
@@ -3692,12 +3669,12 @@
               </a:defRPr>
             </a:pPr>
             <a:r>
-              <a:t>TRES FASES HISTÓRICAS (PANEL B)</a:t>
+              <a:t>1. MOVIMIENTOS A LO LARGO DE LA CURVA</a:t>
             </a:r>
           </a:p>
           <a:p>
             <a:pPr>
-              <a:defRPr sz="1500">
+              <a:defRPr sz="1600">
                 <a:solidFill>
                   <a:srgbClr val="2F3A30"/>
                 </a:solidFill>
@@ -3705,29 +3682,115 @@
               </a:defRPr>
             </a:pPr>
             <a:r>
-              <a:t>1. Fase 1 (1980–2007 · Pre-Crisis):</a:t>
-            </a:r>
-            <a:br/>
-            <a:r>
-              <a:t>Curva relativamente estable y próxima al origen, anclada en el Punto A. Funcionamiento eficiente.</a:t>
+              <a:t>• Causa Exclusiva: Shocks del Ciclo Económico (fluctuaciones de Demanda Agregada).</a:t>
             </a:r>
             <a:br/>
             <a:br/>
             <a:r>
-              <a:t>2. Fase 2 (2008–2013 · Gran Recesión):</a:t>
-            </a:r>
-            <a:br/>
-            <a:r>
-              <a:t>Desplazamiento masivo a la derecha (+5 p.p. de paro estructural). El shock del ladrillo dejó a cientos de miles de peones sin encaje directo en otros sectores.</a:t>
+              <a:t>• Fase de Recesión: La caída de ventas hace que las empresas congelen vacantes y destruyan empleo: movimiento hacia abajo y a la derecha (u ↑, v ↓).</a:t>
             </a:r>
             <a:br/>
             <a:br/>
             <a:r>
-              <a:t>3. Fase 3 (2014–2024 · Recuperación Parcial):</a:t>
+              <a:t>• Fase de Expansión: Aumenta la actividad, se publican más ofertas y se absorben parados: movimiento hacia arriba y a la izquierda (u ↓, v ↑).</a:t>
             </a:r>
             <a:br/>
-            <a:r>
-              <a:t>Retorno de ~3/4 del desplazamiento tras la reforma laboral de 2012. En 2024, récord histórico de vacantes (0,75%-0,90%) con paro rígido en 11,3%.</a:t>
+            <a:br/>
+            <a:r>
+              <a:t>• Pendiente Negativa: Relación inversa natural.</a:t>
+            </a:r>
+          </a:p>
+        </p:txBody>
+      </p:sp>
+      <p:sp>
+        <p:nvSpPr>
+          <p:cNvPr id="9" name="Rounded Rectangle 8"/>
+          <p:cNvSpPr/>
+          <p:nvPr/>
+        </p:nvSpPr>
+        <p:spPr>
+          <a:xfrm>
+            <a:off x="6217920" y="1645920"/>
+            <a:ext cx="5394960" cy="4389120"/>
+          </a:xfrm>
+          <a:prstGeom prst="roundRect">
+            <a:avLst/>
+          </a:prstGeom>
+          <a:solidFill>
+            <a:srgbClr val="FFFFFF"/>
+          </a:solidFill>
+          <a:ln w="19050">
+            <a:solidFill>
+              <a:srgbClr val="E98F71"/>
+            </a:solidFill>
+          </a:ln>
+        </p:spPr>
+        <p:style>
+          <a:lnRef idx="1">
+            <a:schemeClr val="accent1"/>
+          </a:lnRef>
+          <a:fillRef idx="3">
+            <a:schemeClr val="accent1"/>
+          </a:fillRef>
+          <a:effectRef idx="2">
+            <a:schemeClr val="accent1"/>
+          </a:effectRef>
+          <a:fontRef idx="minor">
+            <a:schemeClr val="lt1"/>
+          </a:fontRef>
+        </p:style>
+        <p:txBody>
+          <a:bodyPr wrap="square" lIns="228600" tIns="201168" rIns="228600" rtlCol="0" anchor="ctr"/>
+          <a:lstStyle/>
+          <a:p>
+            <a:pPr algn="ctr">
+              <a:spcAft>
+                <a:spcPts val="1000"/>
+              </a:spcAft>
+              <a:defRPr sz="1600" b="1">
+                <a:solidFill>
+                  <a:srgbClr val="113927"/>
+                </a:solidFill>
+                <a:latin typeface="Outfit"/>
+              </a:defRPr>
+            </a:pPr>
+            <a:r>
+              <a:t>2. DESPLAZAMIENTOS DE LA CURVA</a:t>
+            </a:r>
+          </a:p>
+          <a:p>
+            <a:pPr>
+              <a:defRPr sz="1600">
+                <a:solidFill>
+                  <a:srgbClr val="2F3A30"/>
+                </a:solidFill>
+                <a:latin typeface="Calibri"/>
+              </a:defRPr>
+            </a:pPr>
+            <a:r>
+              <a:t>• Causa Exclusiva: Cambios Estructurales en la Eficiencia del Emparejamiento (A).</a:t>
+            </a:r>
+            <a:br/>
+            <a:br/>
+            <a:r>
+              <a:t>• Desplazamiento Hacia el Exterior (BC1 ➔ BC2):</a:t>
+            </a:r>
+            <a:br/>
+            <a:r>
+              <a:t>  - Para una MISMA tasa de vacantes, hay MUCHO MÁS desempleo.</a:t>
+            </a:r>
+            <a:br/>
+            <a:r>
+              <a:t>  - Síntoma de desajuste formativo (skills mismatch), ineficiencia en el SAE/SEPE o histéresis.</a:t>
+            </a:r>
+            <a:br/>
+            <a:br/>
+            <a:r>
+              <a:t>• Desplazamiento Hacia el Origen (BC2 ➔ BC1):</a:t>
+            </a:r>
+            <a:br/>
+            <a:r>
+              <a:t>  - Aumento de la eficiencia (A ↑): mejor orientación, formación dual y digitalización.</a:t>
             </a:r>
           </a:p>
         </p:txBody>
@@ -3788,7 +3851,7 @@
               </a:defRPr>
             </a:pPr>
             <a:r>
-              <a:t>BLOQUE 3.5 · CUANTIFICACIÓN ANALÍTICA</a:t>
+              <a:t>BLOQUE 3 · INTERPRETACIÓN ECONÓMICA</a:t>
             </a:r>
           </a:p>
         </p:txBody>
@@ -3824,7 +3887,7 @@
               </a:defRPr>
             </a:pPr>
             <a:r>
-              <a:t>El Coste Macroeconómico de la Ineficiencia Laboral</a:t>
+              <a:t>Puntos Notables en la Curva de Beveridge</a:t>
             </a:r>
           </a:p>
         </p:txBody>
@@ -3860,7 +3923,7 @@
               </a:defRPr>
             </a:pPr>
             <a:r>
-              <a:t>Resultados del modelo dinámico de equilibrio general (DGEM) · FEDEA / Nada es Gratis</a:t>
+              <a:t>Epígrafe 6.3 oficial: equilibrio natural (Punto A) vs. desequilibrios macroeconómicos</a:t>
             </a:r>
           </a:p>
         </p:txBody>
@@ -3956,7 +4019,7 @@
               </a:defRPr>
             </a:pPr>
             <a:r>
-              <a:t>12 / 17</a:t>
+              <a:t>10 / 17</a:t>
             </a:r>
           </a:p>
         </p:txBody>
@@ -3970,7 +4033,7 @@
         <p:spPr>
           <a:xfrm>
             <a:off x="548640" y="1645920"/>
-            <a:ext cx="5394960" cy="4389120"/>
+            <a:ext cx="3611880" cy="4389120"/>
           </a:xfrm>
           <a:prstGeom prst="roundRect">
             <a:avLst/>
@@ -3999,14 +4062,14 @@
           </a:fontRef>
         </p:style>
         <p:txBody>
-          <a:bodyPr wrap="square" lIns="228600" tIns="201168" rIns="228600" rtlCol="0" anchor="ctr"/>
+          <a:bodyPr wrap="square" lIns="201168" tIns="201168" rIns="201168" rtlCol="0" anchor="ctr"/>
           <a:lstStyle/>
           <a:p>
             <a:pPr algn="ctr">
               <a:spcAft>
-                <a:spcPts val="1000"/>
+                <a:spcPts val="400"/>
               </a:spcAft>
-              <a:defRPr sz="1600" b="1">
+              <a:defRPr sz="1500" b="1">
                 <a:solidFill>
                   <a:srgbClr val="113927"/>
                 </a:solidFill>
@@ -4014,7 +4077,23 @@
               </a:defRPr>
             </a:pPr>
             <a:r>
-              <a:t>1. CUANTIFICACIÓN DEL IMPACTO</a:t>
+              <a:t>PUNTO A · TASA NATURAL</a:t>
+            </a:r>
+          </a:p>
+          <a:p>
+            <a:pPr>
+              <a:spcAft>
+                <a:spcPts val="1400"/>
+              </a:spcAft>
+              <a:defRPr sz="1200" b="1">
+                <a:solidFill>
+                  <a:srgbClr val="E98F71"/>
+                </a:solidFill>
+                <a:latin typeface="Outfit"/>
+              </a:defRPr>
+            </a:pPr>
+            <a:r>
+              <a:t>Sobre la Bisectriz (u = v)</a:t>
             </a:r>
           </a:p>
           <a:p>
@@ -4027,25 +4106,17 @@
               </a:defRPr>
             </a:pPr>
             <a:r>
-              <a:t>• Impacto sobre el Empleo:</a:t>
-            </a:r>
-            <a:br/>
-            <a:r>
-              <a:t>La caída en la eficiencia de emparejamiento (A) explica hasta el 31% de la destrucción total de puestos de trabajo durante la crisis.</a:t>
+              <a:t>La tasa de desempleo coincide con la de vacantes.</a:t>
             </a:r>
             <a:br/>
             <a:br/>
             <a:r>
-              <a:t>• Impacto sobre el PIB:</a:t>
-            </a:r>
-            <a:br/>
-            <a:r>
-              <a:t>El colapso en A explica el 55% de la disminución del Producto Interior Bruto en el punto más crítico de la recesión.</a:t>
+              <a:t>Todo el desempleo observado es puramente friccional o de reasignación saludable; no hay componente cíclico.</a:t>
             </a:r>
             <a:br/>
             <a:br/>
             <a:r>
-              <a:t>• Horas Trabajadas: El modelo explica el aumento anómalo de horas medias trabajadas por empleado durante la crisis.</a:t>
+              <a:t>Es el punto de referencia de equilibrio ideal para los responsables de política.</a:t>
             </a:r>
           </a:p>
         </p:txBody>
@@ -4058,18 +4129,18 @@
         </p:nvSpPr>
         <p:spPr>
           <a:xfrm>
-            <a:off x="6217920" y="1645920"/>
-            <a:ext cx="5394960" cy="4389120"/>
+            <a:off x="4343400" y="1645920"/>
+            <a:ext cx="3611880" cy="4389120"/>
           </a:xfrm>
           <a:prstGeom prst="roundRect">
             <a:avLst/>
           </a:prstGeom>
           <a:solidFill>
-            <a:srgbClr val="FFFFFF"/>
+            <a:srgbClr val="F4F8F5"/>
           </a:solidFill>
           <a:ln w="19050">
             <a:solidFill>
-              <a:srgbClr val="76927A"/>
+              <a:srgbClr val="DCE5DF"/>
             </a:solidFill>
           </a:ln>
         </p:spPr>
@@ -4088,14 +4159,14 @@
           </a:fontRef>
         </p:style>
         <p:txBody>
-          <a:bodyPr wrap="square" lIns="228600" tIns="201168" rIns="228600" rtlCol="0" anchor="ctr"/>
+          <a:bodyPr wrap="square" lIns="201168" tIns="201168" rIns="201168" rtlCol="0" anchor="ctr"/>
           <a:lstStyle/>
           <a:p>
             <a:pPr algn="ctr">
               <a:spcAft>
-                <a:spcPts val="1000"/>
+                <a:spcPts val="400"/>
               </a:spcAft>
-              <a:defRPr sz="1600" b="1">
+              <a:defRPr sz="1500" b="1">
                 <a:solidFill>
                   <a:srgbClr val="113927"/>
                 </a:solidFill>
@@ -4103,7 +4174,23 @@
               </a:defRPr>
             </a:pPr>
             <a:r>
-              <a:t>2. LECCIÓN CLAVE DE POLÍTICA PÚBLICA</a:t>
+              <a:t>PUNTO B · RECESIÓN SEVERA</a:t>
+            </a:r>
+          </a:p>
+          <a:p>
+            <a:pPr>
+              <a:spcAft>
+                <a:spcPts val="1400"/>
+              </a:spcAft>
+              <a:defRPr sz="1200" b="1">
+                <a:solidFill>
+                  <a:srgbClr val="E98F71"/>
+                </a:solidFill>
+                <a:latin typeface="Outfit"/>
+              </a:defRPr>
+            </a:pPr>
+            <a:r>
+              <a:t>Bajo la Bisectriz (u &gt; v)</a:t>
             </a:r>
           </a:p>
           <a:p>
@@ -4116,278 +4203,41 @@
               </a:defRPr>
             </a:pPr>
             <a:r>
-              <a:t>• El Error del Diagnóstico Exclusivo:</a:t>
-            </a:r>
-            <a:br/>
-            <a:r>
-              <a:t>Tradicionalmente se atribuyó la crisis laboral española solo a la rigidez de los costes de despido o a la negociación colectiva.</a:t>
+              <a:t>La tasa de desempleo supera ampliamente a la de vacantes ofertadas.</a:t>
             </a:r>
             <a:br/>
             <a:br/>
             <a:r>
-              <a:t>• La Importancia de la Intermediación:</a:t>
-            </a:r>
-            <a:br/>
-            <a:r>
-              <a:t>Este estudio demostró que la ineficiencia en las políticas activas y los servicios públicos de empleo (SAE/SEPE) multiplicó la recesión.</a:t>
+              <a:t>Existe un fuerte componente de desempleo involuntario keynesiano por insuficiencia de demanda agregada.</a:t>
             </a:r>
             <a:br/>
             <a:br/>
             <a:r>
-              <a:t>• Desafío Inmediato: Reducir la volatilidad estructural conectando educación y empresa.</a:t>
-            </a:r>
-          </a:p>
-        </p:txBody>
-      </p:sp>
-    </p:spTree>
-  </p:cSld>
-  <p:clrMapOvr>
-    <a:masterClrMapping/>
-  </p:clrMapOvr>
-</p:sld>
-</file>
-
-<file path=ppt/slides/slide12.xml><?xml version="1.0" encoding="utf-8"?>
-<p:sld xmlns:a="http://schemas.openxmlformats.org/drawingml/2006/main" xmlns:r="http://schemas.openxmlformats.org/officeDocument/2006/relationships" xmlns:p="http://schemas.openxmlformats.org/presentationml/2006/main">
-  <p:cSld>
-    <p:spTree>
-      <p:nvGrpSpPr>
-        <p:cNvPr id="1" name=""/>
-        <p:cNvGrpSpPr/>
-        <p:nvPr/>
-      </p:nvGrpSpPr>
-      <p:grpSpPr>
-        <a:xfrm>
-          <a:off x="0" y="0"/>
-          <a:ext cx="0" cy="0"/>
-          <a:chOff x="0" y="0"/>
-          <a:chExt cx="0" cy="0"/>
-        </a:xfrm>
-      </p:grpSpPr>
-      <p:sp>
-        <p:nvSpPr>
-          <p:cNvPr id="2" name="TextBox 1"/>
-          <p:cNvSpPr txBox="1"/>
-          <p:nvPr/>
-        </p:nvSpPr>
-        <p:spPr>
-          <a:xfrm>
-            <a:off x="548640" y="365760"/>
-            <a:ext cx="9144000" cy="274320"/>
-          </a:xfrm>
-          <a:prstGeom prst="rect">
-            <a:avLst/>
-          </a:prstGeom>
-          <a:noFill/>
-        </p:spPr>
-        <p:txBody>
-          <a:bodyPr wrap="square" lIns="0" tIns="0" rIns="0" bIns="0">
-            <a:spAutoFit/>
-          </a:bodyPr>
-          <a:lstStyle/>
-          <a:p>
-            <a:pPr>
-              <a:defRPr sz="1100" b="1">
-                <a:solidFill>
-                  <a:srgbClr val="E98F71"/>
-                </a:solidFill>
-                <a:latin typeface="Outfit"/>
-              </a:defRPr>
-            </a:pPr>
-            <a:r>
-              <a:t>BLOQUE 4 · LABORATORIO ACTIVO Y SIMULADOR (20 MIN)</a:t>
-            </a:r>
-          </a:p>
-        </p:txBody>
-      </p:sp>
-      <p:sp>
-        <p:nvSpPr>
-          <p:cNvPr id="3" name="TextBox 2"/>
-          <p:cNvSpPr txBox="1"/>
-          <p:nvPr/>
-        </p:nvSpPr>
-        <p:spPr>
-          <a:xfrm>
-            <a:off x="548640" y="621792"/>
-            <a:ext cx="9601200" cy="475488"/>
-          </a:xfrm>
-          <a:prstGeom prst="rect">
-            <a:avLst/>
-          </a:prstGeom>
-          <a:noFill/>
-        </p:spPr>
-        <p:txBody>
-          <a:bodyPr wrap="square" lIns="0" tIns="0" rIns="0" bIns="0">
-            <a:spAutoFit/>
-          </a:bodyPr>
-          <a:lstStyle/>
-          <a:p>
-            <a:pPr>
-              <a:defRPr sz="2400" b="1">
-                <a:solidFill>
-                  <a:srgbClr val="113927"/>
-                </a:solidFill>
-                <a:latin typeface="Outfit"/>
-              </a:defRPr>
-            </a:pPr>
-            <a:r>
-              <a:t>Simulador Móvil: Curva de Beveridge y Emparejamiento</a:t>
-            </a:r>
-          </a:p>
-        </p:txBody>
-      </p:sp>
-      <p:sp>
-        <p:nvSpPr>
-          <p:cNvPr id="4" name="TextBox 3"/>
-          <p:cNvSpPr txBox="1"/>
-          <p:nvPr/>
-        </p:nvSpPr>
-        <p:spPr>
-          <a:xfrm>
-            <a:off x="548640" y="1097280"/>
-            <a:ext cx="9601200" cy="347472"/>
-          </a:xfrm>
-          <a:prstGeom prst="rect">
-            <a:avLst/>
-          </a:prstGeom>
-          <a:noFill/>
-        </p:spPr>
-        <p:txBody>
-          <a:bodyPr wrap="square" lIns="0" tIns="0" rIns="0" bIns="0">
-            <a:spAutoFit/>
-          </a:bodyPr>
-          <a:lstStyle/>
-          <a:p>
-            <a:pPr>
-              <a:defRPr sz="1400">
-                <a:solidFill>
-                  <a:srgbClr val="76927A"/>
-                </a:solidFill>
-                <a:latin typeface="Calibri"/>
-              </a:defRPr>
-            </a:pPr>
-            <a:r>
-              <a:t>Misión técnica interactiva: rol de Analistas de la Consejería de Empleo desde el smartphone</a:t>
-            </a:r>
-          </a:p>
-        </p:txBody>
-      </p:sp>
-      <p:pic>
-        <p:nvPicPr>
-          <p:cNvPr id="5" name="Picture 4" descr="psll_lockup.png"/>
-          <p:cNvPicPr>
-            <a:picLocks noChangeAspect="1"/>
-          </p:cNvPicPr>
-          <p:nvPr/>
-        </p:nvPicPr>
-        <p:blipFill>
-          <a:blip r:embed="rId2"/>
-          <a:stretch>
-            <a:fillRect/>
-          </a:stretch>
-        </p:blipFill>
-        <p:spPr>
-          <a:xfrm>
-            <a:off x="10515600" y="365760"/>
-            <a:ext cx="1158544" cy="365760"/>
-          </a:xfrm>
-          <a:prstGeom prst="rect">
-            <a:avLst/>
-          </a:prstGeom>
-        </p:spPr>
-      </p:pic>
-      <p:sp>
-        <p:nvSpPr>
-          <p:cNvPr id="6" name="TextBox 5"/>
-          <p:cNvSpPr txBox="1"/>
-          <p:nvPr/>
-        </p:nvSpPr>
-        <p:spPr>
-          <a:xfrm>
-            <a:off x="548640" y="6400800"/>
-            <a:ext cx="9144000" cy="274320"/>
-          </a:xfrm>
-          <a:prstGeom prst="rect">
-            <a:avLst/>
-          </a:prstGeom>
-          <a:noFill/>
-        </p:spPr>
-        <p:txBody>
-          <a:bodyPr wrap="none" lIns="0" tIns="0" rIns="0" bIns="0">
-            <a:spAutoFit/>
-          </a:bodyPr>
-          <a:lstStyle/>
-          <a:p>
-            <a:pPr>
-              <a:defRPr sz="1000">
-                <a:solidFill>
-                  <a:srgbClr val="76927A"/>
-                </a:solidFill>
-                <a:latin typeface="Calibri"/>
-              </a:defRPr>
-            </a:pPr>
-            <a:r>
-              <a:t>Políticas Sociolaborales y de Empleo · Grado en RRLL y RRHH / Doble Grado DER-RRLL · UPO</a:t>
-            </a:r>
-          </a:p>
-        </p:txBody>
-      </p:sp>
-      <p:sp>
-        <p:nvSpPr>
-          <p:cNvPr id="7" name="TextBox 6"/>
-          <p:cNvSpPr txBox="1"/>
-          <p:nvPr/>
-        </p:nvSpPr>
-        <p:spPr>
-          <a:xfrm>
-            <a:off x="10515600" y="6400800"/>
-            <a:ext cx="1097280" cy="274320"/>
-          </a:xfrm>
-          <a:prstGeom prst="rect">
-            <a:avLst/>
-          </a:prstGeom>
-          <a:noFill/>
-        </p:spPr>
-        <p:txBody>
-          <a:bodyPr wrap="none" lIns="0" tIns="0" rIns="0" bIns="0">
-            <a:spAutoFit/>
-          </a:bodyPr>
-          <a:lstStyle/>
-          <a:p>
-            <a:pPr algn="r">
-              <a:defRPr sz="1000">
-                <a:solidFill>
-                  <a:srgbClr val="76927A"/>
-                </a:solidFill>
-                <a:latin typeface="Calibri"/>
-              </a:defRPr>
-            </a:pPr>
-            <a:r>
-              <a:t>13 / 17</a:t>
-            </a:r>
-          </a:p>
-        </p:txBody>
-      </p:sp>
-      <p:sp>
-        <p:nvSpPr>
-          <p:cNvPr id="8" name="Rounded Rectangle 7"/>
+              <a:t>Requiere políticas macroeconómicas y estabilizadores.</a:t>
+            </a:r>
+          </a:p>
+        </p:txBody>
+      </p:sp>
+      <p:sp>
+        <p:nvSpPr>
+          <p:cNvPr id="10" name="Rounded Rectangle 9"/>
           <p:cNvSpPr/>
           <p:nvPr/>
         </p:nvSpPr>
         <p:spPr>
           <a:xfrm>
-            <a:off x="548640" y="1645920"/>
-            <a:ext cx="6858000" cy="4389120"/>
+            <a:off x="8138160" y="1645920"/>
+            <a:ext cx="3611880" cy="4389120"/>
           </a:xfrm>
           <a:prstGeom prst="roundRect">
             <a:avLst/>
           </a:prstGeom>
           <a:solidFill>
-            <a:srgbClr val="FFFFFF"/>
+            <a:srgbClr val="F4F8F5"/>
           </a:solidFill>
           <a:ln w="19050">
             <a:solidFill>
-              <a:srgbClr val="76927A"/>
+              <a:srgbClr val="DCE5DF"/>
             </a:solidFill>
           </a:ln>
         </p:spPr>
@@ -4406,12 +4256,28 @@
           </a:fontRef>
         </p:style>
         <p:txBody>
-          <a:bodyPr wrap="square" lIns="256032" tIns="201168" rIns="256032" rtlCol="0" anchor="ctr"/>
+          <a:bodyPr wrap="square" lIns="201168" tIns="201168" rIns="201168" rtlCol="0" anchor="ctr"/>
           <a:lstStyle/>
           <a:p>
             <a:pPr algn="ctr">
               <a:spcAft>
-                <a:spcPts val="800"/>
+                <a:spcPts val="400"/>
+              </a:spcAft>
+              <a:defRPr sz="1500" b="1">
+                <a:solidFill>
+                  <a:srgbClr val="113927"/>
+                </a:solidFill>
+                <a:latin typeface="Outfit"/>
+              </a:defRPr>
+            </a:pPr>
+            <a:r>
+              <a:t>PUNTO C · SOBRECALENTAMIENTO</a:t>
+            </a:r>
+          </a:p>
+          <a:p>
+            <a:pPr>
+              <a:spcAft>
+                <a:spcPts val="1400"/>
               </a:spcAft>
               <a:defRPr sz="1200" b="1">
                 <a:solidFill>
@@ -4421,7 +4287,7 @@
               </a:defRPr>
             </a:pPr>
             <a:r>
-              <a:t>MISIÓN TÉCNICA · GABINETE DE LA CONSEJERÍA DE EMPLEO</a:t>
+              <a:t>Sobre la Bisectriz (u &lt; v)</a:t>
             </a:r>
           </a:p>
           <a:p>
@@ -4434,46 +4300,348 @@
               </a:defRPr>
             </a:pPr>
             <a:r>
-              <a:t>1. Apertura de la App en el Móvil: Escanear el código QR contiguo para abrir el simulador interactivo en HTML5 Canvas.</a:t>
+              <a:t>La tasa de vacantes supera al desempleo disponible en la economía.</a:t>
             </a:r>
             <a:br/>
             <a:br/>
             <a:r>
-              <a:t>2. Experimento 1 (Ciclo vs Estructura): Mover el control de Demanda Agregada manteniendo A constante. Comprobar cómo la economía se desplaza a lo largo de la curva UV.</a:t>
+              <a:t>Tensión crítica (θ &gt;&gt; 1): las empresas no encuentran mano de obra.</a:t>
             </a:r>
             <a:br/>
             <a:br/>
             <a:r>
-              <a:t>3. Experimento 2 (Shock de Desajuste): Activar el escenario de Skills Mismatch y caída de A. Observar cómo la curva entera se desplaza hacia el exterior.</a:t>
-            </a:r>
-            <a:br/>
-            <a:br/>
-            <a:r>
-              <a:t>4. Cumplimentar en parejas la Hoja de Laboratorio Activo.</a:t>
-            </a:r>
-          </a:p>
-        </p:txBody>
-      </p:sp>
-      <p:sp>
-        <p:nvSpPr>
-          <p:cNvPr id="9" name="Rounded Rectangle 8"/>
+              <a:t>Riesgo de presiones salariales inflacionistas según la Curva de Phillips aceleracionista.</a:t>
+            </a:r>
+          </a:p>
+        </p:txBody>
+      </p:sp>
+    </p:spTree>
+  </p:cSld>
+  <p:clrMapOvr>
+    <a:masterClrMapping/>
+  </p:clrMapOvr>
+</p:sld>
+</file>
+
+<file path=ppt/slides/slide12.xml><?xml version="1.0" encoding="utf-8"?>
+<p:sld xmlns:a="http://schemas.openxmlformats.org/drawingml/2006/main" xmlns:r="http://schemas.openxmlformats.org/officeDocument/2006/relationships" xmlns:p="http://schemas.openxmlformats.org/presentationml/2006/main">
+  <p:cSld>
+    <p:spTree>
+      <p:nvGrpSpPr>
+        <p:cNvPr id="1" name="">
+          <a:extLst>
+            <a:ext uri="{FF2B5EF4-FFF2-40B4-BE49-F238E27FC236}">
+              <a16:creationId xmlns:a16="http://schemas.microsoft.com/office/drawing/2014/main" id="{6300D231-1922-E95E-EF0B-90A9AADB65C4}"/>
+            </a:ext>
+          </a:extLst>
+        </p:cNvPr>
+        <p:cNvGrpSpPr/>
+        <p:nvPr/>
+      </p:nvGrpSpPr>
+      <p:grpSpPr>
+        <a:xfrm>
+          <a:off x="0" y="0"/>
+          <a:ext cx="0" cy="0"/>
+          <a:chOff x="0" y="0"/>
+          <a:chExt cx="0" cy="0"/>
+        </a:xfrm>
+      </p:grpSpPr>
+      <p:sp>
+        <p:nvSpPr>
+          <p:cNvPr id="2" name="TextBox 1">
+            <a:extLst>
+              <a:ext uri="{FF2B5EF4-FFF2-40B4-BE49-F238E27FC236}">
+                <a16:creationId xmlns:a16="http://schemas.microsoft.com/office/drawing/2014/main" id="{959DD111-46D1-34C2-D78D-B93F65FBBF94}"/>
+              </a:ext>
+            </a:extLst>
+          </p:cNvPr>
+          <p:cNvSpPr txBox="1"/>
+          <p:nvPr/>
+        </p:nvSpPr>
+        <p:spPr>
+          <a:xfrm>
+            <a:off x="548640" y="365760"/>
+            <a:ext cx="9144000" cy="274320"/>
+          </a:xfrm>
+          <a:prstGeom prst="rect">
+            <a:avLst/>
+          </a:prstGeom>
+          <a:noFill/>
+        </p:spPr>
+        <p:txBody>
+          <a:bodyPr wrap="square" lIns="0" tIns="0" rIns="0" bIns="0">
+            <a:spAutoFit/>
+          </a:bodyPr>
+          <a:lstStyle/>
+          <a:p>
+            <a:pPr>
+              <a:defRPr sz="1100" b="1">
+                <a:solidFill>
+                  <a:srgbClr val="E98F71"/>
+                </a:solidFill>
+                <a:latin typeface="Outfit"/>
+              </a:defRPr>
+            </a:pPr>
+            <a:r>
+              <a:t>BLOQUE 3.5 · EVIDENCIA EMPÍRICA (AMPLIACIÓN L1)</a:t>
+            </a:r>
+          </a:p>
+        </p:txBody>
+      </p:sp>
+      <p:sp>
+        <p:nvSpPr>
+          <p:cNvPr id="3" name="TextBox 2">
+            <a:extLst>
+              <a:ext uri="{FF2B5EF4-FFF2-40B4-BE49-F238E27FC236}">
+                <a16:creationId xmlns:a16="http://schemas.microsoft.com/office/drawing/2014/main" id="{D79FEF47-986B-EF7A-FE2A-55CD1796EC5E}"/>
+              </a:ext>
+            </a:extLst>
+          </p:cNvPr>
+          <p:cNvSpPr txBox="1"/>
+          <p:nvPr/>
+        </p:nvSpPr>
+        <p:spPr>
+          <a:xfrm>
+            <a:off x="548640" y="621792"/>
+            <a:ext cx="9601200" cy="475488"/>
+          </a:xfrm>
+          <a:prstGeom prst="rect">
+            <a:avLst/>
+          </a:prstGeom>
+          <a:noFill/>
+        </p:spPr>
+        <p:txBody>
+          <a:bodyPr wrap="square" lIns="0" tIns="0" rIns="0" bIns="0">
+            <a:spAutoFit/>
+          </a:bodyPr>
+          <a:lstStyle/>
+          <a:p>
+            <a:pPr>
+              <a:defRPr sz="2400" b="1">
+                <a:solidFill>
+                  <a:srgbClr val="113927"/>
+                </a:solidFill>
+                <a:latin typeface="Outfit"/>
+              </a:defRPr>
+            </a:pPr>
+            <a:r>
+              <a:t>La Curva de Beveridge en España (1980–2024)</a:t>
+            </a:r>
+          </a:p>
+        </p:txBody>
+      </p:sp>
+      <p:sp>
+        <p:nvSpPr>
+          <p:cNvPr id="4" name="TextBox 3">
+            <a:extLst>
+              <a:ext uri="{FF2B5EF4-FFF2-40B4-BE49-F238E27FC236}">
+                <a16:creationId xmlns:a16="http://schemas.microsoft.com/office/drawing/2014/main" id="{8E082E67-CA71-AC8C-22A6-9C7407091F2F}"/>
+              </a:ext>
+            </a:extLst>
+          </p:cNvPr>
+          <p:cNvSpPr txBox="1"/>
+          <p:nvPr/>
+        </p:nvSpPr>
+        <p:spPr>
+          <a:xfrm>
+            <a:off x="548640" y="1097280"/>
+            <a:ext cx="9601200" cy="347472"/>
+          </a:xfrm>
+          <a:prstGeom prst="rect">
+            <a:avLst/>
+          </a:prstGeom>
+          <a:noFill/>
+        </p:spPr>
+        <p:txBody>
+          <a:bodyPr wrap="square" lIns="0" tIns="0" rIns="0" bIns="0">
+            <a:spAutoFit/>
+          </a:bodyPr>
+          <a:lstStyle/>
+          <a:p>
+            <a:pPr>
+              <a:defRPr sz="1400">
+                <a:solidFill>
+                  <a:srgbClr val="76927A"/>
+                </a:solidFill>
+                <a:latin typeface="Calibri"/>
+              </a:defRPr>
+            </a:pPr>
+            <a:r>
+              <a:t>Figura 1.9 oficial de los apuntes: análisis de las tres fases históricas macroeconómicas</a:t>
+            </a:r>
+          </a:p>
+        </p:txBody>
+      </p:sp>
+      <p:pic>
+        <p:nvPicPr>
+          <p:cNvPr id="5" name="Picture 4" descr="psll_lockup.png">
+            <a:extLst>
+              <a:ext uri="{FF2B5EF4-FFF2-40B4-BE49-F238E27FC236}">
+                <a16:creationId xmlns:a16="http://schemas.microsoft.com/office/drawing/2014/main" id="{15905136-84FC-0632-C482-ADDAB6C375EF}"/>
+              </a:ext>
+            </a:extLst>
+          </p:cNvPr>
+          <p:cNvPicPr>
+            <a:picLocks noChangeAspect="1"/>
+          </p:cNvPicPr>
+          <p:nvPr/>
+        </p:nvPicPr>
+        <p:blipFill>
+          <a:blip r:embed="rId2"/>
+          <a:stretch>
+            <a:fillRect/>
+          </a:stretch>
+        </p:blipFill>
+        <p:spPr>
+          <a:xfrm>
+            <a:off x="10515600" y="365760"/>
+            <a:ext cx="1158544" cy="365760"/>
+          </a:xfrm>
+          <a:prstGeom prst="rect">
+            <a:avLst/>
+          </a:prstGeom>
+        </p:spPr>
+      </p:pic>
+      <p:sp>
+        <p:nvSpPr>
+          <p:cNvPr id="6" name="TextBox 5">
+            <a:extLst>
+              <a:ext uri="{FF2B5EF4-FFF2-40B4-BE49-F238E27FC236}">
+                <a16:creationId xmlns:a16="http://schemas.microsoft.com/office/drawing/2014/main" id="{FF0158CF-245D-A1B5-6D95-8F8BF787EE5C}"/>
+              </a:ext>
+            </a:extLst>
+          </p:cNvPr>
+          <p:cNvSpPr txBox="1"/>
+          <p:nvPr/>
+        </p:nvSpPr>
+        <p:spPr>
+          <a:xfrm>
+            <a:off x="548640" y="6400800"/>
+            <a:ext cx="9144000" cy="274320"/>
+          </a:xfrm>
+          <a:prstGeom prst="rect">
+            <a:avLst/>
+          </a:prstGeom>
+          <a:noFill/>
+        </p:spPr>
+        <p:txBody>
+          <a:bodyPr wrap="none" lIns="0" tIns="0" rIns="0" bIns="0">
+            <a:spAutoFit/>
+          </a:bodyPr>
+          <a:lstStyle/>
+          <a:p>
+            <a:pPr>
+              <a:defRPr sz="1000">
+                <a:solidFill>
+                  <a:srgbClr val="76927A"/>
+                </a:solidFill>
+                <a:latin typeface="Calibri"/>
+              </a:defRPr>
+            </a:pPr>
+            <a:r>
+              <a:t>Políticas Sociolaborales y de Empleo · Grado en RRLL y RRHH / Doble Grado DER-RRLL · UPO</a:t>
+            </a:r>
+          </a:p>
+        </p:txBody>
+      </p:sp>
+      <p:sp>
+        <p:nvSpPr>
+          <p:cNvPr id="7" name="TextBox 6">
+            <a:extLst>
+              <a:ext uri="{FF2B5EF4-FFF2-40B4-BE49-F238E27FC236}">
+                <a16:creationId xmlns:a16="http://schemas.microsoft.com/office/drawing/2014/main" id="{FBC307A8-0AA8-FD96-2643-6DCD8503FB92}"/>
+              </a:ext>
+            </a:extLst>
+          </p:cNvPr>
+          <p:cNvSpPr txBox="1"/>
+          <p:nvPr/>
+        </p:nvSpPr>
+        <p:spPr>
+          <a:xfrm>
+            <a:off x="10515600" y="6400800"/>
+            <a:ext cx="1097280" cy="274320"/>
+          </a:xfrm>
+          <a:prstGeom prst="rect">
+            <a:avLst/>
+          </a:prstGeom>
+          <a:noFill/>
+        </p:spPr>
+        <p:txBody>
+          <a:bodyPr wrap="none" lIns="0" tIns="0" rIns="0" bIns="0">
+            <a:spAutoFit/>
+          </a:bodyPr>
+          <a:lstStyle/>
+          <a:p>
+            <a:pPr algn="r">
+              <a:defRPr sz="1000">
+                <a:solidFill>
+                  <a:srgbClr val="76927A"/>
+                </a:solidFill>
+                <a:latin typeface="Calibri"/>
+              </a:defRPr>
+            </a:pPr>
+            <a:r>
+              <a:t>11 / 17</a:t>
+            </a:r>
+          </a:p>
+        </p:txBody>
+      </p:sp>
+      <p:pic>
+        <p:nvPicPr>
+          <p:cNvPr id="8" name="Picture 7" descr="curva_beveridge_dual.png">
+            <a:extLst>
+              <a:ext uri="{FF2B5EF4-FFF2-40B4-BE49-F238E27FC236}">
+                <a16:creationId xmlns:a16="http://schemas.microsoft.com/office/drawing/2014/main" id="{B04A6A34-94D0-0637-4A09-5732DC8D2A70}"/>
+              </a:ext>
+            </a:extLst>
+          </p:cNvPr>
+          <p:cNvPicPr>
+            <a:picLocks noChangeAspect="1"/>
+          </p:cNvPicPr>
+          <p:nvPr/>
+        </p:nvPicPr>
+        <p:blipFill>
+          <a:blip r:embed="rId3"/>
+          <a:stretch>
+            <a:fillRect/>
+          </a:stretch>
+        </p:blipFill>
+        <p:spPr>
+          <a:xfrm>
+            <a:off x="548640" y="1645920"/>
+            <a:ext cx="6217920" cy="4389120"/>
+          </a:xfrm>
+          <a:prstGeom prst="rect">
+            <a:avLst/>
+          </a:prstGeom>
+        </p:spPr>
+      </p:pic>
+      <p:sp>
+        <p:nvSpPr>
+          <p:cNvPr id="9" name="Rounded Rectangle 8">
+            <a:extLst>
+              <a:ext uri="{FF2B5EF4-FFF2-40B4-BE49-F238E27FC236}">
+                <a16:creationId xmlns:a16="http://schemas.microsoft.com/office/drawing/2014/main" id="{8D1A21B5-1FD5-580B-93DB-3A3EDE87EDCD}"/>
+              </a:ext>
+            </a:extLst>
+          </p:cNvPr>
           <p:cNvSpPr/>
           <p:nvPr/>
         </p:nvSpPr>
         <p:spPr>
           <a:xfrm>
-            <a:off x="7680960" y="1645920"/>
-            <a:ext cx="3931920" cy="4389120"/>
+            <a:off x="6949440" y="1645920"/>
+            <a:ext cx="4663440" cy="4389120"/>
           </a:xfrm>
           <a:prstGeom prst="roundRect">
             <a:avLst/>
           </a:prstGeom>
           <a:solidFill>
-            <a:srgbClr val="F4F8F5"/>
+            <a:srgbClr val="FFFFFF"/>
           </a:solidFill>
           <a:ln w="19050">
             <a:solidFill>
-              <a:srgbClr val="E98F71"/>
+              <a:srgbClr val="76927A"/>
             </a:solidFill>
           </a:ln>
         </p:spPr>
@@ -4492,24 +4660,8 @@
           </a:fontRef>
         </p:style>
         <p:txBody>
-          <a:bodyPr wrap="square" lIns="182880" tIns="201168" rIns="182880" rtlCol="0" anchor="ctr"/>
-          <a:lstStyle/>
-          <a:p>
-            <a:pPr algn="ctr">
-              <a:spcAft>
-                <a:spcPts val="600"/>
-              </a:spcAft>
-              <a:defRPr sz="1100" b="1">
-                <a:solidFill>
-                  <a:srgbClr val="113927"/>
-                </a:solidFill>
-                <a:latin typeface="Outfit"/>
-              </a:defRPr>
-            </a:pPr>
-            <a:r>
-              <a:t>ACCESO DIRECTO A LA MICRO-APP</a:t>
-            </a:r>
-          </a:p>
+          <a:bodyPr wrap="square" lIns="228600" tIns="182880" rIns="228600" rtlCol="0" anchor="ctr"/>
+          <a:lstStyle/>
           <a:p>
             <a:pPr algn="ctr">
               <a:spcAft>
@@ -4517,65 +4669,18 @@
               </a:spcAft>
               <a:defRPr sz="1500" b="1">
                 <a:solidFill>
-                  <a:srgbClr val="E98F71"/>
+                  <a:srgbClr val="113927"/>
                 </a:solidFill>
                 <a:latin typeface="Outfit"/>
               </a:defRPr>
             </a:pPr>
             <a:r>
-              <a:t>Simulador Beveridge &amp; DMP</a:t>
-            </a:r>
-          </a:p>
-        </p:txBody>
-      </p:sp>
-      <p:pic>
-        <p:nvPicPr>
-          <p:cNvPr id="10" name="Picture 9" descr="qr_app_sesion05.png"/>
-          <p:cNvPicPr>
-            <a:picLocks noChangeAspect="1"/>
-          </p:cNvPicPr>
-          <p:nvPr/>
-        </p:nvPicPr>
-        <p:blipFill>
-          <a:blip r:embed="rId3"/>
-          <a:stretch>
-            <a:fillRect/>
-          </a:stretch>
-        </p:blipFill>
-        <p:spPr>
-          <a:xfrm>
-            <a:off x="8412480" y="2560320"/>
-            <a:ext cx="2468880" cy="2468880"/>
-          </a:xfrm>
-          <a:prstGeom prst="rect">
-            <a:avLst/>
-          </a:prstGeom>
-        </p:spPr>
-      </p:pic>
-      <p:sp>
-        <p:nvSpPr>
-          <p:cNvPr id="11" name="TextBox 10"/>
-          <p:cNvSpPr txBox="1"/>
-          <p:nvPr/>
-        </p:nvSpPr>
-        <p:spPr>
-          <a:xfrm>
-            <a:off x="7772400" y="5166360"/>
-            <a:ext cx="3749039" cy="731520"/>
-          </a:xfrm>
-          <a:prstGeom prst="rect">
-            <a:avLst/>
-          </a:prstGeom>
-          <a:noFill/>
-        </p:spPr>
-        <p:txBody>
-          <a:bodyPr wrap="none">
-            <a:spAutoFit/>
-          </a:bodyPr>
-          <a:lstStyle/>
-          <a:p>
-            <a:pPr algn="ctr">
-              <a:defRPr sz="1300">
+              <a:t>TRES FASES HISTÓRICAS (PANEL B)</a:t>
+            </a:r>
+          </a:p>
+          <a:p>
+            <a:pPr>
+              <a:defRPr sz="1500">
                 <a:solidFill>
                   <a:srgbClr val="2F3A30"/>
                 </a:solidFill>
@@ -4583,16 +4688,39 @@
               </a:defRPr>
             </a:pPr>
             <a:r>
-              <a:t>mhidper.github.io/micro_apps</a:t>
+              <a:t>1. Fase 1 (1980–2007 · Pre-Crisis):</a:t>
             </a:r>
             <a:br/>
             <a:r>
-              <a:t>(Simulador interactivo · 15 min)</a:t>
+              <a:t>Curva relativamente estable y próxima al origen, anclada en el Punto A. Funcionamiento eficiente.</a:t>
+            </a:r>
+            <a:br/>
+            <a:br/>
+            <a:r>
+              <a:t>2. Fase 2 (2008–2013 · Gran Recesión):</a:t>
+            </a:r>
+            <a:br/>
+            <a:r>
+              <a:t>Desplazamiento masivo a la derecha (+5 p.p. de paro estructural). El shock del ladrillo dejó a cientos de miles de peones sin encaje directo en otros sectores.</a:t>
+            </a:r>
+            <a:br/>
+            <a:br/>
+            <a:r>
+              <a:t>3. Fase 3 (2014–2024 · Recuperación Parcial):</a:t>
+            </a:r>
+            <a:br/>
+            <a:r>
+              <a:t>Retorno de ~3/4 del desplazamiento tras la reforma laboral de 2012. En 2024, récord histórico de vacantes (0,75%-0,90%) con paro rígido en 11,3%.</a:t>
             </a:r>
           </a:p>
         </p:txBody>
       </p:sp>
     </p:spTree>
+    <p:extLst>
+      <p:ext uri="{BB962C8B-B14F-4D97-AF65-F5344CB8AC3E}">
+        <p14:creationId xmlns:p14="http://schemas.microsoft.com/office/powerpoint/2010/main" val="3455451888"/>
+      </p:ext>
+    </p:extLst>
   </p:cSld>
   <p:clrMapOvr>
     <a:masterClrMapping/>
@@ -4648,7 +4776,7 @@
               </a:defRPr>
             </a:pPr>
             <a:r>
-              <a:t>BLOQUE 4 · AUDITORÍA DE POLÍTICAS PÚBLICAS</a:t>
+              <a:t>BLOQUE 3.5 · CUANTIFICACIÓN ANALÍTICA</a:t>
             </a:r>
           </a:p>
         </p:txBody>
@@ -4684,7 +4812,7 @@
               </a:defRPr>
             </a:pPr>
             <a:r>
-              <a:t>El Programa Emplea-T y las Políticas Activas (PAE)</a:t>
+              <a:t>El Coste Macroeconómico de la Ineficiencia Laboral</a:t>
             </a:r>
           </a:p>
         </p:txBody>
@@ -4720,7 +4848,7 @@
               </a:defRPr>
             </a:pPr>
             <a:r>
-              <a:t>Conexión directa con el Caso 1 de EPD: auditoría de la Orden de 3 de octubre de 2024</a:t>
+              <a:t>Resultados del modelo dinámico de equilibrio general (DGEM) · FEDEA / Nada es Gratis</a:t>
             </a:r>
           </a:p>
         </p:txBody>
@@ -4816,7 +4944,7 @@
               </a:defRPr>
             </a:pPr>
             <a:r>
-              <a:t>14 / 17</a:t>
+              <a:t>12 / 17</a:t>
             </a:r>
           </a:p>
         </p:txBody>
@@ -4836,7 +4964,7 @@
             <a:avLst/>
           </a:prstGeom>
           <a:solidFill>
-            <a:srgbClr val="FFFFFF"/>
+            <a:srgbClr val="F4F8F5"/>
           </a:solidFill>
           <a:ln w="19050">
             <a:solidFill>
@@ -4874,7 +5002,7 @@
               </a:defRPr>
             </a:pPr>
             <a:r>
-              <a:t>1. EL RETO DEL PESO MUERTO (DEADWEIGHT)</a:t>
+              <a:t>1. CUANTIFICACIÓN DEL IMPACTO</a:t>
             </a:r>
           </a:p>
           <a:p>
@@ -4887,17 +5015,25 @@
               </a:defRPr>
             </a:pPr>
             <a:r>
-              <a:t>• Definición Económica: Subvencionar contrataciones que la empresa privada habría realizado de todos modos según su operativa habitual.</a:t>
+              <a:t>• Impacto sobre el Empleo:</a:t>
+            </a:r>
+            <a:br/>
+            <a:r>
+              <a:t>La caída en la eficiencia de emparejamiento (A) explica hasta el 31% de la destrucción total de puestos de trabajo durante la crisis.</a:t>
             </a:r>
             <a:br/>
             <a:br/>
             <a:r>
-              <a:t>• Impacto Presupuestario: El dinero público se transfiere como renta a la empresa sin generar empleo neto adicional, disparando el coste efectivo por parado rescatado.</a:t>
+              <a:t>• Impacto sobre el PIB:</a:t>
+            </a:r>
+            <a:br/>
+            <a:r>
+              <a:t>El colapso en A explica el 55% de la disminución del Producto Interior Bruto en el punto más crítico de la recesión.</a:t>
             </a:r>
             <a:br/>
             <a:br/>
             <a:r>
-              <a:t>• En Beveridge: No desplaza la curva hacia el origen; simplemente financia contrataciones que ya estaban previstas.</a:t>
+              <a:t>• Horas Trabajadas: El modelo explica el aumento anómalo de horas medias trabajadas por empleado durante la crisis.</a:t>
             </a:r>
           </a:p>
         </p:txBody>
@@ -4917,7 +5053,7 @@
             <a:avLst/>
           </a:prstGeom>
           <a:solidFill>
-            <a:srgbClr val="F4F8F5"/>
+            <a:srgbClr val="FFFFFF"/>
           </a:solidFill>
           <a:ln w="19050">
             <a:solidFill>
@@ -4955,7 +5091,7 @@
               </a:defRPr>
             </a:pPr>
             <a:r>
-              <a:t>2. CLÁUSULA ANTI-SUSTITUCIÓN</a:t>
+              <a:t>2. LECCIÓN CLAVE DE POLÍTICA PÚBLICA</a:t>
             </a:r>
           </a:p>
           <a:p>
@@ -4968,25 +5104,25 @@
               </a:defRPr>
             </a:pPr>
             <a:r>
-              <a:t>• El Riesgo de Sustitución: Despedir o no renovar a un trabajador veterano para contratar a un parado subvencionado por la Junta.</a:t>
+              <a:t>• El Error del Diagnóstico Exclusivo:</a:t>
+            </a:r>
+            <a:br/>
+            <a:r>
+              <a:t>Tradicionalmente se atribuyó la crisis laboral española solo a la rigidez de los costes de despido o a la negociación colectiva.</a:t>
             </a:r>
             <a:br/>
             <a:br/>
             <a:r>
-              <a:t>• Solución Técnica de la Orden Emplea-T:</a:t>
+              <a:t>• La Importancia de la Intermediación:</a:t>
             </a:r>
             <a:br/>
             <a:r>
-              <a:t>  - Exigir incremento neto de la plantilla media de los 12 meses anteriores.</a:t>
-            </a:r>
-            <a:br/>
-            <a:r>
-              <a:t>  - Compromiso de mantenimiento del puesto subvencionado durante al menos 12 o 24 meses.</a:t>
+              <a:t>Este estudio demostró que la ineficiencia en las políticas activas y los servicios públicos de empleo (SAE/SEPE) multiplicó la recesión.</a:t>
             </a:r>
             <a:br/>
             <a:br/>
             <a:r>
-              <a:t>• Clave para EPD: Auditar el cumplimiento de estas cláusulas en los microdatos.</a:t>
+              <a:t>• Desafío Inmediato: Reducir la volatilidad estructural conectando educación y empresa.</a:t>
             </a:r>
           </a:p>
         </p:txBody>
@@ -5047,7 +5183,7 @@
               </a:defRPr>
             </a:pPr>
             <a:r>
-              <a:t>SÍNTESIS Y CIERRE DE TEMA 1</a:t>
+              <a:t>BLOQUE 4 · LABORATORIO ACTIVO Y SIMULADOR (20 MIN)</a:t>
             </a:r>
           </a:p>
         </p:txBody>
@@ -5083,7 +5219,7 @@
               </a:defRPr>
             </a:pPr>
             <a:r>
-              <a:t>Las Tres Conclusiones Imborrables de Hoy</a:t>
+              <a:t>Simulador Móvil: Curva de Beveridge y Emparejamiento</a:t>
             </a:r>
           </a:p>
         </p:txBody>
@@ -5119,7 +5255,7 @@
               </a:defRPr>
             </a:pPr>
             <a:r>
-              <a:t>Resumen macroeconómico y puente hacia las sesiones prácticas de EPD</a:t>
+              <a:t>Misión técnica interactiva: rol de Analistas de la Consejería de Empleo desde el smartphone</a:t>
             </a:r>
           </a:p>
         </p:txBody>
@@ -5215,7 +5351,7 @@
               </a:defRPr>
             </a:pPr>
             <a:r>
-              <a:t>15 / 17</a:t>
+              <a:t>13 / 17</a:t>
             </a:r>
           </a:p>
         </p:txBody>
@@ -5229,7 +5365,7 @@
         <p:spPr>
           <a:xfrm>
             <a:off x="548640" y="1645920"/>
-            <a:ext cx="11091672" cy="1325880"/>
+            <a:ext cx="6858000" cy="4389120"/>
           </a:xfrm>
           <a:prstGeom prst="roundRect">
             <a:avLst/>
@@ -5239,7 +5375,7 @@
           </a:solidFill>
           <a:ln w="19050">
             <a:solidFill>
-              <a:srgbClr val="DCE5DF"/>
+              <a:srgbClr val="76927A"/>
             </a:solidFill>
           </a:ln>
         </p:spPr>
@@ -5258,22 +5394,22 @@
           </a:fontRef>
         </p:style>
         <p:txBody>
-          <a:bodyPr wrap="square" lIns="228600" tIns="164592" rIns="228600" rtlCol="0" anchor="ctr"/>
+          <a:bodyPr wrap="square" lIns="256032" tIns="201168" rIns="256032" rtlCol="0" anchor="ctr"/>
           <a:lstStyle/>
           <a:p>
             <a:pPr algn="ctr">
               <a:spcAft>
-                <a:spcPts val="400"/>
+                <a:spcPts val="800"/>
               </a:spcAft>
-              <a:defRPr sz="1500" b="1">
-                <a:solidFill>
-                  <a:srgbClr val="113927"/>
+              <a:defRPr sz="1200" b="1">
+                <a:solidFill>
+                  <a:srgbClr val="E98F71"/>
                 </a:solidFill>
                 <a:latin typeface="Outfit"/>
               </a:defRPr>
             </a:pPr>
             <a:r>
-              <a:t>1. EL DESEMPLEO ES UN BALANCE DINÁMICO DE FLUJOS</a:t>
+              <a:t>MISIÓN TÉCNICA · GABINETE DE LA CONSEJERÍA DE EMPLEO</a:t>
             </a:r>
           </a:p>
           <a:p>
@@ -5286,7 +5422,22 @@
               </a:defRPr>
             </a:pPr>
             <a:r>
-              <a:t>La tasa natural estacionaria u* = s / (s + f) demuestra que el desempleo no es una masa estática. Las políticas públicas deben actuar simultáneamente sobre la estabilidad en el empleo (reducir s) y sobre la eficacia de la intermediación y recolocación (aumentar f).</a:t>
+              <a:t>1. Apertura de la App en el Móvil: Escanear el código QR contiguo para abrir el simulador interactivo en HTML5 Canvas.</a:t>
+            </a:r>
+            <a:br/>
+            <a:br/>
+            <a:r>
+              <a:t>2. Experimento 1 (Ciclo vs Estructura): Mover el control de Demanda Agregada manteniendo A constante. Comprobar cómo la economía se desplaza a lo largo de la curva UV.</a:t>
+            </a:r>
+            <a:br/>
+            <a:br/>
+            <a:r>
+              <a:t>3. Experimento 2 (Shock de Desajuste): Activar el escenario de Skills Mismatch y caída de A. Observar cómo la curva entera se desplaza hacia el exterior.</a:t>
+            </a:r>
+            <a:br/>
+            <a:br/>
+            <a:r>
+              <a:t>4. Cumplimentar en parejas la Hoja de Laboratorio Activo.</a:t>
             </a:r>
           </a:p>
         </p:txBody>
@@ -5299,18 +5450,18 @@
         </p:nvSpPr>
         <p:spPr>
           <a:xfrm>
-            <a:off x="548640" y="3154680"/>
-            <a:ext cx="11091672" cy="1325880"/>
+            <a:off x="7680960" y="1645920"/>
+            <a:ext cx="3931920" cy="4389120"/>
           </a:xfrm>
           <a:prstGeom prst="roundRect">
             <a:avLst/>
           </a:prstGeom>
           <a:solidFill>
-            <a:srgbClr val="FFFFFF"/>
+            <a:srgbClr val="F4F8F5"/>
           </a:solidFill>
           <a:ln w="19050">
             <a:solidFill>
-              <a:srgbClr val="DCE5DF"/>
+              <a:srgbClr val="E98F71"/>
             </a:solidFill>
           </a:ln>
         </p:spPr>
@@ -5329,27 +5480,90 @@
           </a:fontRef>
         </p:style>
         <p:txBody>
-          <a:bodyPr wrap="square" lIns="228600" tIns="164592" rIns="228600" rtlCol="0" anchor="ctr"/>
+          <a:bodyPr wrap="square" lIns="182880" tIns="201168" rIns="182880" rtlCol="0" anchor="ctr"/>
           <a:lstStyle/>
           <a:p>
             <a:pPr algn="ctr">
               <a:spcAft>
-                <a:spcPts val="400"/>
+                <a:spcPts val="600"/>
+              </a:spcAft>
+              <a:defRPr sz="1100" b="1">
+                <a:solidFill>
+                  <a:srgbClr val="113927"/>
+                </a:solidFill>
+                <a:latin typeface="Outfit"/>
+              </a:defRPr>
+            </a:pPr>
+            <a:r>
+              <a:t>ACCESO DIRECTO A LA MICRO-APP</a:t>
+            </a:r>
+          </a:p>
+          <a:p>
+            <a:pPr algn="ctr">
+              <a:spcAft>
+                <a:spcPts val="1000"/>
               </a:spcAft>
               <a:defRPr sz="1500" b="1">
                 <a:solidFill>
-                  <a:srgbClr val="113927"/>
+                  <a:srgbClr val="E98F71"/>
                 </a:solidFill>
                 <a:latin typeface="Outfit"/>
               </a:defRPr>
             </a:pPr>
             <a:r>
-              <a:t>2. BEVERIDGE DIFERENCIA EL CICLO DE LA ESTRUCTURA</a:t>
-            </a:r>
-          </a:p>
-          <a:p>
-            <a:pPr>
-              <a:defRPr sz="1600">
+              <a:t>Simulador Beveridge &amp; DMP</a:t>
+            </a:r>
+          </a:p>
+        </p:txBody>
+      </p:sp>
+      <p:pic>
+        <p:nvPicPr>
+          <p:cNvPr id="10" name="Picture 9" descr="qr_app_sesion05.png"/>
+          <p:cNvPicPr>
+            <a:picLocks noChangeAspect="1"/>
+          </p:cNvPicPr>
+          <p:nvPr/>
+        </p:nvPicPr>
+        <p:blipFill>
+          <a:blip r:embed="rId3"/>
+          <a:stretch>
+            <a:fillRect/>
+          </a:stretch>
+        </p:blipFill>
+        <p:spPr>
+          <a:xfrm>
+            <a:off x="8412480" y="2560320"/>
+            <a:ext cx="2468880" cy="2468880"/>
+          </a:xfrm>
+          <a:prstGeom prst="rect">
+            <a:avLst/>
+          </a:prstGeom>
+        </p:spPr>
+      </p:pic>
+      <p:sp>
+        <p:nvSpPr>
+          <p:cNvPr id="11" name="TextBox 10"/>
+          <p:cNvSpPr txBox="1"/>
+          <p:nvPr/>
+        </p:nvSpPr>
+        <p:spPr>
+          <a:xfrm>
+            <a:off x="7772400" y="5166360"/>
+            <a:ext cx="3749039" cy="731520"/>
+          </a:xfrm>
+          <a:prstGeom prst="rect">
+            <a:avLst/>
+          </a:prstGeom>
+          <a:noFill/>
+        </p:spPr>
+        <p:txBody>
+          <a:bodyPr wrap="none">
+            <a:spAutoFit/>
+          </a:bodyPr>
+          <a:lstStyle/>
+          <a:p>
+            <a:pPr algn="ctr">
+              <a:defRPr sz="1300">
                 <a:solidFill>
                   <a:srgbClr val="2F3A30"/>
                 </a:solidFill>
@@ -5357,78 +5571,11 @@
               </a:defRPr>
             </a:pPr>
             <a:r>
-              <a:t>Un shock de demanda mueve la economía a lo largo de la curva de Beveridge (recesión keynesiana). Un desajuste de habilidades o ineficiencia institucional desplaza la curva entera hacia afuera. El gasto de demanda generalizado ante desajustes solo produce inflación.</a:t>
-            </a:r>
-          </a:p>
-        </p:txBody>
-      </p:sp>
-      <p:sp>
-        <p:nvSpPr>
-          <p:cNvPr id="10" name="Rounded Rectangle 9"/>
-          <p:cNvSpPr/>
-          <p:nvPr/>
-        </p:nvSpPr>
-        <p:spPr>
-          <a:xfrm>
-            <a:off x="548640" y="4663440"/>
-            <a:ext cx="11091672" cy="1325880"/>
-          </a:xfrm>
-          <a:prstGeom prst="roundRect">
-            <a:avLst/>
-          </a:prstGeom>
-          <a:solidFill>
-            <a:srgbClr val="F4F8F5"/>
-          </a:solidFill>
-          <a:ln w="19050">
-            <a:solidFill>
-              <a:srgbClr val="E98F71"/>
-            </a:solidFill>
-          </a:ln>
-        </p:spPr>
-        <p:style>
-          <a:lnRef idx="1">
-            <a:schemeClr val="accent1"/>
-          </a:lnRef>
-          <a:fillRef idx="3">
-            <a:schemeClr val="accent1"/>
-          </a:fillRef>
-          <a:effectRef idx="2">
-            <a:schemeClr val="accent1"/>
-          </a:effectRef>
-          <a:fontRef idx="minor">
-            <a:schemeClr val="lt1"/>
-          </a:fontRef>
-        </p:style>
-        <p:txBody>
-          <a:bodyPr wrap="square" lIns="228600" tIns="164592" rIns="228600" rtlCol="0" anchor="ctr"/>
-          <a:lstStyle/>
-          <a:p>
-            <a:pPr algn="ctr">
-              <a:spcAft>
-                <a:spcPts val="400"/>
-              </a:spcAft>
-              <a:defRPr sz="1500" b="1">
-                <a:solidFill>
-                  <a:srgbClr val="113927"/>
-                </a:solidFill>
-                <a:latin typeface="Outfit"/>
-              </a:defRPr>
-            </a:pPr>
-            <a:r>
-              <a:t>3. PRÓXIMA PARADA: CASO 1 EN EPD Y TEMA 2 (POLÍTICAS ACTIVAS)</a:t>
-            </a:r>
-          </a:p>
-          <a:p>
-            <a:pPr>
-              <a:defRPr sz="1600">
-                <a:solidFill>
-                  <a:srgbClr val="2F3A30"/>
-                </a:solidFill>
-                <a:latin typeface="Calibri"/>
-              </a:defRPr>
-            </a:pPr>
-            <a:r>
-              <a:t>Concluimos formalmente el Tema 1. En la Semana 5 arrancan las prácticas EPD en el aula de informática, donde vuestro equipo auditará los microdatos reales del Programa Emplea-T aplicando todo el instrumental analítico aprendido.</a:t>
+              <a:t>mhidper.github.io/micro_apps</a:t>
+            </a:r>
+            <a:br/>
+            <a:r>
+              <a:t>(Simulador interactivo · 15 min)</a:t>
             </a:r>
           </a:p>
         </p:txBody>
@@ -5489,7 +5636,7 @@
               </a:defRPr>
             </a:pPr>
             <a:r>
-              <a:t>BLOQUE 5 · RETO INDIVIDUAL DE CIERRE (10 MIN)</a:t>
+              <a:t>BLOQUE 4 · AUDITORÍA DE POLÍTICAS PÚBLICAS</a:t>
             </a:r>
           </a:p>
         </p:txBody>
@@ -5525,7 +5672,7 @@
               </a:defRPr>
             </a:pPr>
             <a:r>
-              <a:t>Reto Manuscrito Anti-IA en Papel: Beveridge y Flujos</a:t>
+              <a:t>El Programa Emplea-T y las Políticas Activas (PAE)</a:t>
             </a:r>
           </a:p>
         </p:txBody>
@@ -5561,7 +5708,7 @@
               </a:defRPr>
             </a:pPr>
             <a:r>
-              <a:t>Redacción individual de puño y letra en cuartilla de papel en entorno libre de pantallas</a:t>
+              <a:t>Conexión directa con el Caso 1 de EPD: auditoría de la Orden de 3 de octubre de 2024</a:t>
             </a:r>
           </a:p>
         </p:txBody>
@@ -5657,7 +5804,7 @@
               </a:defRPr>
             </a:pPr>
             <a:r>
-              <a:t>16 / 17</a:t>
+              <a:t>14 / 17</a:t>
             </a:r>
           </a:p>
         </p:txBody>
@@ -5707,7 +5854,7 @@
               <a:spcAft>
                 <a:spcPts val="1000"/>
               </a:spcAft>
-              <a:defRPr sz="1500" b="1">
+              <a:defRPr sz="1600" b="1">
                 <a:solidFill>
                   <a:srgbClr val="113927"/>
                 </a:solidFill>
@@ -5715,7 +5862,7 @@
               </a:defRPr>
             </a:pPr>
             <a:r>
-              <a:t>PREGUNTA 1 · CONCEPTUAL (500 PTS)</a:t>
+              <a:t>1. EL RETO DEL PESO MUERTO (DEADWEIGHT)</a:t>
             </a:r>
           </a:p>
           <a:p>
@@ -5728,17 +5875,17 @@
               </a:defRPr>
             </a:pPr>
             <a:r>
-              <a:t>A partir de la condición de flujo estacionario y la función de emparejamiento m = A·U^α·V^(1-α):</a:t>
+              <a:t>• Definición Económica: Subvencionar contrataciones que la empresa privada habría realizado de todos modos según su operativa habitual.</a:t>
             </a:r>
             <a:br/>
             <a:br/>
             <a:r>
-              <a:t>a) Demuestre analíticamente por qué la tasa natural de desempleo de equilibrio a largo plazo es u* = s / (s + f) y defina con precisión las variables s y f.</a:t>
+              <a:t>• Impacto Presupuestario: El dinero público se transfiere como renta a la empresa sin generar empleo neto adicional, disparando el coste efectivo por parado rescatado.</a:t>
             </a:r>
             <a:br/>
             <a:br/>
             <a:r>
-              <a:t>b) Utilizando el marco de la Curva de Beveridge, distinga conceptualmente entre un movimiento a lo largo de la curva y un desplazamiento hacia el exterior, indicando qué variables provocan cada uno.</a:t>
+              <a:t>• En Beveridge: No desplaza la curva hacia el origen; simplemente financia contrataciones que ya estaban previstas.</a:t>
             </a:r>
           </a:p>
         </p:txBody>
@@ -5758,11 +5905,11 @@
             <a:avLst/>
           </a:prstGeom>
           <a:solidFill>
-            <a:srgbClr val="FFFFFF"/>
+            <a:srgbClr val="F4F8F5"/>
           </a:solidFill>
           <a:ln w="19050">
             <a:solidFill>
-              <a:srgbClr val="E98F71"/>
+              <a:srgbClr val="76927A"/>
             </a:solidFill>
           </a:ln>
         </p:spPr>
@@ -5788,7 +5935,7 @@
               <a:spcAft>
                 <a:spcPts val="1000"/>
               </a:spcAft>
-              <a:defRPr sz="1500" b="1">
+              <a:defRPr sz="1600" b="1">
                 <a:solidFill>
                   <a:srgbClr val="113927"/>
                 </a:solidFill>
@@ -5796,7 +5943,7 @@
               </a:defRPr>
             </a:pPr>
             <a:r>
-              <a:t>PREGUNTA 2 · APLICADA (500 PTS)</a:t>
+              <a:t>2. CLÁUSULA ANTI-SUSTITUCIÓN</a:t>
             </a:r>
           </a:p>
           <a:p>
@@ -5809,22 +5956,25 @@
               </a:defRPr>
             </a:pPr>
             <a:r>
-              <a:t>En España coexisten 155.000 vacantes sin cubrir (v ≈ 0,75%) y una tasa de paro del 11,3%:</a:t>
+              <a:t>• El Riesgo de Sustitución: Despedir o no renovar a un trabajador veterano para contratar a un parado subvencionado por la Junta.</a:t>
             </a:r>
             <a:br/>
             <a:br/>
             <a:r>
-              <a:t>a) Represente gráficamente la situación en el plano (U,V), sitúe la posición respecto a la bisectriz y determine si el problema es cíclico o estructural.</a:t>
+              <a:t>• Solución Técnica de la Orden Emplea-T:</a:t>
+            </a:r>
+            <a:br/>
+            <a:r>
+              <a:t>  - Exigir incremento neto de la plantilla media de los 12 meses anteriores.</a:t>
+            </a:r>
+            <a:br/>
+            <a:r>
+              <a:t>  - Compromiso de mantenimiento del puesto subvencionado durante al menos 12 o 24 meses.</a:t>
             </a:r>
             <a:br/>
             <a:br/>
             <a:r>
-              <a:t>b) Si el gobierno inyecta 10.000 M€ en estímulos fiscales de consumo creyendo que el paro es puramente cíclico: ¿qué ocurrirá con vacantes, paro e inflación?</a:t>
-            </a:r>
-            <a:br/>
-            <a:br/>
-            <a:r>
-              <a:t>c) En el Programa Emplea-T, proponga medidas que eleven A y explique cómo evitar el peso muerto (deadweight).</a:t>
+              <a:t>• Clave para EPD: Auditar el cumplimiento de estas cláusulas en los microdatos.</a:t>
             </a:r>
           </a:p>
         </p:txBody>
@@ -5885,7 +6035,7 @@
               </a:defRPr>
             </a:pPr>
             <a:r>
-              <a:t>BLOQUE 5 · SUBIDA FOTOGRÁFICA Y RÚBRICA (5 MIN)</a:t>
+              <a:t>SÍNTESIS Y CIERRE DE TEMA 1</a:t>
             </a:r>
           </a:p>
         </p:txBody>
@@ -5921,7 +6071,7 @@
               </a:defRPr>
             </a:pPr>
             <a:r>
-              <a:t>Envío Digital Autenticado del Reto Manuscrito</a:t>
+              <a:t>Las Tres Conclusiones Imborrables de Hoy</a:t>
             </a:r>
           </a:p>
         </p:txBody>
@@ -5957,7 +6107,7 @@
               </a:defRPr>
             </a:pPr>
             <a:r>
-              <a:t>Fotografía y subida instantánea mediante código QR institucional UPO en Microsoft Forms</a:t>
+              <a:t>Resumen macroeconómico y puente hacia las sesiones prácticas de EPD</a:t>
             </a:r>
           </a:p>
         </p:txBody>
@@ -6053,7 +6203,7 @@
               </a:defRPr>
             </a:pPr>
             <a:r>
-              <a:t>17 / 17</a:t>
+              <a:t>15 / 17</a:t>
             </a:r>
           </a:p>
         </p:txBody>
@@ -6067,7 +6217,7 @@
         <p:spPr>
           <a:xfrm>
             <a:off x="548640" y="1645920"/>
-            <a:ext cx="6858000" cy="4389120"/>
+            <a:ext cx="11091672" cy="1325880"/>
           </a:xfrm>
           <a:prstGeom prst="roundRect">
             <a:avLst/>
@@ -6077,7 +6227,7 @@
           </a:solidFill>
           <a:ln w="19050">
             <a:solidFill>
-              <a:srgbClr val="76927A"/>
+              <a:srgbClr val="DCE5DF"/>
             </a:solidFill>
           </a:ln>
         </p:spPr>
@@ -6096,22 +6246,22 @@
           </a:fontRef>
         </p:style>
         <p:txBody>
-          <a:bodyPr wrap="square" lIns="256032" tIns="201168" rIns="256032" rtlCol="0" anchor="ctr"/>
+          <a:bodyPr wrap="square" lIns="228600" tIns="164592" rIns="228600" rtlCol="0" anchor="ctr"/>
           <a:lstStyle/>
           <a:p>
             <a:pPr algn="ctr">
               <a:spcAft>
-                <a:spcPts val="800"/>
+                <a:spcPts val="400"/>
               </a:spcAft>
-              <a:defRPr sz="1200" b="1">
-                <a:solidFill>
-                  <a:srgbClr val="E98F71"/>
+              <a:defRPr sz="1500" b="1">
+                <a:solidFill>
+                  <a:srgbClr val="113927"/>
                 </a:solidFill>
                 <a:latin typeface="Outfit"/>
               </a:defRPr>
             </a:pPr>
             <a:r>
-              <a:t>PASAPORTE DE EVALUACIÓN CONTINUA · PSLL</a:t>
+              <a:t>1. EL DESEMPLEO ES UN BALANCE DINÁMICO DE FLUJOS</a:t>
             </a:r>
           </a:p>
           <a:p>
@@ -6124,36 +6274,7 @@
               </a:defRPr>
             </a:pPr>
             <a:r>
-              <a:t>• Instrucciones de Entrega (2 minutos):</a:t>
-            </a:r>
-            <a:br/>
-            <a:r>
-              <a:t>  1. Desbloquea tu teléfono móvil y abre la cámara.</a:t>
-            </a:r>
-            <a:br/>
-            <a:r>
-              <a:t>  2. Escanea el código QR contiguo para acceder al formulario institucional.</a:t>
-            </a:r>
-            <a:br/>
-            <a:r>
-              <a:t>  3. Toma una fotografía nítida, iluminada y vertical de tu cuartilla manuscrita.</a:t>
-            </a:r>
-            <a:br/>
-            <a:r>
-              <a:t>  4. Sube la imagen autenticándote con tu cuenta oficial @alu.upo.es.</a:t>
-            </a:r>
-            <a:br/>
-            <a:br/>
-            <a:r>
-              <a:t>• Gamificación / Beneficios de Evaluación:</a:t>
-            </a:r>
-            <a:br/>
-            <a:r>
-              <a:t>  - La entrega en tiempo y forma acumula puntos en tu Pasaporte Digital.</a:t>
-            </a:r>
-            <a:br/>
-            <a:r>
-              <a:t>  - Las calificaciones y soluciones canónicas estarán disponibles en el portal tras la corrección ciega.</a:t>
+              <a:t>La tasa natural estacionaria u* = s / (s + f) demuestra que el desempleo no es una masa estática. Las políticas públicas deben actuar simultáneamente sobre la estabilidad en el empleo (reducir s) y sobre la eficacia de la intermediación y recolocación (aumentar f).</a:t>
             </a:r>
           </a:p>
         </p:txBody>
@@ -6166,18 +6287,18 @@
         </p:nvSpPr>
         <p:spPr>
           <a:xfrm>
-            <a:off x="7680960" y="1645920"/>
-            <a:ext cx="3931920" cy="4389120"/>
+            <a:off x="548640" y="3154680"/>
+            <a:ext cx="11091672" cy="1325880"/>
           </a:xfrm>
           <a:prstGeom prst="roundRect">
             <a:avLst/>
           </a:prstGeom>
           <a:solidFill>
-            <a:srgbClr val="F4F8F5"/>
+            <a:srgbClr val="FFFFFF"/>
           </a:solidFill>
           <a:ln w="19050">
             <a:solidFill>
-              <a:srgbClr val="E98F71"/>
+              <a:srgbClr val="DCE5DF"/>
             </a:solidFill>
           </a:ln>
         </p:spPr>
@@ -6196,90 +6317,27 @@
           </a:fontRef>
         </p:style>
         <p:txBody>
-          <a:bodyPr wrap="square" lIns="182880" tIns="201168" rIns="182880" rtlCol="0" anchor="ctr"/>
+          <a:bodyPr wrap="square" lIns="228600" tIns="164592" rIns="228600" rtlCol="0" anchor="ctr"/>
           <a:lstStyle/>
           <a:p>
             <a:pPr algn="ctr">
               <a:spcAft>
-                <a:spcPts val="600"/>
-              </a:spcAft>
-              <a:defRPr sz="1100" b="1">
-                <a:solidFill>
-                  <a:srgbClr val="113927"/>
-                </a:solidFill>
-                <a:latin typeface="Outfit"/>
-              </a:defRPr>
-            </a:pPr>
-            <a:r>
-              <a:t>ESCANEA PARA SUBIR TU RETO</a:t>
-            </a:r>
-          </a:p>
-          <a:p>
-            <a:pPr algn="ctr">
-              <a:spcAft>
-                <a:spcPts val="1000"/>
+                <a:spcPts val="400"/>
               </a:spcAft>
               <a:defRPr sz="1500" b="1">
                 <a:solidFill>
-                  <a:srgbClr val="E98F71"/>
+                  <a:srgbClr val="113927"/>
                 </a:solidFill>
                 <a:latin typeface="Outfit"/>
               </a:defRPr>
             </a:pPr>
             <a:r>
-              <a:t>Microsoft Forms · Cuenta UPO</a:t>
-            </a:r>
-          </a:p>
-        </p:txBody>
-      </p:sp>
-      <p:pic>
-        <p:nvPicPr>
-          <p:cNvPr id="10" name="Picture 9" descr="qr_reto_sesion05.png"/>
-          <p:cNvPicPr>
-            <a:picLocks noChangeAspect="1"/>
-          </p:cNvPicPr>
-          <p:nvPr/>
-        </p:nvPicPr>
-        <p:blipFill>
-          <a:blip r:embed="rId3"/>
-          <a:stretch>
-            <a:fillRect/>
-          </a:stretch>
-        </p:blipFill>
-        <p:spPr>
-          <a:xfrm>
-            <a:off x="8412480" y="2560320"/>
-            <a:ext cx="2468880" cy="2468880"/>
-          </a:xfrm>
-          <a:prstGeom prst="rect">
-            <a:avLst/>
-          </a:prstGeom>
-        </p:spPr>
-      </p:pic>
-      <p:sp>
-        <p:nvSpPr>
-          <p:cNvPr id="11" name="TextBox 10"/>
-          <p:cNvSpPr txBox="1"/>
-          <p:nvPr/>
-        </p:nvSpPr>
-        <p:spPr>
-          <a:xfrm>
-            <a:off x="7772400" y="5166360"/>
-            <a:ext cx="3749039" cy="731520"/>
-          </a:xfrm>
-          <a:prstGeom prst="rect">
-            <a:avLst/>
-          </a:prstGeom>
-          <a:noFill/>
-        </p:spPr>
-        <p:txBody>
-          <a:bodyPr wrap="none">
-            <a:spAutoFit/>
-          </a:bodyPr>
-          <a:lstStyle/>
-          <a:p>
-            <a:pPr algn="ctr">
-              <a:defRPr sz="1300">
+              <a:t>2. BEVERIDGE DIFERENCIA EL CICLO DE LA ESTRUCTURA</a:t>
+            </a:r>
+          </a:p>
+          <a:p>
+            <a:pPr>
+              <a:defRPr sz="1600">
                 <a:solidFill>
                   <a:srgbClr val="2F3A30"/>
                 </a:solidFill>
@@ -6287,199 +6345,21 @@
               </a:defRPr>
             </a:pPr>
             <a:r>
-              <a:t>forms.office.com/e/PSLL-Reto-S05</a:t>
-            </a:r>
-            <a:br/>
-            <a:r>
-              <a:t>(Tiempo de subida: 2 min)</a:t>
-            </a:r>
-          </a:p>
-        </p:txBody>
-      </p:sp>
-    </p:spTree>
-  </p:cSld>
-  <p:clrMapOvr>
-    <a:masterClrMapping/>
-  </p:clrMapOvr>
-</p:sld>
-</file>
-
-<file path=ppt/slides/slide17.xml><?xml version="1.0" encoding="utf-8"?>
-<p:sld xmlns:a="http://schemas.openxmlformats.org/drawingml/2006/main" xmlns:p="http://schemas.openxmlformats.org/presentationml/2006/main" xmlns:r="http://schemas.openxmlformats.org/officeDocument/2006/relationships">
-  <p:cSld>
-    <p:spTree>
-      <p:nvGrpSpPr>
-        <p:cNvPr id="1" name=""/>
-        <p:cNvGrpSpPr/>
-        <p:nvPr/>
-      </p:nvGrpSpPr>
-      <p:grpSpPr/>
-      <p:sp>
-        <p:nvSpPr>
-          <p:cNvPr id="2" name="TextBox 1"/>
-          <p:cNvSpPr txBox="1"/>
-          <p:nvPr/>
-        </p:nvSpPr>
-        <p:spPr>
-          <a:xfrm>
-            <a:off x="548640" y="365760"/>
-            <a:ext cx="9144000" cy="274320"/>
-          </a:xfrm>
-          <a:prstGeom prst="rect">
-            <a:avLst/>
-          </a:prstGeom>
-          <a:noFill/>
-        </p:spPr>
-        <p:txBody>
-          <a:bodyPr wrap="none">
-            <a:spAutoFit/>
-          </a:bodyPr>
-          <a:lstStyle/>
-          <a:p>
-            <a:pPr>
-              <a:defRPr sz="1100" b="1">
-                <a:solidFill>
-                  <a:srgbClr val="E98F71"/>
-                </a:solidFill>
-                <a:latin typeface="Outfit"/>
-              </a:defRPr>
-            </a:pPr>
-            <a:r>
-              <a:t>BLOQUE 2 · MODELIZACIÓN Y ESPACIO UV</a:t>
-            </a:r>
-          </a:p>
-        </p:txBody>
-      </p:sp>
-      <p:sp>
-        <p:nvSpPr>
-          <p:cNvPr id="3" name="TextBox 2"/>
-          <p:cNvSpPr txBox="1"/>
-          <p:nvPr/>
-        </p:nvSpPr>
-        <p:spPr>
-          <a:xfrm>
-            <a:off x="548640" y="621792"/>
-            <a:ext cx="9601200" cy="475488"/>
-          </a:xfrm>
-          <a:prstGeom prst="rect">
-            <a:avLst/>
-          </a:prstGeom>
-          <a:noFill/>
-        </p:spPr>
-        <p:txBody>
-          <a:bodyPr wrap="none">
-            <a:spAutoFit/>
-          </a:bodyPr>
-          <a:lstStyle/>
-          <a:p>
-            <a:pPr>
-              <a:defRPr sz="2400" b="1">
-                <a:solidFill>
-                  <a:srgbClr val="113927"/>
-                </a:solidFill>
-                <a:latin typeface="Outfit"/>
-              </a:defRPr>
-            </a:pPr>
-            <a:r>
-              <a:t>De la Pista de Baile a la Curva de Beveridge</a:t>
-            </a:r>
-          </a:p>
-        </p:txBody>
-      </p:sp>
-      <p:sp>
-        <p:nvSpPr>
-          <p:cNvPr id="4" name="TextBox 3"/>
-          <p:cNvSpPr txBox="1"/>
-          <p:nvPr/>
-        </p:nvSpPr>
-        <p:spPr>
-          <a:xfrm>
-            <a:off x="548640" y="1097280"/>
-            <a:ext cx="9601200" cy="347472"/>
-          </a:xfrm>
-          <a:prstGeom prst="rect">
-            <a:avLst/>
-          </a:prstGeom>
-          <a:noFill/>
-        </p:spPr>
-        <p:txBody>
-          <a:bodyPr wrap="none">
-            <a:spAutoFit/>
-          </a:bodyPr>
-          <a:lstStyle/>
-          <a:p>
-            <a:pPr>
-              <a:defRPr sz="1400">
-                <a:solidFill>
-                  <a:srgbClr val="76927A"/>
-                </a:solidFill>
-                <a:latin typeface="Calibri"/>
-              </a:defRPr>
-            </a:pPr>
-            <a:r>
-              <a:t>Epígrafe 6.1–6.2 oficial: cómo las micro-interacciones de la pista trazan la curva macroeconómica</a:t>
-            </a:r>
-          </a:p>
-        </p:txBody>
-      </p:sp>
-      <p:pic>
-        <p:nvPicPr>
-          <p:cNvPr id="5" name="Picture 4" descr="image.png"/>
-          <p:cNvPicPr>
-            <a:picLocks noChangeAspect="1"/>
-          </p:cNvPicPr>
-          <p:nvPr/>
-        </p:nvPicPr>
-        <p:blipFill>
-          <a:blip r:embed="rId2"/>
-          <a:stretch>
-            <a:fillRect/>
-          </a:stretch>
-        </p:blipFill>
-        <p:spPr>
-          <a:xfrm>
-            <a:off x="10515600" y="365760"/>
-            <a:ext cx="1161288" cy="365760"/>
-          </a:xfrm>
-          <a:prstGeom prst="rect">
-            <a:avLst/>
-          </a:prstGeom>
-        </p:spPr>
-      </p:pic>
-      <p:pic>
-        <p:nvPicPr>
-          <p:cNvPr id="6" name="Picture 5" descr="curva_beveridge_pista_baile.png"/>
-          <p:cNvPicPr>
-            <a:picLocks noChangeAspect="1"/>
-          </p:cNvPicPr>
-          <p:nvPr/>
-        </p:nvPicPr>
-        <p:blipFill>
-          <a:blip r:embed="rId3"/>
-          <a:stretch>
-            <a:fillRect/>
-          </a:stretch>
-        </p:blipFill>
-        <p:spPr>
-          <a:xfrm>
-            <a:off x="548640" y="1536192"/>
-            <a:ext cx="7772400" cy="3611880"/>
-          </a:xfrm>
-          <a:prstGeom prst="rect">
-            <a:avLst/>
-          </a:prstGeom>
-        </p:spPr>
-      </p:pic>
-      <p:sp>
-        <p:nvSpPr>
-          <p:cNvPr id="7" name="Rounded Rectangle 6"/>
+              <a:t>Un shock de demanda mueve la economía a lo largo de la curva de Beveridge (recesión keynesiana). Un desajuste de habilidades o ineficiencia institucional desplaza la curva entera hacia afuera. El gasto de demanda generalizado ante desajustes solo produce inflación.</a:t>
+            </a:r>
+          </a:p>
+        </p:txBody>
+      </p:sp>
+      <p:sp>
+        <p:nvSpPr>
+          <p:cNvPr id="10" name="Rounded Rectangle 9"/>
           <p:cNvSpPr/>
           <p:nvPr/>
         </p:nvSpPr>
         <p:spPr>
           <a:xfrm>
-            <a:off x="548640" y="5230368"/>
-            <a:ext cx="7772400" cy="1005840"/>
+            <a:off x="548640" y="4663440"/>
+            <a:ext cx="11091672" cy="1325880"/>
           </a:xfrm>
           <a:prstGeom prst="roundRect">
             <a:avLst/>
@@ -6487,9 +6367,9 @@
           <a:solidFill>
             <a:srgbClr val="F4F8F5"/>
           </a:solidFill>
-          <a:ln w="12700">
+          <a:ln w="19050">
             <a:solidFill>
-              <a:srgbClr val="DCE5DF"/>
+              <a:srgbClr val="E98F71"/>
             </a:solidFill>
           </a:ln>
         </p:spPr>
@@ -6508,11 +6388,14 @@
           </a:fontRef>
         </p:style>
         <p:txBody>
-          <a:bodyPr rtlCol="0" anchor="ctr" wrap="square" lIns="164592" rIns="164592" tIns="109728" bIns="91440"/>
+          <a:bodyPr wrap="square" lIns="228600" tIns="164592" rIns="228600" rtlCol="0" anchor="ctr"/>
           <a:lstStyle/>
           <a:p>
             <a:pPr algn="ctr">
-              <a:defRPr sz="1300" b="1">
+              <a:spcAft>
+                <a:spcPts val="400"/>
+              </a:spcAft>
+              <a:defRPr sz="1500" b="1">
                 <a:solidFill>
                   <a:srgbClr val="113927"/>
                 </a:solidFill>
@@ -6520,12 +6403,12 @@
               </a:defRPr>
             </a:pPr>
             <a:r>
-              <a:t>Mecanismo Causal de Agregación (De la Micro a la Macro):</a:t>
+              <a:t>3. PRÓXIMA PARADA: CASO 1 EN EPD Y TEMA 2 (POLÍTICAS ACTIVAS)</a:t>
             </a:r>
           </a:p>
           <a:p>
             <a:pPr>
-              <a:defRPr sz="1500">
+              <a:defRPr sz="1600">
                 <a:solidFill>
                   <a:srgbClr val="2F3A30"/>
                 </a:solidFill>
@@ -6533,21 +6416,236 @@
               </a:defRPr>
             </a:pPr>
             <a:r>
-              <a:t>• En </a:t>
-            </a:r>
-            <a:r>
-              <a:rPr b="1"/>
-              <a:t>Recesión</a:t>
-            </a:r>
-            <a:r>
-              <a:t>, las empresas retiran vacantes y los parados quedan solos en la sala (movimiento a lo largo, u ↑, v ↓). Con </a:t>
-            </a:r>
-            <a:r>
-              <a:rPr b="1"/>
-              <a:t>desajuste formativo (A ↓)</a:t>
-            </a:r>
-            <a:r>
-              <a:t>, la pista se llena de puntos que chocan y rebotan sin emparejarse (desplazamiento hacia fuera).</a:t>
+              <a:t>Concluimos formalmente el Tema 1. En la Semana 5 arrancan las prácticas EPD en el aula de informática, donde vuestro equipo auditará los microdatos reales del Programa Emplea-T aplicando todo el instrumental analítico aprendido.</a:t>
+            </a:r>
+          </a:p>
+        </p:txBody>
+      </p:sp>
+    </p:spTree>
+  </p:cSld>
+  <p:clrMapOvr>
+    <a:masterClrMapping/>
+  </p:clrMapOvr>
+</p:sld>
+</file>
+
+<file path=ppt/slides/slide17.xml><?xml version="1.0" encoding="utf-8"?>
+<p:sld xmlns:a="http://schemas.openxmlformats.org/drawingml/2006/main" xmlns:r="http://schemas.openxmlformats.org/officeDocument/2006/relationships" xmlns:p="http://schemas.openxmlformats.org/presentationml/2006/main">
+  <p:cSld>
+    <p:spTree>
+      <p:nvGrpSpPr>
+        <p:cNvPr id="1" name=""/>
+        <p:cNvGrpSpPr/>
+        <p:nvPr/>
+      </p:nvGrpSpPr>
+      <p:grpSpPr>
+        <a:xfrm>
+          <a:off x="0" y="0"/>
+          <a:ext cx="0" cy="0"/>
+          <a:chOff x="0" y="0"/>
+          <a:chExt cx="0" cy="0"/>
+        </a:xfrm>
+      </p:grpSpPr>
+      <p:sp>
+        <p:nvSpPr>
+          <p:cNvPr id="2" name="TextBox 1"/>
+          <p:cNvSpPr txBox="1"/>
+          <p:nvPr/>
+        </p:nvSpPr>
+        <p:spPr>
+          <a:xfrm>
+            <a:off x="548640" y="365760"/>
+            <a:ext cx="9144000" cy="274320"/>
+          </a:xfrm>
+          <a:prstGeom prst="rect">
+            <a:avLst/>
+          </a:prstGeom>
+          <a:noFill/>
+        </p:spPr>
+        <p:txBody>
+          <a:bodyPr wrap="square" lIns="0" tIns="0" rIns="0" bIns="0">
+            <a:spAutoFit/>
+          </a:bodyPr>
+          <a:lstStyle/>
+          <a:p>
+            <a:pPr>
+              <a:defRPr sz="1100" b="1">
+                <a:solidFill>
+                  <a:srgbClr val="E98F71"/>
+                </a:solidFill>
+                <a:latin typeface="Outfit"/>
+              </a:defRPr>
+            </a:pPr>
+            <a:r>
+              <a:t>BLOQUE 5 · RETO INDIVIDUAL DE CIERRE (10 MIN)</a:t>
+            </a:r>
+          </a:p>
+        </p:txBody>
+      </p:sp>
+      <p:sp>
+        <p:nvSpPr>
+          <p:cNvPr id="3" name="TextBox 2"/>
+          <p:cNvSpPr txBox="1"/>
+          <p:nvPr/>
+        </p:nvSpPr>
+        <p:spPr>
+          <a:xfrm>
+            <a:off x="548640" y="621792"/>
+            <a:ext cx="9601200" cy="475488"/>
+          </a:xfrm>
+          <a:prstGeom prst="rect">
+            <a:avLst/>
+          </a:prstGeom>
+          <a:noFill/>
+        </p:spPr>
+        <p:txBody>
+          <a:bodyPr wrap="square" lIns="0" tIns="0" rIns="0" bIns="0">
+            <a:spAutoFit/>
+          </a:bodyPr>
+          <a:lstStyle/>
+          <a:p>
+            <a:pPr>
+              <a:defRPr sz="2400" b="1">
+                <a:solidFill>
+                  <a:srgbClr val="113927"/>
+                </a:solidFill>
+                <a:latin typeface="Outfit"/>
+              </a:defRPr>
+            </a:pPr>
+            <a:r>
+              <a:t>Reto Manuscrito Anti-IA en Papel: Beveridge y Flujos</a:t>
+            </a:r>
+          </a:p>
+        </p:txBody>
+      </p:sp>
+      <p:sp>
+        <p:nvSpPr>
+          <p:cNvPr id="4" name="TextBox 3"/>
+          <p:cNvSpPr txBox="1"/>
+          <p:nvPr/>
+        </p:nvSpPr>
+        <p:spPr>
+          <a:xfrm>
+            <a:off x="548640" y="1097280"/>
+            <a:ext cx="9601200" cy="347472"/>
+          </a:xfrm>
+          <a:prstGeom prst="rect">
+            <a:avLst/>
+          </a:prstGeom>
+          <a:noFill/>
+        </p:spPr>
+        <p:txBody>
+          <a:bodyPr wrap="square" lIns="0" tIns="0" rIns="0" bIns="0">
+            <a:spAutoFit/>
+          </a:bodyPr>
+          <a:lstStyle/>
+          <a:p>
+            <a:pPr>
+              <a:defRPr sz="1400">
+                <a:solidFill>
+                  <a:srgbClr val="76927A"/>
+                </a:solidFill>
+                <a:latin typeface="Calibri"/>
+              </a:defRPr>
+            </a:pPr>
+            <a:r>
+              <a:t>Redacción individual de puño y letra en cuartilla de papel en entorno libre de pantallas</a:t>
+            </a:r>
+          </a:p>
+        </p:txBody>
+      </p:sp>
+      <p:pic>
+        <p:nvPicPr>
+          <p:cNvPr id="5" name="Picture 4" descr="psll_lockup.png"/>
+          <p:cNvPicPr>
+            <a:picLocks noChangeAspect="1"/>
+          </p:cNvPicPr>
+          <p:nvPr/>
+        </p:nvPicPr>
+        <p:blipFill>
+          <a:blip r:embed="rId2"/>
+          <a:stretch>
+            <a:fillRect/>
+          </a:stretch>
+        </p:blipFill>
+        <p:spPr>
+          <a:xfrm>
+            <a:off x="10515600" y="365760"/>
+            <a:ext cx="1158544" cy="365760"/>
+          </a:xfrm>
+          <a:prstGeom prst="rect">
+            <a:avLst/>
+          </a:prstGeom>
+        </p:spPr>
+      </p:pic>
+      <p:sp>
+        <p:nvSpPr>
+          <p:cNvPr id="6" name="TextBox 5"/>
+          <p:cNvSpPr txBox="1"/>
+          <p:nvPr/>
+        </p:nvSpPr>
+        <p:spPr>
+          <a:xfrm>
+            <a:off x="548640" y="6400800"/>
+            <a:ext cx="9144000" cy="274320"/>
+          </a:xfrm>
+          <a:prstGeom prst="rect">
+            <a:avLst/>
+          </a:prstGeom>
+          <a:noFill/>
+        </p:spPr>
+        <p:txBody>
+          <a:bodyPr wrap="none" lIns="0" tIns="0" rIns="0" bIns="0">
+            <a:spAutoFit/>
+          </a:bodyPr>
+          <a:lstStyle/>
+          <a:p>
+            <a:pPr>
+              <a:defRPr sz="1000">
+                <a:solidFill>
+                  <a:srgbClr val="76927A"/>
+                </a:solidFill>
+                <a:latin typeface="Calibri"/>
+              </a:defRPr>
+            </a:pPr>
+            <a:r>
+              <a:t>Políticas Sociolaborales y de Empleo · Grado en RRLL y RRHH / Doble Grado DER-RRLL · UPO</a:t>
+            </a:r>
+          </a:p>
+        </p:txBody>
+      </p:sp>
+      <p:sp>
+        <p:nvSpPr>
+          <p:cNvPr id="7" name="TextBox 6"/>
+          <p:cNvSpPr txBox="1"/>
+          <p:nvPr/>
+        </p:nvSpPr>
+        <p:spPr>
+          <a:xfrm>
+            <a:off x="10515600" y="6400800"/>
+            <a:ext cx="1097280" cy="274320"/>
+          </a:xfrm>
+          <a:prstGeom prst="rect">
+            <a:avLst/>
+          </a:prstGeom>
+          <a:noFill/>
+        </p:spPr>
+        <p:txBody>
+          <a:bodyPr wrap="none" lIns="0" tIns="0" rIns="0" bIns="0">
+            <a:spAutoFit/>
+          </a:bodyPr>
+          <a:lstStyle/>
+          <a:p>
+            <a:pPr algn="r">
+              <a:defRPr sz="1000">
+                <a:solidFill>
+                  <a:srgbClr val="76927A"/>
+                </a:solidFill>
+                <a:latin typeface="Calibri"/>
+              </a:defRPr>
+            </a:pPr>
+            <a:r>
+              <a:t>16 / 17</a:t>
             </a:r>
           </a:p>
         </p:txBody>
@@ -6560,8 +6658,8 @@
         </p:nvSpPr>
         <p:spPr>
           <a:xfrm>
-            <a:off x="8503920" y="1536192"/>
-            <a:ext cx="3154680" cy="4700016"/>
+            <a:off x="548640" y="1645920"/>
+            <a:ext cx="5394960" cy="4389120"/>
           </a:xfrm>
           <a:prstGeom prst="roundRect">
             <a:avLst/>
@@ -6571,7 +6669,7 @@
           </a:solidFill>
           <a:ln w="19050">
             <a:solidFill>
-              <a:srgbClr val="113927"/>
+              <a:srgbClr val="DCE5DF"/>
             </a:solidFill>
           </a:ln>
         </p:spPr>
@@ -6590,11 +6688,14 @@
           </a:fontRef>
         </p:style>
         <p:txBody>
-          <a:bodyPr rtlCol="0" anchor="ctr" wrap="square" lIns="146304" rIns="146304" tIns="128016" bIns="91440"/>
+          <a:bodyPr wrap="square" lIns="228600" tIns="201168" rIns="228600" rtlCol="0" anchor="ctr"/>
           <a:lstStyle/>
           <a:p>
             <a:pPr algn="ctr">
-              <a:defRPr sz="1400" b="1">
+              <a:spcAft>
+                <a:spcPts val="1000"/>
+              </a:spcAft>
+              <a:defRPr sz="1500" b="1">
                 <a:solidFill>
                   <a:srgbClr val="113927"/>
                 </a:solidFill>
@@ -6602,12 +6703,241 @@
               </a:defRPr>
             </a:pPr>
             <a:r>
-              <a:t>LABORATORIO EN VIVO</a:t>
-            </a:r>
-          </a:p>
+              <a:t>PREGUNTA 1 · CONCEPTUAL (500 PTS)</a:t>
+            </a:r>
+          </a:p>
+          <a:p>
+            <a:pPr>
+              <a:defRPr sz="1600">
+                <a:solidFill>
+                  <a:srgbClr val="2F3A30"/>
+                </a:solidFill>
+                <a:latin typeface="Calibri"/>
+              </a:defRPr>
+            </a:pPr>
+            <a:r>
+              <a:t>A partir de la condición de flujo estacionario y la función de emparejamiento m = A·U^α·V^(1-α):</a:t>
+            </a:r>
+            <a:br/>
+            <a:br/>
+            <a:r>
+              <a:t>a) Demuestre analíticamente por qué la tasa natural de desempleo de equilibrio a largo plazo es u* = s / (s + f) y defina con precisión las variables s y f.</a:t>
+            </a:r>
+            <a:br/>
+            <a:br/>
+            <a:r>
+              <a:t>b) Utilizando el marco de la Curva de Beveridge, distinga conceptualmente entre un movimiento a lo largo de la curva y un desplazamiento hacia el exterior, indicando qué variables provocan cada uno.</a:t>
+            </a:r>
+          </a:p>
+        </p:txBody>
+      </p:sp>
+      <p:sp>
+        <p:nvSpPr>
+          <p:cNvPr id="9" name="Rounded Rectangle 8"/>
+          <p:cNvSpPr/>
+          <p:nvPr/>
+        </p:nvSpPr>
+        <p:spPr>
+          <a:xfrm>
+            <a:off x="6217920" y="1645920"/>
+            <a:ext cx="5394960" cy="4389120"/>
+          </a:xfrm>
+          <a:prstGeom prst="roundRect">
+            <a:avLst/>
+          </a:prstGeom>
+          <a:solidFill>
+            <a:srgbClr val="FFFFFF"/>
+          </a:solidFill>
+          <a:ln w="19050">
+            <a:solidFill>
+              <a:srgbClr val="E98F71"/>
+            </a:solidFill>
+          </a:ln>
+        </p:spPr>
+        <p:style>
+          <a:lnRef idx="1">
+            <a:schemeClr val="accent1"/>
+          </a:lnRef>
+          <a:fillRef idx="3">
+            <a:schemeClr val="accent1"/>
+          </a:fillRef>
+          <a:effectRef idx="2">
+            <a:schemeClr val="accent1"/>
+          </a:effectRef>
+          <a:fontRef idx="minor">
+            <a:schemeClr val="lt1"/>
+          </a:fontRef>
+        </p:style>
+        <p:txBody>
+          <a:bodyPr wrap="square" lIns="228600" tIns="201168" rIns="228600" rtlCol="0" anchor="ctr"/>
+          <a:lstStyle/>
           <a:p>
             <a:pPr algn="ctr">
-              <a:defRPr sz="1200" b="1">
+              <a:spcAft>
+                <a:spcPts val="1000"/>
+              </a:spcAft>
+              <a:defRPr sz="1500" b="1">
+                <a:solidFill>
+                  <a:srgbClr val="113927"/>
+                </a:solidFill>
+                <a:latin typeface="Outfit"/>
+              </a:defRPr>
+            </a:pPr>
+            <a:r>
+              <a:t>PREGUNTA 2 · APLICADA (500 PTS)</a:t>
+            </a:r>
+          </a:p>
+          <a:p>
+            <a:pPr>
+              <a:defRPr sz="1600">
+                <a:solidFill>
+                  <a:srgbClr val="2F3A30"/>
+                </a:solidFill>
+                <a:latin typeface="Calibri"/>
+              </a:defRPr>
+            </a:pPr>
+            <a:r>
+              <a:t>En España coexisten 155.000 vacantes sin cubrir (v ≈ 0,75%) y una tasa de paro del 11,3%:</a:t>
+            </a:r>
+            <a:br/>
+            <a:br/>
+            <a:r>
+              <a:t>a) Represente gráficamente la situación en el plano (U,V), sitúe la posición respecto a la bisectriz y determine si el problema es cíclico o estructural.</a:t>
+            </a:r>
+            <a:br/>
+            <a:br/>
+            <a:r>
+              <a:t>b) Si el gobierno inyecta 10.000 M€ en estímulos fiscales de consumo creyendo que el paro es puramente cíclico: ¿qué ocurrirá con vacantes, paro e inflación?</a:t>
+            </a:r>
+            <a:br/>
+            <a:br/>
+            <a:r>
+              <a:t>c) En el Programa Emplea-T, proponga medidas que eleven A y explique cómo evitar el peso muerto (deadweight).</a:t>
+            </a:r>
+          </a:p>
+        </p:txBody>
+      </p:sp>
+    </p:spTree>
+  </p:cSld>
+  <p:clrMapOvr>
+    <a:masterClrMapping/>
+  </p:clrMapOvr>
+</p:sld>
+</file>
+
+<file path=ppt/slides/slide18.xml><?xml version="1.0" encoding="utf-8"?>
+<p:sld xmlns:a="http://schemas.openxmlformats.org/drawingml/2006/main" xmlns:r="http://schemas.openxmlformats.org/officeDocument/2006/relationships" xmlns:p="http://schemas.openxmlformats.org/presentationml/2006/main">
+  <p:cSld>
+    <p:spTree>
+      <p:nvGrpSpPr>
+        <p:cNvPr id="1" name=""/>
+        <p:cNvGrpSpPr/>
+        <p:nvPr/>
+      </p:nvGrpSpPr>
+      <p:grpSpPr>
+        <a:xfrm>
+          <a:off x="0" y="0"/>
+          <a:ext cx="0" cy="0"/>
+          <a:chOff x="0" y="0"/>
+          <a:chExt cx="0" cy="0"/>
+        </a:xfrm>
+      </p:grpSpPr>
+      <p:sp>
+        <p:nvSpPr>
+          <p:cNvPr id="2" name="TextBox 1"/>
+          <p:cNvSpPr txBox="1"/>
+          <p:nvPr/>
+        </p:nvSpPr>
+        <p:spPr>
+          <a:xfrm>
+            <a:off x="548640" y="365760"/>
+            <a:ext cx="9144000" cy="274320"/>
+          </a:xfrm>
+          <a:prstGeom prst="rect">
+            <a:avLst/>
+          </a:prstGeom>
+          <a:noFill/>
+        </p:spPr>
+        <p:txBody>
+          <a:bodyPr wrap="square" lIns="0" tIns="0" rIns="0" bIns="0">
+            <a:spAutoFit/>
+          </a:bodyPr>
+          <a:lstStyle/>
+          <a:p>
+            <a:pPr>
+              <a:defRPr sz="1100" b="1">
+                <a:solidFill>
+                  <a:srgbClr val="E98F71"/>
+                </a:solidFill>
+                <a:latin typeface="Outfit"/>
+              </a:defRPr>
+            </a:pPr>
+            <a:r>
+              <a:t>BLOQUE 5 · SUBIDA FOTOGRÁFICA Y RÚBRICA (5 MIN)</a:t>
+            </a:r>
+          </a:p>
+        </p:txBody>
+      </p:sp>
+      <p:sp>
+        <p:nvSpPr>
+          <p:cNvPr id="3" name="TextBox 2"/>
+          <p:cNvSpPr txBox="1"/>
+          <p:nvPr/>
+        </p:nvSpPr>
+        <p:spPr>
+          <a:xfrm>
+            <a:off x="548640" y="621792"/>
+            <a:ext cx="9601200" cy="475488"/>
+          </a:xfrm>
+          <a:prstGeom prst="rect">
+            <a:avLst/>
+          </a:prstGeom>
+          <a:noFill/>
+        </p:spPr>
+        <p:txBody>
+          <a:bodyPr wrap="square" lIns="0" tIns="0" rIns="0" bIns="0">
+            <a:spAutoFit/>
+          </a:bodyPr>
+          <a:lstStyle/>
+          <a:p>
+            <a:pPr>
+              <a:defRPr sz="2400" b="1">
+                <a:solidFill>
+                  <a:srgbClr val="113927"/>
+                </a:solidFill>
+                <a:latin typeface="Outfit"/>
+              </a:defRPr>
+            </a:pPr>
+            <a:r>
+              <a:t>Envío Digital Autenticado del Reto Manuscrito</a:t>
+            </a:r>
+          </a:p>
+        </p:txBody>
+      </p:sp>
+      <p:sp>
+        <p:nvSpPr>
+          <p:cNvPr id="4" name="TextBox 3"/>
+          <p:cNvSpPr txBox="1"/>
+          <p:nvPr/>
+        </p:nvSpPr>
+        <p:spPr>
+          <a:xfrm>
+            <a:off x="548640" y="1097280"/>
+            <a:ext cx="9601200" cy="347472"/>
+          </a:xfrm>
+          <a:prstGeom prst="rect">
+            <a:avLst/>
+          </a:prstGeom>
+          <a:noFill/>
+        </p:spPr>
+        <p:txBody>
+          <a:bodyPr wrap="square" lIns="0" tIns="0" rIns="0" bIns="0">
+            <a:spAutoFit/>
+          </a:bodyPr>
+          <a:lstStyle/>
+          <a:p>
+            <a:pPr>
+              <a:defRPr sz="1400">
                 <a:solidFill>
                   <a:srgbClr val="76927A"/>
                 </a:solidFill>
@@ -6615,29 +6945,29 @@
               </a:defRPr>
             </a:pPr>
             <a:r>
-              <a:t>Micro-App: Pista de Baile ABM</a:t>
+              <a:t>Fotografía y subida instantánea mediante código QR institucional UPO en Microsoft Forms</a:t>
             </a:r>
           </a:p>
         </p:txBody>
       </p:sp>
       <p:pic>
         <p:nvPicPr>
-          <p:cNvPr id="9" name="Picture 8" descr="image.png"/>
+          <p:cNvPr id="5" name="Picture 4" descr="psll_lockup.png"/>
           <p:cNvPicPr>
             <a:picLocks noChangeAspect="1"/>
           </p:cNvPicPr>
           <p:nvPr/>
         </p:nvPicPr>
         <p:blipFill>
-          <a:blip r:embed="rId4"/>
+          <a:blip r:embed="rId2"/>
           <a:stretch>
             <a:fillRect/>
           </a:stretch>
         </p:blipFill>
         <p:spPr>
           <a:xfrm>
-            <a:off x="9253728" y="2194560"/>
-            <a:ext cx="1645920" cy="1645920"/>
+            <a:off x="10515600" y="365760"/>
+            <a:ext cx="1158544" cy="365760"/>
           </a:xfrm>
           <a:prstGeom prst="rect">
             <a:avLst/>
@@ -6646,14 +6976,14 @@
       </p:pic>
       <p:sp>
         <p:nvSpPr>
-          <p:cNvPr id="10" name="TextBox 9"/>
+          <p:cNvPr id="6" name="TextBox 5"/>
           <p:cNvSpPr txBox="1"/>
           <p:nvPr/>
         </p:nvSpPr>
         <p:spPr>
           <a:xfrm>
-            <a:off x="8595360" y="3931920"/>
-            <a:ext cx="2971800" cy="2194560"/>
+            <a:off x="548640" y="6400800"/>
+            <a:ext cx="9144000" cy="274320"/>
           </a:xfrm>
           <a:prstGeom prst="rect">
             <a:avLst/>
@@ -6661,158 +6991,259 @@
           <a:noFill/>
         </p:spPr>
         <p:txBody>
-          <a:bodyPr wrap="square" lIns="0" rIns="0" tIns="0" bIns="0">
+          <a:bodyPr wrap="none" lIns="0" tIns="0" rIns="0" bIns="0">
             <a:spAutoFit/>
           </a:bodyPr>
           <a:lstStyle/>
           <a:p>
             <a:pPr>
+              <a:defRPr sz="1000">
+                <a:solidFill>
+                  <a:srgbClr val="76927A"/>
+                </a:solidFill>
+                <a:latin typeface="Calibri"/>
+              </a:defRPr>
+            </a:pPr>
+            <a:r>
+              <a:t>Políticas Sociolaborales y de Empleo · Grado en RRLL y RRHH / Doble Grado DER-RRLL · UPO</a:t>
+            </a:r>
+          </a:p>
+        </p:txBody>
+      </p:sp>
+      <p:sp>
+        <p:nvSpPr>
+          <p:cNvPr id="7" name="TextBox 6"/>
+          <p:cNvSpPr txBox="1"/>
+          <p:nvPr/>
+        </p:nvSpPr>
+        <p:spPr>
+          <a:xfrm>
+            <a:off x="10515600" y="6400800"/>
+            <a:ext cx="1097280" cy="274320"/>
+          </a:xfrm>
+          <a:prstGeom prst="rect">
+            <a:avLst/>
+          </a:prstGeom>
+          <a:noFill/>
+        </p:spPr>
+        <p:txBody>
+          <a:bodyPr wrap="none" lIns="0" tIns="0" rIns="0" bIns="0">
+            <a:spAutoFit/>
+          </a:bodyPr>
+          <a:lstStyle/>
+          <a:p>
+            <a:pPr algn="r">
+              <a:defRPr sz="1000">
+                <a:solidFill>
+                  <a:srgbClr val="76927A"/>
+                </a:solidFill>
+                <a:latin typeface="Calibri"/>
+              </a:defRPr>
+            </a:pPr>
+            <a:r>
+              <a:t>17 / 17</a:t>
+            </a:r>
+          </a:p>
+        </p:txBody>
+      </p:sp>
+      <p:sp>
+        <p:nvSpPr>
+          <p:cNvPr id="8" name="Rounded Rectangle 7"/>
+          <p:cNvSpPr/>
+          <p:nvPr/>
+        </p:nvSpPr>
+        <p:spPr>
+          <a:xfrm>
+            <a:off x="548640" y="1645920"/>
+            <a:ext cx="6858000" cy="4389120"/>
+          </a:xfrm>
+          <a:prstGeom prst="roundRect">
+            <a:avLst/>
+          </a:prstGeom>
+          <a:solidFill>
+            <a:srgbClr val="FFFFFF"/>
+          </a:solidFill>
+          <a:ln w="19050">
+            <a:solidFill>
+              <a:srgbClr val="76927A"/>
+            </a:solidFill>
+          </a:ln>
+        </p:spPr>
+        <p:style>
+          <a:lnRef idx="1">
+            <a:schemeClr val="accent1"/>
+          </a:lnRef>
+          <a:fillRef idx="3">
+            <a:schemeClr val="accent1"/>
+          </a:fillRef>
+          <a:effectRef idx="2">
+            <a:schemeClr val="accent1"/>
+          </a:effectRef>
+          <a:fontRef idx="minor">
+            <a:schemeClr val="lt1"/>
+          </a:fontRef>
+        </p:style>
+        <p:txBody>
+          <a:bodyPr wrap="square" lIns="256032" tIns="201168" rIns="256032" rtlCol="0" anchor="ctr"/>
+          <a:lstStyle/>
+          <a:p>
+            <a:pPr algn="ctr">
               <a:spcAft>
-                <a:spcPts val="200"/>
+                <a:spcPts val="800"/>
               </a:spcAft>
-              <a:defRPr sz="1100">
+              <a:defRPr sz="1200" b="1">
+                <a:solidFill>
+                  <a:srgbClr val="E98F71"/>
+                </a:solidFill>
+                <a:latin typeface="Outfit"/>
+              </a:defRPr>
+            </a:pPr>
+            <a:r>
+              <a:t>PASAPORTE DE EVALUACIÓN CONTINUA · PSLL</a:t>
+            </a:r>
+          </a:p>
+          <a:p>
+            <a:pPr>
+              <a:defRPr sz="1600">
+                <a:solidFill>
+                  <a:srgbClr val="2F3A30"/>
+                </a:solidFill>
                 <a:latin typeface="Calibri"/>
               </a:defRPr>
             </a:pPr>
             <a:r>
-              <a:rPr b="1">
+              <a:t>• Instrucciones de Entrega (2 minutos):</a:t>
+            </a:r>
+            <a:br/>
+            <a:r>
+              <a:t>  1. Desbloquea tu teléfono móvil y abre la cámara.</a:t>
+            </a:r>
+            <a:br/>
+            <a:r>
+              <a:t>  2. Escanea el código QR contiguo para acceder al formulario institucional.</a:t>
+            </a:r>
+            <a:br/>
+            <a:r>
+              <a:t>  3. Toma una fotografía nítida, iluminada y vertical de tu cuartilla manuscrita.</a:t>
+            </a:r>
+            <a:br/>
+            <a:r>
+              <a:t>  4. Sube la imagen autenticándote con tu cuenta oficial @alu.upo.es.</a:t>
+            </a:r>
+            <a:br/>
+            <a:br/>
+            <a:r>
+              <a:t>• Gamificación / Beneficios de Evaluación:</a:t>
+            </a:r>
+            <a:br/>
+            <a:r>
+              <a:t>  - La entrega en tiempo y forma acumula puntos en tu Pasaporte Digital.</a:t>
+            </a:r>
+            <a:br/>
+            <a:r>
+              <a:t>  - Las calificaciones y soluciones canónicas estarán disponibles en el portal tras la corrección ciega.</a:t>
+            </a:r>
+          </a:p>
+        </p:txBody>
+      </p:sp>
+      <p:sp>
+        <p:nvSpPr>
+          <p:cNvPr id="9" name="Rounded Rectangle 8"/>
+          <p:cNvSpPr/>
+          <p:nvPr/>
+        </p:nvSpPr>
+        <p:spPr>
+          <a:xfrm>
+            <a:off x="7680960" y="1645920"/>
+            <a:ext cx="3931920" cy="4389120"/>
+          </a:xfrm>
+          <a:prstGeom prst="roundRect">
+            <a:avLst/>
+          </a:prstGeom>
+          <a:solidFill>
+            <a:srgbClr val="F4F8F5"/>
+          </a:solidFill>
+          <a:ln w="19050">
+            <a:solidFill>
+              <a:srgbClr val="E98F71"/>
+            </a:solidFill>
+          </a:ln>
+        </p:spPr>
+        <p:style>
+          <a:lnRef idx="1">
+            <a:schemeClr val="accent1"/>
+          </a:lnRef>
+          <a:fillRef idx="3">
+            <a:schemeClr val="accent1"/>
+          </a:fillRef>
+          <a:effectRef idx="2">
+            <a:schemeClr val="accent1"/>
+          </a:effectRef>
+          <a:fontRef idx="minor">
+            <a:schemeClr val="lt1"/>
+          </a:fontRef>
+        </p:style>
+        <p:txBody>
+          <a:bodyPr wrap="square" lIns="182880" tIns="201168" rIns="182880" rtlCol="0" anchor="ctr"/>
+          <a:lstStyle/>
+          <a:p>
+            <a:pPr algn="ctr">
+              <a:spcAft>
+                <a:spcPts val="600"/>
+              </a:spcAft>
+              <a:defRPr sz="1100" b="1">
                 <a:solidFill>
                   <a:srgbClr val="113927"/>
                 </a:solidFill>
-              </a:rPr>
-              <a:t>🔴 Puntos Rojos: </a:t>
-            </a:r>
-            <a:r>
-              <a:rPr>
-                <a:solidFill>
-                  <a:srgbClr val="2F3A30"/>
-                </a:solidFill>
-              </a:rPr>
-              <a:t>Trabajadores desempleados (U).</a:t>
-            </a:r>
-          </a:p>
-          <a:p>
-            <a:pPr>
+                <a:latin typeface="Outfit"/>
+              </a:defRPr>
+            </a:pPr>
+            <a:r>
+              <a:t>ESCANEA PARA SUBIR TU RETO</a:t>
+            </a:r>
+          </a:p>
+          <a:p>
+            <a:pPr algn="ctr">
               <a:spcAft>
-                <a:spcPts val="200"/>
+                <a:spcPts val="1000"/>
               </a:spcAft>
-              <a:defRPr sz="1100">
-                <a:latin typeface="Calibri"/>
-              </a:defRPr>
-            </a:pPr>
-            <a:r>
-              <a:rPr b="1">
-                <a:solidFill>
-                  <a:srgbClr val="113927"/>
-                </a:solidFill>
-              </a:rPr>
-              <a:t>🔵 Puntos Azules: </a:t>
-            </a:r>
-            <a:r>
-              <a:rPr>
-                <a:solidFill>
-                  <a:srgbClr val="2F3A30"/>
-                </a:solidFill>
-              </a:rPr>
-              <a:t>Empresas con vacantes (V).</a:t>
-            </a:r>
-          </a:p>
-          <a:p>
-            <a:pPr>
-              <a:spcAft>
-                <a:spcPts val="200"/>
-              </a:spcAft>
-              <a:defRPr sz="1100">
-                <a:latin typeface="Calibri"/>
-              </a:defRPr>
-            </a:pPr>
-            <a:r>
-              <a:rPr b="1">
-                <a:solidFill>
-                  <a:srgbClr val="113927"/>
-                </a:solidFill>
-              </a:rPr>
-              <a:t>🟢 Pareja Enlazada: </a:t>
-            </a:r>
-            <a:r>
-              <a:rPr>
-                <a:solidFill>
-                  <a:srgbClr val="2F3A30"/>
-                </a:solidFill>
-              </a:rPr>
-              <a:t>Contratación exitosa (M).</a:t>
-            </a:r>
-          </a:p>
-          <a:p>
-            <a:pPr>
-              <a:spcAft>
-                <a:spcPts val="200"/>
-              </a:spcAft>
-              <a:defRPr sz="1100">
-                <a:latin typeface="Calibri"/>
-              </a:defRPr>
-            </a:pPr>
-            <a:r>
-              <a:rPr b="1">
-                <a:solidFill>
-                  <a:srgbClr val="113927"/>
-                </a:solidFill>
-              </a:rPr>
-              <a:t>🎯 Parámetro A: </a:t>
-            </a:r>
-            <a:r>
-              <a:rPr>
-                <a:solidFill>
-                  <a:srgbClr val="2F3A30"/>
-                </a:solidFill>
-              </a:rPr>
-              <a:t>Ajuste de habilidades y competencias.</a:t>
-            </a:r>
-          </a:p>
-          <a:p>
-            <a:pPr>
-              <a:spcAft>
-                <a:spcPts val="200"/>
-              </a:spcAft>
-              <a:defRPr sz="1100">
-                <a:latin typeface="Calibri"/>
-              </a:defRPr>
-            </a:pPr>
-            <a:r>
-              <a:rPr b="1">
-                <a:solidFill>
-                  <a:srgbClr val="113927"/>
-                </a:solidFill>
-              </a:rPr>
-              <a:t>💡 Prueba el shock: </a:t>
-            </a:r>
-            <a:r>
-              <a:rPr>
-                <a:solidFill>
-                  <a:srgbClr val="2F3A30"/>
-                </a:solidFill>
-              </a:rPr>
-              <a:t>Pulsa 'Recesión' y 'Mismatch' en tu móvil.</a:t>
-            </a:r>
-          </a:p>
-          <a:p>
-            <a:pPr algn="ctr">
-              <a:spcBef>
-                <a:spcPts val="400"/>
-              </a:spcBef>
-            </a:pPr>
-            <a:r>
-              <a:rPr sz="1100" b="1">
+              <a:defRPr sz="1500" b="1">
                 <a:solidFill>
                   <a:srgbClr val="E98F71"/>
                 </a:solidFill>
-                <a:latin typeface="Calibri"/>
-              </a:rPr>
-              <a:t>mhidper.github.io/micro_apps/</a:t>
-            </a:r>
-          </a:p>
-        </p:txBody>
-      </p:sp>
+                <a:latin typeface="Outfit"/>
+              </a:defRPr>
+            </a:pPr>
+            <a:r>
+              <a:t>Microsoft Forms · Cuenta UPO</a:t>
+            </a:r>
+          </a:p>
+        </p:txBody>
+      </p:sp>
+      <p:pic>
+        <p:nvPicPr>
+          <p:cNvPr id="10" name="Picture 9" descr="qr_reto_sesion05.png"/>
+          <p:cNvPicPr>
+            <a:picLocks noChangeAspect="1"/>
+          </p:cNvPicPr>
+          <p:nvPr/>
+        </p:nvPicPr>
+        <p:blipFill>
+          <a:blip r:embed="rId3"/>
+          <a:stretch>
+            <a:fillRect/>
+          </a:stretch>
+        </p:blipFill>
+        <p:spPr>
+          <a:xfrm>
+            <a:off x="8412480" y="2560320"/>
+            <a:ext cx="2468880" cy="2468880"/>
+          </a:xfrm>
+          <a:prstGeom prst="rect">
+            <a:avLst/>
+          </a:prstGeom>
+        </p:spPr>
+      </p:pic>
       <p:sp>
         <p:nvSpPr>
           <p:cNvPr id="11" name="TextBox 10"/>
@@ -6821,8 +7252,8 @@
         </p:nvSpPr>
         <p:spPr>
           <a:xfrm>
-            <a:off x="548640" y="6400800"/>
-            <a:ext cx="9144000" cy="274320"/>
+            <a:off x="7772400" y="5166360"/>
+            <a:ext cx="3749039" cy="731520"/>
           </a:xfrm>
           <a:prstGeom prst="rect">
             <a:avLst/>
@@ -6835,52 +7266,20 @@
           </a:bodyPr>
           <a:lstStyle/>
           <a:p>
-            <a:pPr>
-              <a:defRPr sz="1000">
-                <a:solidFill>
-                  <a:srgbClr val="76927A"/>
+            <a:pPr algn="ctr">
+              <a:defRPr sz="1300">
+                <a:solidFill>
+                  <a:srgbClr val="2F3A30"/>
                 </a:solidFill>
                 <a:latin typeface="Calibri"/>
               </a:defRPr>
             </a:pPr>
             <a:r>
-              <a:t>Políticas Sociolaborales y de Empleo · Grado en RRLL y RRHH / Doble Grado DER-RRLL · UPO</a:t>
-            </a:r>
-          </a:p>
-        </p:txBody>
-      </p:sp>
-      <p:sp>
-        <p:nvSpPr>
-          <p:cNvPr id="12" name="TextBox 11"/>
-          <p:cNvSpPr txBox="1"/>
-          <p:nvPr/>
-        </p:nvSpPr>
-        <p:spPr>
-          <a:xfrm>
-            <a:off x="10515600" y="6400800"/>
-            <a:ext cx="1097280" cy="274320"/>
-          </a:xfrm>
-          <a:prstGeom prst="rect">
-            <a:avLst/>
-          </a:prstGeom>
-          <a:noFill/>
-        </p:spPr>
-        <p:txBody>
-          <a:bodyPr wrap="none">
-            <a:spAutoFit/>
-          </a:bodyPr>
-          <a:lstStyle/>
-          <a:p>
-            <a:pPr algn="r">
-              <a:defRPr sz="1000">
-                <a:solidFill>
-                  <a:srgbClr val="76927A"/>
-                </a:solidFill>
-                <a:latin typeface="Calibri"/>
-              </a:defRPr>
-            </a:pPr>
-            <a:r>
-              <a:t>8 / 17</a:t>
+              <a:t>forms.office.com/e/PSLL-Reto-S05</a:t>
+            </a:r>
+            <a:br/>
+            <a:r>
+              <a:t>(Tiempo de subida: 2 min)</a:t>
             </a:r>
           </a:p>
         </p:txBody>
@@ -9340,8 +9739,8 @@
           </a:p>
         </p:txBody>
       </p:sp>
-      <mc:AlternateContent xmlns:mc="http://schemas.openxmlformats.org/markup-compatibility/2006">
-        <mc:Choice xmlns:a14="http://schemas.microsoft.com/office/drawing/2010/main" Requires="a14">
+      <mc:AlternateContent xmlns:mc="http://schemas.openxmlformats.org/markup-compatibility/2006" xmlns:a14="http://schemas.microsoft.com/office/drawing/2010/main">
+        <mc:Choice Requires="a14">
           <p:sp>
             <p:nvSpPr>
               <p:cNvPr id="8" name="Rounded Rectangle 7"/>
@@ -9831,7 +10230,7 @@
             </p:txBody>
           </p:sp>
         </mc:Choice>
-        <mc:Fallback>
+        <mc:Fallback xmlns="">
           <p:sp>
             <p:nvSpPr>
               <p:cNvPr id="8" name="Rounded Rectangle 7"/>
@@ -10230,8 +10629,8 @@
           </a:p>
         </p:txBody>
       </p:sp>
-      <mc:AlternateContent xmlns:mc="http://schemas.openxmlformats.org/markup-compatibility/2006">
-        <mc:Choice xmlns:a14="http://schemas.microsoft.com/office/drawing/2010/main" Requires="a14">
+      <mc:AlternateContent xmlns:mc="http://schemas.openxmlformats.org/markup-compatibility/2006" xmlns:a14="http://schemas.microsoft.com/office/drawing/2010/main">
+        <mc:Choice Requires="a14">
           <p:sp>
             <p:nvSpPr>
               <p:cNvPr id="8" name="Rounded Rectangle 7"/>
@@ -10765,7 +11164,7 @@
             </p:txBody>
           </p:sp>
         </mc:Choice>
-        <mc:Fallback>
+        <mc:Fallback xmlns="">
           <p:sp>
             <p:nvSpPr>
               <p:cNvPr id="8" name="Rounded Rectangle 7"/>
@@ -10932,7 +11331,7 @@
           <a:noFill/>
         </p:spPr>
         <p:txBody>
-          <a:bodyPr wrap="square" lIns="0" tIns="0" rIns="0" bIns="0">
+          <a:bodyPr wrap="none">
             <a:spAutoFit/>
           </a:bodyPr>
           <a:lstStyle/>
@@ -10946,7 +11345,7 @@
               </a:defRPr>
             </a:pPr>
             <a:r>
-              <a:t>BLOQUE 3 · TEORÍA Y DIAGNÓSTICO</a:t>
+              <a:t>BLOQUE 2 · MODELIZACIÓN Y ESPACIO UV</a:t>
             </a:r>
           </a:p>
         </p:txBody>
@@ -10968,7 +11367,7 @@
           <a:noFill/>
         </p:spPr>
         <p:txBody>
-          <a:bodyPr wrap="square" lIns="0" tIns="0" rIns="0" bIns="0">
+          <a:bodyPr wrap="none">
             <a:spAutoFit/>
           </a:bodyPr>
           <a:lstStyle/>
@@ -10982,7 +11381,7 @@
               </a:defRPr>
             </a:pPr>
             <a:r>
-              <a:t>Geometría de Beveridge: Movimientos vs. Desplazamientos</a:t>
+              <a:t>De la Pista de Baile a la Curva de Beveridge</a:t>
             </a:r>
           </a:p>
         </p:txBody>
@@ -11004,7 +11403,7 @@
           <a:noFill/>
         </p:spPr>
         <p:txBody>
-          <a:bodyPr wrap="square" lIns="0" tIns="0" rIns="0" bIns="0">
+          <a:bodyPr wrap="none">
             <a:spAutoFit/>
           </a:bodyPr>
           <a:lstStyle/>
@@ -11018,14 +11417,14 @@
               </a:defRPr>
             </a:pPr>
             <a:r>
-              <a:t>Epígrafe 6.2 oficial: la distinción analítica entre ciclo económico y desajuste estructural</a:t>
+              <a:t>Epígrafe 6.1–6.2 oficial: cómo las micro-interacciones de la pista trazan la curva macroeconómica</a:t>
             </a:r>
           </a:p>
         </p:txBody>
       </p:sp>
       <p:pic>
         <p:nvPicPr>
-          <p:cNvPr id="5" name="Picture 4" descr="psll_lockup.png"/>
+          <p:cNvPr id="5" name="Picture 4" descr="image.png"/>
           <p:cNvPicPr>
             <a:picLocks noChangeAspect="1"/>
           </p:cNvPicPr>
@@ -11040,103 +11439,55 @@
         <p:spPr>
           <a:xfrm>
             <a:off x="10515600" y="365760"/>
-            <a:ext cx="1158544" cy="365760"/>
+            <a:ext cx="1161288" cy="365760"/>
           </a:xfrm>
           <a:prstGeom prst="rect">
             <a:avLst/>
           </a:prstGeom>
         </p:spPr>
       </p:pic>
-      <p:sp>
-        <p:nvSpPr>
-          <p:cNvPr id="6" name="TextBox 5"/>
-          <p:cNvSpPr txBox="1"/>
-          <p:nvPr/>
-        </p:nvSpPr>
-        <p:spPr>
-          <a:xfrm>
-            <a:off x="548640" y="6400800"/>
-            <a:ext cx="9144000" cy="274320"/>
+      <p:pic>
+        <p:nvPicPr>
+          <p:cNvPr id="6" name="Picture 5" descr="curva_beveridge_pista_baile.png"/>
+          <p:cNvPicPr>
+            <a:picLocks noChangeAspect="1"/>
+          </p:cNvPicPr>
+          <p:nvPr/>
+        </p:nvPicPr>
+        <p:blipFill>
+          <a:blip r:embed="rId3"/>
+          <a:stretch>
+            <a:fillRect/>
+          </a:stretch>
+        </p:blipFill>
+        <p:spPr>
+          <a:xfrm>
+            <a:off x="548640" y="1536192"/>
+            <a:ext cx="7772400" cy="3611880"/>
           </a:xfrm>
           <a:prstGeom prst="rect">
             <a:avLst/>
           </a:prstGeom>
-          <a:noFill/>
-        </p:spPr>
-        <p:txBody>
-          <a:bodyPr wrap="none" lIns="0" tIns="0" rIns="0" bIns="0">
-            <a:spAutoFit/>
-          </a:bodyPr>
-          <a:lstStyle/>
-          <a:p>
-            <a:pPr>
-              <a:defRPr sz="1000">
-                <a:solidFill>
-                  <a:srgbClr val="76927A"/>
-                </a:solidFill>
-                <a:latin typeface="Calibri"/>
-              </a:defRPr>
-            </a:pPr>
-            <a:r>
-              <a:t>Políticas Sociolaborales y de Empleo · Grado en RRLL y RRHH / Doble Grado DER-RRLL · UPO</a:t>
-            </a:r>
-          </a:p>
-        </p:txBody>
-      </p:sp>
-      <p:sp>
-        <p:nvSpPr>
-          <p:cNvPr id="7" name="TextBox 6"/>
-          <p:cNvSpPr txBox="1"/>
-          <p:nvPr/>
-        </p:nvSpPr>
-        <p:spPr>
-          <a:xfrm>
-            <a:off x="10515600" y="6400800"/>
-            <a:ext cx="1097280" cy="274320"/>
-          </a:xfrm>
-          <a:prstGeom prst="rect">
-            <a:avLst/>
-          </a:prstGeom>
-          <a:noFill/>
-        </p:spPr>
-        <p:txBody>
-          <a:bodyPr wrap="none" lIns="0" tIns="0" rIns="0" bIns="0">
-            <a:spAutoFit/>
-          </a:bodyPr>
-          <a:lstStyle/>
-          <a:p>
-            <a:pPr algn="r">
-              <a:defRPr sz="1000">
-                <a:solidFill>
-                  <a:srgbClr val="76927A"/>
-                </a:solidFill>
-                <a:latin typeface="Calibri"/>
-              </a:defRPr>
-            </a:pPr>
-            <a:r>
-              <a:t>9 / 17</a:t>
-            </a:r>
-          </a:p>
-        </p:txBody>
-      </p:sp>
-      <p:sp>
-        <p:nvSpPr>
-          <p:cNvPr id="8" name="Rounded Rectangle 7"/>
+        </p:spPr>
+      </p:pic>
+      <p:sp>
+        <p:nvSpPr>
+          <p:cNvPr id="7" name="Rounded Rectangle 6"/>
           <p:cNvSpPr/>
           <p:nvPr/>
         </p:nvSpPr>
         <p:spPr>
           <a:xfrm>
-            <a:off x="548640" y="1645920"/>
-            <a:ext cx="5394960" cy="4389120"/>
+            <a:off x="548640" y="5230368"/>
+            <a:ext cx="7772400" cy="1005840"/>
           </a:xfrm>
           <a:prstGeom prst="roundRect">
             <a:avLst/>
           </a:prstGeom>
           <a:solidFill>
-            <a:srgbClr val="FFFFFF"/>
+            <a:srgbClr val="F4F8F5"/>
           </a:solidFill>
-          <a:ln w="19050">
+          <a:ln w="12700">
             <a:solidFill>
               <a:srgbClr val="DCE5DF"/>
             </a:solidFill>
@@ -11157,14 +11508,11 @@
           </a:fontRef>
         </p:style>
         <p:txBody>
-          <a:bodyPr wrap="square" lIns="228600" tIns="201168" rIns="228600" rtlCol="0" anchor="ctr"/>
+          <a:bodyPr wrap="square" lIns="164592" tIns="109728" rIns="164592" bIns="91440" rtlCol="0" anchor="ctr"/>
           <a:lstStyle/>
           <a:p>
             <a:pPr algn="ctr">
-              <a:spcAft>
-                <a:spcPts val="1000"/>
-              </a:spcAft>
-              <a:defRPr sz="1600" b="1">
+              <a:defRPr sz="1300" b="1">
                 <a:solidFill>
                   <a:srgbClr val="113927"/>
                 </a:solidFill>
@@ -11172,12 +11520,12 @@
               </a:defRPr>
             </a:pPr>
             <a:r>
-              <a:t>1. MOVIMIENTOS A LO LARGO DE LA CURVA</a:t>
+              <a:t>Mecanismo Causal de Agregación (De la Micro a la Macro):</a:t>
             </a:r>
           </a:p>
           <a:p>
             <a:pPr>
-              <a:defRPr sz="1600">
+              <a:defRPr sz="1500">
                 <a:solidFill>
                   <a:srgbClr val="2F3A30"/>
                 </a:solidFill>
@@ -11185,36 +11533,35 @@
               </a:defRPr>
             </a:pPr>
             <a:r>
-              <a:t>• Causa Exclusiva: Shocks del Ciclo Económico (fluctuaciones de Demanda Agregada).</a:t>
-            </a:r>
-            <a:br/>
-            <a:br/>
-            <a:r>
-              <a:t>• Fase de Recesión: La caída de ventas hace que las empresas congelen vacantes y destruyan empleo: movimiento hacia abajo y a la derecha (u ↑, v ↓).</a:t>
-            </a:r>
-            <a:br/>
-            <a:br/>
-            <a:r>
-              <a:t>• Fase de Expansión: Aumenta la actividad, se publican más ofertas y se absorben parados: movimiento hacia arriba y a la izquierda (u ↓, v ↑).</a:t>
-            </a:r>
-            <a:br/>
-            <a:br/>
-            <a:r>
-              <a:t>• Pendiente Negativa: Relación inversa natural.</a:t>
-            </a:r>
-          </a:p>
-        </p:txBody>
-      </p:sp>
-      <p:sp>
-        <p:nvSpPr>
-          <p:cNvPr id="9" name="Rounded Rectangle 8"/>
+              <a:t>• En </a:t>
+            </a:r>
+            <a:r>
+              <a:rPr b="1"/>
+              <a:t>Recesión</a:t>
+            </a:r>
+            <a:r>
+              <a:t>, las empresas retiran vacantes y los parados quedan solos en la sala (movimiento a lo largo, u ↑, v ↓). Con </a:t>
+            </a:r>
+            <a:r>
+              <a:rPr b="1"/>
+              <a:t>desajuste formativo (A ↓)</a:t>
+            </a:r>
+            <a:r>
+              <a:t>, la pista se llena de puntos que chocan y rebotan sin emparejarse (desplazamiento hacia fuera).</a:t>
+            </a:r>
+          </a:p>
+        </p:txBody>
+      </p:sp>
+      <p:sp>
+        <p:nvSpPr>
+          <p:cNvPr id="8" name="Rounded Rectangle 7"/>
           <p:cNvSpPr/>
           <p:nvPr/>
         </p:nvSpPr>
         <p:spPr>
           <a:xfrm>
-            <a:off x="6217920" y="1645920"/>
-            <a:ext cx="5394960" cy="4389120"/>
+            <a:off x="8503920" y="1536192"/>
+            <a:ext cx="3154680" cy="4700016"/>
           </a:xfrm>
           <a:prstGeom prst="roundRect">
             <a:avLst/>
@@ -11224,7 +11571,7 @@
           </a:solidFill>
           <a:ln w="19050">
             <a:solidFill>
-              <a:srgbClr val="E98F71"/>
+              <a:srgbClr val="113927"/>
             </a:solidFill>
           </a:ln>
         </p:spPr>
@@ -11243,57 +11590,557 @@
           </a:fontRef>
         </p:style>
         <p:txBody>
-          <a:bodyPr wrap="square" lIns="228600" tIns="201168" rIns="228600" rtlCol="0" anchor="ctr"/>
+          <a:bodyPr wrap="square" lIns="146304" tIns="128016" rIns="146304" bIns="91440" rtlCol="0" anchor="ctr"/>
           <a:lstStyle/>
           <a:p>
             <a:pPr algn="ctr">
+              <a:defRPr sz="1400" b="1">
+                <a:solidFill>
+                  <a:srgbClr val="113927"/>
+                </a:solidFill>
+                <a:latin typeface="Outfit"/>
+              </a:defRPr>
+            </a:pPr>
+            <a:r>
+              <a:rPr dirty="0"/>
+              <a:t>LABORATORIO EN VIVO</a:t>
+            </a:r>
+          </a:p>
+          <a:p>
+            <a:pPr algn="ctr">
+              <a:defRPr sz="1200" b="1">
+                <a:solidFill>
+                  <a:srgbClr val="76927A"/>
+                </a:solidFill>
+                <a:latin typeface="Calibri"/>
+              </a:defRPr>
+            </a:pPr>
+            <a:r>
+              <a:rPr dirty="0"/>
+              <a:t>Micro-App: Pista de Baile ABM</a:t>
+            </a:r>
+          </a:p>
+        </p:txBody>
+      </p:sp>
+      <p:pic>
+        <p:nvPicPr>
+          <p:cNvPr id="9" name="Picture 8" descr="image.png"/>
+          <p:cNvPicPr>
+            <a:picLocks noChangeAspect="1"/>
+          </p:cNvPicPr>
+          <p:nvPr/>
+        </p:nvPicPr>
+        <p:blipFill>
+          <a:blip r:embed="rId4"/>
+          <a:stretch>
+            <a:fillRect/>
+          </a:stretch>
+        </p:blipFill>
+        <p:spPr>
+          <a:xfrm>
+            <a:off x="9253728" y="1929384"/>
+            <a:ext cx="1645920" cy="1645920"/>
+          </a:xfrm>
+          <a:prstGeom prst="rect">
+            <a:avLst/>
+          </a:prstGeom>
+        </p:spPr>
+      </p:pic>
+      <p:sp>
+        <p:nvSpPr>
+          <p:cNvPr id="10" name="TextBox 9"/>
+          <p:cNvSpPr txBox="1"/>
+          <p:nvPr/>
+        </p:nvSpPr>
+        <p:spPr>
+          <a:xfrm>
+            <a:off x="8595360" y="4297680"/>
+            <a:ext cx="2971800" cy="2194560"/>
+          </a:xfrm>
+          <a:prstGeom prst="rect">
+            <a:avLst/>
+          </a:prstGeom>
+          <a:noFill/>
+        </p:spPr>
+        <p:txBody>
+          <a:bodyPr wrap="square" lIns="0" tIns="0" rIns="0" bIns="0">
+            <a:spAutoFit/>
+          </a:bodyPr>
+          <a:lstStyle/>
+          <a:p>
+            <a:pPr>
               <a:spcAft>
-                <a:spcPts val="1000"/>
+                <a:spcPts val="200"/>
               </a:spcAft>
-              <a:defRPr sz="1600" b="1">
+              <a:defRPr sz="1100">
+                <a:latin typeface="Calibri"/>
+              </a:defRPr>
+            </a:pPr>
+            <a:r>
+              <a:rPr b="1" dirty="0">
                 <a:solidFill>
                   <a:srgbClr val="113927"/>
                 </a:solidFill>
-                <a:latin typeface="Outfit"/>
-              </a:defRPr>
-            </a:pPr>
-            <a:r>
-              <a:t>2. DESPLAZAMIENTOS DE LA CURVA</a:t>
+              </a:rPr>
+              <a:t>🔴 Puntos Rojos: </a:t>
+            </a:r>
+            <a:r>
+              <a:rPr dirty="0" err="1">
+                <a:solidFill>
+                  <a:srgbClr val="2F3A30"/>
+                </a:solidFill>
+              </a:rPr>
+              <a:t>Trabajadores</a:t>
+            </a:r>
+            <a:r>
+              <a:rPr dirty="0">
+                <a:solidFill>
+                  <a:srgbClr val="2F3A30"/>
+                </a:solidFill>
+              </a:rPr>
+              <a:t> </a:t>
+            </a:r>
+            <a:r>
+              <a:rPr dirty="0" err="1">
+                <a:solidFill>
+                  <a:srgbClr val="2F3A30"/>
+                </a:solidFill>
+              </a:rPr>
+              <a:t>desempleados</a:t>
+            </a:r>
+            <a:r>
+              <a:rPr dirty="0">
+                <a:solidFill>
+                  <a:srgbClr val="2F3A30"/>
+                </a:solidFill>
+              </a:rPr>
+              <a:t> (U).</a:t>
             </a:r>
           </a:p>
           <a:p>
             <a:pPr>
-              <a:defRPr sz="1600">
+              <a:spcAft>
+                <a:spcPts val="200"/>
+              </a:spcAft>
+              <a:defRPr sz="1100">
+                <a:latin typeface="Calibri"/>
+              </a:defRPr>
+            </a:pPr>
+            <a:r>
+              <a:rPr b="1" dirty="0">
+                <a:solidFill>
+                  <a:srgbClr val="113927"/>
+                </a:solidFill>
+              </a:rPr>
+              <a:t>🔵 Puntos </a:t>
+            </a:r>
+            <a:r>
+              <a:rPr b="1" dirty="0" err="1">
+                <a:solidFill>
+                  <a:srgbClr val="113927"/>
+                </a:solidFill>
+              </a:rPr>
+              <a:t>Azules</a:t>
+            </a:r>
+            <a:r>
+              <a:rPr b="1" dirty="0">
+                <a:solidFill>
+                  <a:srgbClr val="113927"/>
+                </a:solidFill>
+              </a:rPr>
+              <a:t>: </a:t>
+            </a:r>
+            <a:r>
+              <a:rPr dirty="0">
                 <a:solidFill>
                   <a:srgbClr val="2F3A30"/>
                 </a:solidFill>
+              </a:rPr>
+              <a:t>Empresas con </a:t>
+            </a:r>
+            <a:r>
+              <a:rPr dirty="0" err="1">
+                <a:solidFill>
+                  <a:srgbClr val="2F3A30"/>
+                </a:solidFill>
+              </a:rPr>
+              <a:t>vacantes</a:t>
+            </a:r>
+            <a:r>
+              <a:rPr dirty="0">
+                <a:solidFill>
+                  <a:srgbClr val="2F3A30"/>
+                </a:solidFill>
+              </a:rPr>
+              <a:t> (V).</a:t>
+            </a:r>
+          </a:p>
+          <a:p>
+            <a:pPr>
+              <a:spcAft>
+                <a:spcPts val="200"/>
+              </a:spcAft>
+              <a:defRPr sz="1100">
                 <a:latin typeface="Calibri"/>
               </a:defRPr>
             </a:pPr>
             <a:r>
-              <a:t>• Causa Exclusiva: Cambios Estructurales en la Eficiencia del Emparejamiento (A).</a:t>
-            </a:r>
-            <a:br/>
-            <a:br/>
-            <a:r>
-              <a:t>• Desplazamiento Hacia el Exterior (BC1 ➔ BC2):</a:t>
-            </a:r>
-            <a:br/>
-            <a:r>
-              <a:t>  - Para una MISMA tasa de vacantes, hay MUCHO MÁS desempleo.</a:t>
-            </a:r>
-            <a:br/>
-            <a:r>
-              <a:t>  - Síntoma de desajuste formativo (skills mismatch), ineficiencia en el SAE/SEPE o histéresis.</a:t>
-            </a:r>
-            <a:br/>
-            <a:br/>
-            <a:r>
-              <a:t>• Desplazamiento Hacia el Origen (BC2 ➔ BC1):</a:t>
-            </a:r>
-            <a:br/>
-            <a:r>
-              <a:t>  - Aumento de la eficiencia (A ↑): mejor orientación, formación dual y digitalización.</a:t>
+              <a:rPr b="1" dirty="0">
+                <a:solidFill>
+                  <a:srgbClr val="113927"/>
+                </a:solidFill>
+              </a:rPr>
+              <a:t>🟢 Pareja </a:t>
+            </a:r>
+            <a:r>
+              <a:rPr b="1" dirty="0" err="1">
+                <a:solidFill>
+                  <a:srgbClr val="113927"/>
+                </a:solidFill>
+              </a:rPr>
+              <a:t>Enlazada</a:t>
+            </a:r>
+            <a:r>
+              <a:rPr b="1" dirty="0">
+                <a:solidFill>
+                  <a:srgbClr val="113927"/>
+                </a:solidFill>
+              </a:rPr>
+              <a:t>: </a:t>
+            </a:r>
+            <a:r>
+              <a:rPr dirty="0" err="1">
+                <a:solidFill>
+                  <a:srgbClr val="2F3A30"/>
+                </a:solidFill>
+              </a:rPr>
+              <a:t>Contratación</a:t>
+            </a:r>
+            <a:r>
+              <a:rPr dirty="0">
+                <a:solidFill>
+                  <a:srgbClr val="2F3A30"/>
+                </a:solidFill>
+              </a:rPr>
+              <a:t> </a:t>
+            </a:r>
+            <a:r>
+              <a:rPr dirty="0" err="1">
+                <a:solidFill>
+                  <a:srgbClr val="2F3A30"/>
+                </a:solidFill>
+              </a:rPr>
+              <a:t>exitosa</a:t>
+            </a:r>
+            <a:r>
+              <a:rPr dirty="0">
+                <a:solidFill>
+                  <a:srgbClr val="2F3A30"/>
+                </a:solidFill>
+              </a:rPr>
+              <a:t> (M).</a:t>
+            </a:r>
+          </a:p>
+          <a:p>
+            <a:pPr>
+              <a:spcAft>
+                <a:spcPts val="200"/>
+              </a:spcAft>
+              <a:defRPr sz="1100">
+                <a:latin typeface="Calibri"/>
+              </a:defRPr>
+            </a:pPr>
+            <a:r>
+              <a:rPr b="1" dirty="0">
+                <a:solidFill>
+                  <a:srgbClr val="113927"/>
+                </a:solidFill>
+              </a:rPr>
+              <a:t>🎯 </a:t>
+            </a:r>
+            <a:r>
+              <a:rPr b="1" dirty="0" err="1">
+                <a:solidFill>
+                  <a:srgbClr val="113927"/>
+                </a:solidFill>
+              </a:rPr>
+              <a:t>Parámetro</a:t>
+            </a:r>
+            <a:r>
+              <a:rPr b="1" dirty="0">
+                <a:solidFill>
+                  <a:srgbClr val="113927"/>
+                </a:solidFill>
+              </a:rPr>
+              <a:t> A: </a:t>
+            </a:r>
+            <a:r>
+              <a:rPr dirty="0" err="1">
+                <a:solidFill>
+                  <a:srgbClr val="2F3A30"/>
+                </a:solidFill>
+              </a:rPr>
+              <a:t>Ajuste</a:t>
+            </a:r>
+            <a:r>
+              <a:rPr dirty="0">
+                <a:solidFill>
+                  <a:srgbClr val="2F3A30"/>
+                </a:solidFill>
+              </a:rPr>
+              <a:t> de </a:t>
+            </a:r>
+            <a:r>
+              <a:rPr dirty="0" err="1">
+                <a:solidFill>
+                  <a:srgbClr val="2F3A30"/>
+                </a:solidFill>
+              </a:rPr>
+              <a:t>habilidades</a:t>
+            </a:r>
+            <a:r>
+              <a:rPr dirty="0">
+                <a:solidFill>
+                  <a:srgbClr val="2F3A30"/>
+                </a:solidFill>
+              </a:rPr>
+              <a:t> y </a:t>
+            </a:r>
+            <a:r>
+              <a:rPr dirty="0" err="1">
+                <a:solidFill>
+                  <a:srgbClr val="2F3A30"/>
+                </a:solidFill>
+              </a:rPr>
+              <a:t>competencias</a:t>
+            </a:r>
+            <a:r>
+              <a:rPr dirty="0">
+                <a:solidFill>
+                  <a:srgbClr val="2F3A30"/>
+                </a:solidFill>
+              </a:rPr>
+              <a:t>.</a:t>
+            </a:r>
+          </a:p>
+          <a:p>
+            <a:pPr>
+              <a:spcAft>
+                <a:spcPts val="200"/>
+              </a:spcAft>
+              <a:defRPr sz="1100">
+                <a:latin typeface="Calibri"/>
+              </a:defRPr>
+            </a:pPr>
+            <a:r>
+              <a:rPr b="1" dirty="0">
+                <a:solidFill>
+                  <a:srgbClr val="113927"/>
+                </a:solidFill>
+              </a:rPr>
+              <a:t>💡 </a:t>
+            </a:r>
+            <a:r>
+              <a:rPr b="1" dirty="0" err="1">
+                <a:solidFill>
+                  <a:srgbClr val="113927"/>
+                </a:solidFill>
+              </a:rPr>
+              <a:t>Prueba</a:t>
+            </a:r>
+            <a:r>
+              <a:rPr b="1" dirty="0">
+                <a:solidFill>
+                  <a:srgbClr val="113927"/>
+                </a:solidFill>
+              </a:rPr>
+              <a:t> el shock: </a:t>
+            </a:r>
+            <a:r>
+              <a:rPr dirty="0" err="1">
+                <a:solidFill>
+                  <a:srgbClr val="2F3A30"/>
+                </a:solidFill>
+              </a:rPr>
+              <a:t>Pulsa</a:t>
+            </a:r>
+            <a:r>
+              <a:rPr dirty="0">
+                <a:solidFill>
+                  <a:srgbClr val="2F3A30"/>
+                </a:solidFill>
+              </a:rPr>
+              <a:t> '</a:t>
+            </a:r>
+            <a:r>
+              <a:rPr dirty="0" err="1">
+                <a:solidFill>
+                  <a:srgbClr val="2F3A30"/>
+                </a:solidFill>
+              </a:rPr>
+              <a:t>Recesión</a:t>
+            </a:r>
+            <a:r>
+              <a:rPr dirty="0">
+                <a:solidFill>
+                  <a:srgbClr val="2F3A30"/>
+                </a:solidFill>
+              </a:rPr>
+              <a:t>' y 'Mismatch' </a:t>
+            </a:r>
+            <a:r>
+              <a:rPr dirty="0" err="1">
+                <a:solidFill>
+                  <a:srgbClr val="2F3A30"/>
+                </a:solidFill>
+              </a:rPr>
+              <a:t>en</a:t>
+            </a:r>
+            <a:r>
+              <a:rPr dirty="0">
+                <a:solidFill>
+                  <a:srgbClr val="2F3A30"/>
+                </a:solidFill>
+              </a:rPr>
+              <a:t> </a:t>
+            </a:r>
+            <a:r>
+              <a:rPr dirty="0" err="1">
+                <a:solidFill>
+                  <a:srgbClr val="2F3A30"/>
+                </a:solidFill>
+              </a:rPr>
+              <a:t>tu</a:t>
+            </a:r>
+            <a:r>
+              <a:rPr dirty="0">
+                <a:solidFill>
+                  <a:srgbClr val="2F3A30"/>
+                </a:solidFill>
+              </a:rPr>
+              <a:t> </a:t>
+            </a:r>
+            <a:r>
+              <a:rPr dirty="0" err="1">
+                <a:solidFill>
+                  <a:srgbClr val="2F3A30"/>
+                </a:solidFill>
+              </a:rPr>
+              <a:t>móvil</a:t>
+            </a:r>
+            <a:r>
+              <a:rPr dirty="0">
+                <a:solidFill>
+                  <a:srgbClr val="2F3A30"/>
+                </a:solidFill>
+              </a:rPr>
+              <a:t>.</a:t>
+            </a:r>
+          </a:p>
+          <a:p>
+            <a:pPr algn="ctr">
+              <a:spcBef>
+                <a:spcPts val="400"/>
+              </a:spcBef>
+            </a:pPr>
+            <a:r>
+              <a:rPr sz="1100" b="1" dirty="0">
+                <a:solidFill>
+                  <a:srgbClr val="E98F71"/>
+                </a:solidFill>
+                <a:latin typeface="Calibri"/>
+              </a:rPr>
+              <a:t>mhidper.github.io/</a:t>
+            </a:r>
+            <a:r>
+              <a:rPr sz="1100" b="1" dirty="0" err="1">
+                <a:solidFill>
+                  <a:srgbClr val="E98F71"/>
+                </a:solidFill>
+                <a:latin typeface="Calibri"/>
+              </a:rPr>
+              <a:t>micro_apps</a:t>
+            </a:r>
+            <a:r>
+              <a:rPr sz="1100" b="1" dirty="0">
+                <a:solidFill>
+                  <a:srgbClr val="E98F71"/>
+                </a:solidFill>
+                <a:latin typeface="Calibri"/>
+              </a:rPr>
+              <a:t>/</a:t>
+            </a:r>
+          </a:p>
+        </p:txBody>
+      </p:sp>
+      <p:sp>
+        <p:nvSpPr>
+          <p:cNvPr id="11" name="TextBox 10"/>
+          <p:cNvSpPr txBox="1"/>
+          <p:nvPr/>
+        </p:nvSpPr>
+        <p:spPr>
+          <a:xfrm>
+            <a:off x="548640" y="6400800"/>
+            <a:ext cx="9144000" cy="274320"/>
+          </a:xfrm>
+          <a:prstGeom prst="rect">
+            <a:avLst/>
+          </a:prstGeom>
+          <a:noFill/>
+        </p:spPr>
+        <p:txBody>
+          <a:bodyPr wrap="none">
+            <a:spAutoFit/>
+          </a:bodyPr>
+          <a:lstStyle/>
+          <a:p>
+            <a:pPr>
+              <a:defRPr sz="1000">
+                <a:solidFill>
+                  <a:srgbClr val="76927A"/>
+                </a:solidFill>
+                <a:latin typeface="Calibri"/>
+              </a:defRPr>
+            </a:pPr>
+            <a:r>
+              <a:t>Políticas Sociolaborales y de Empleo · Grado en RRLL y RRHH / Doble Grado DER-RRLL · UPO</a:t>
+            </a:r>
+          </a:p>
+        </p:txBody>
+      </p:sp>
+      <p:sp>
+        <p:nvSpPr>
+          <p:cNvPr id="12" name="TextBox 11"/>
+          <p:cNvSpPr txBox="1"/>
+          <p:nvPr/>
+        </p:nvSpPr>
+        <p:spPr>
+          <a:xfrm>
+            <a:off x="10515600" y="6400800"/>
+            <a:ext cx="1097280" cy="274320"/>
+          </a:xfrm>
+          <a:prstGeom prst="rect">
+            <a:avLst/>
+          </a:prstGeom>
+          <a:noFill/>
+        </p:spPr>
+        <p:txBody>
+          <a:bodyPr wrap="none">
+            <a:spAutoFit/>
+          </a:bodyPr>
+          <a:lstStyle/>
+          <a:p>
+            <a:pPr algn="r">
+              <a:defRPr sz="1000">
+                <a:solidFill>
+                  <a:srgbClr val="76927A"/>
+                </a:solidFill>
+                <a:latin typeface="Calibri"/>
+              </a:defRPr>
+            </a:pPr>
+            <a:r>
+              <a:t>8 / 17</a:t>
             </a:r>
           </a:p>
         </p:txBody>
@@ -11332,7 +12179,7 @@
         <p:spPr>
           <a:xfrm>
             <a:off x="548640" y="365760"/>
-            <a:ext cx="9144000" cy="274320"/>
+            <a:ext cx="9144000" cy="169277"/>
           </a:xfrm>
           <a:prstGeom prst="rect">
             <a:avLst/>
@@ -11354,7 +12201,8 @@
               </a:defRPr>
             </a:pPr>
             <a:r>
-              <a:t>BLOQUE 3 · INTERPRETACIÓN ECONÓMICA</a:t>
+              <a:rPr dirty="0"/>
+              <a:t>BLOQUE 3 · EVIDENCIA EMPÍRICA (AMPLIACIÓN L1)</a:t>
             </a:r>
           </a:p>
         </p:txBody>
@@ -11390,7 +12238,16 @@
               </a:defRPr>
             </a:pPr>
             <a:r>
-              <a:t>Puntos Notables en la Curva de Beveridge</a:t>
+              <a:rPr dirty="0"/>
+              <a:t>La Curva de Beveridge </a:t>
+            </a:r>
+            <a:r>
+              <a:rPr dirty="0" err="1"/>
+              <a:t>en</a:t>
+            </a:r>
+            <a:r>
+              <a:rPr dirty="0"/>
+              <a:t> España (1980–2024)</a:t>
             </a:r>
           </a:p>
         </p:txBody>
@@ -11426,7 +12283,7 @@
               </a:defRPr>
             </a:pPr>
             <a:r>
-              <a:t>Epígrafe 6.3 oficial: equilibrio natural (Punto A) vs. desequilibrios macroeconómicos</a:t>
+              <a:t>Figura 1.9 oficial de los apuntes: análisis de las tres fases históricas macroeconómicas</a:t>
             </a:r>
           </a:p>
         </p:txBody>
@@ -11522,302 +12379,35 @@
               </a:defRPr>
             </a:pPr>
             <a:r>
-              <a:t>10 / 17</a:t>
-            </a:r>
-          </a:p>
-        </p:txBody>
-      </p:sp>
-      <p:sp>
-        <p:nvSpPr>
-          <p:cNvPr id="8" name="Rounded Rectangle 7"/>
-          <p:cNvSpPr/>
-          <p:nvPr/>
-        </p:nvSpPr>
-        <p:spPr>
-          <a:xfrm>
-            <a:off x="548640" y="1645920"/>
-            <a:ext cx="3611880" cy="4389120"/>
-          </a:xfrm>
-          <a:prstGeom prst="roundRect">
-            <a:avLst/>
-          </a:prstGeom>
-          <a:solidFill>
-            <a:srgbClr val="F4F8F5"/>
-          </a:solidFill>
-          <a:ln w="19050">
-            <a:solidFill>
-              <a:srgbClr val="DCE5DF"/>
-            </a:solidFill>
-          </a:ln>
-        </p:spPr>
-        <p:style>
-          <a:lnRef idx="1">
-            <a:schemeClr val="accent1"/>
-          </a:lnRef>
-          <a:fillRef idx="3">
-            <a:schemeClr val="accent1"/>
-          </a:fillRef>
-          <a:effectRef idx="2">
-            <a:schemeClr val="accent1"/>
-          </a:effectRef>
-          <a:fontRef idx="minor">
-            <a:schemeClr val="lt1"/>
-          </a:fontRef>
-        </p:style>
-        <p:txBody>
-          <a:bodyPr wrap="square" lIns="201168" tIns="201168" rIns="201168" rtlCol="0" anchor="ctr"/>
-          <a:lstStyle/>
-          <a:p>
-            <a:pPr algn="ctr">
-              <a:spcAft>
-                <a:spcPts val="400"/>
-              </a:spcAft>
-              <a:defRPr sz="1500" b="1">
-                <a:solidFill>
-                  <a:srgbClr val="113927"/>
-                </a:solidFill>
-                <a:latin typeface="Outfit"/>
-              </a:defRPr>
-            </a:pPr>
-            <a:r>
-              <a:t>PUNTO A · TASA NATURAL</a:t>
-            </a:r>
-          </a:p>
-          <a:p>
-            <a:pPr>
-              <a:spcAft>
-                <a:spcPts val="1400"/>
-              </a:spcAft>
-              <a:defRPr sz="1200" b="1">
-                <a:solidFill>
-                  <a:srgbClr val="E98F71"/>
-                </a:solidFill>
-                <a:latin typeface="Outfit"/>
-              </a:defRPr>
-            </a:pPr>
-            <a:r>
-              <a:t>Sobre la Bisectriz (u = v)</a:t>
-            </a:r>
-          </a:p>
-          <a:p>
-            <a:pPr>
-              <a:defRPr sz="1600">
-                <a:solidFill>
-                  <a:srgbClr val="2F3A30"/>
-                </a:solidFill>
-                <a:latin typeface="Calibri"/>
-              </a:defRPr>
-            </a:pPr>
-            <a:r>
-              <a:t>La tasa de desempleo coincide con la de vacantes.</a:t>
-            </a:r>
-            <a:br/>
-            <a:br/>
-            <a:r>
-              <a:t>Todo el desempleo observado es puramente friccional o de reasignación saludable; no hay componente cíclico.</a:t>
-            </a:r>
-            <a:br/>
-            <a:br/>
-            <a:r>
-              <a:t>Es el punto de referencia de equilibrio ideal para los responsables de política.</a:t>
-            </a:r>
-          </a:p>
-        </p:txBody>
-      </p:sp>
-      <p:sp>
-        <p:nvSpPr>
-          <p:cNvPr id="9" name="Rounded Rectangle 8"/>
-          <p:cNvSpPr/>
-          <p:nvPr/>
-        </p:nvSpPr>
-        <p:spPr>
-          <a:xfrm>
-            <a:off x="4343400" y="1645920"/>
-            <a:ext cx="3611880" cy="4389120"/>
-          </a:xfrm>
-          <a:prstGeom prst="roundRect">
-            <a:avLst/>
-          </a:prstGeom>
-          <a:solidFill>
-            <a:srgbClr val="F4F8F5"/>
-          </a:solidFill>
-          <a:ln w="19050">
-            <a:solidFill>
-              <a:srgbClr val="DCE5DF"/>
-            </a:solidFill>
-          </a:ln>
-        </p:spPr>
-        <p:style>
-          <a:lnRef idx="1">
-            <a:schemeClr val="accent1"/>
-          </a:lnRef>
-          <a:fillRef idx="3">
-            <a:schemeClr val="accent1"/>
-          </a:fillRef>
-          <a:effectRef idx="2">
-            <a:schemeClr val="accent1"/>
-          </a:effectRef>
-          <a:fontRef idx="minor">
-            <a:schemeClr val="lt1"/>
-          </a:fontRef>
-        </p:style>
-        <p:txBody>
-          <a:bodyPr wrap="square" lIns="201168" tIns="201168" rIns="201168" rtlCol="0" anchor="ctr"/>
-          <a:lstStyle/>
-          <a:p>
-            <a:pPr algn="ctr">
-              <a:spcAft>
-                <a:spcPts val="400"/>
-              </a:spcAft>
-              <a:defRPr sz="1500" b="1">
-                <a:solidFill>
-                  <a:srgbClr val="113927"/>
-                </a:solidFill>
-                <a:latin typeface="Outfit"/>
-              </a:defRPr>
-            </a:pPr>
-            <a:r>
-              <a:t>PUNTO B · RECESIÓN SEVERA</a:t>
-            </a:r>
-          </a:p>
-          <a:p>
-            <a:pPr>
-              <a:spcAft>
-                <a:spcPts val="1400"/>
-              </a:spcAft>
-              <a:defRPr sz="1200" b="1">
-                <a:solidFill>
-                  <a:srgbClr val="E98F71"/>
-                </a:solidFill>
-                <a:latin typeface="Outfit"/>
-              </a:defRPr>
-            </a:pPr>
-            <a:r>
-              <a:t>Bajo la Bisectriz (u &gt; v)</a:t>
-            </a:r>
-          </a:p>
-          <a:p>
-            <a:pPr>
-              <a:defRPr sz="1600">
-                <a:solidFill>
-                  <a:srgbClr val="2F3A30"/>
-                </a:solidFill>
-                <a:latin typeface="Calibri"/>
-              </a:defRPr>
-            </a:pPr>
-            <a:r>
-              <a:t>La tasa de desempleo supera ampliamente a la de vacantes ofertadas.</a:t>
-            </a:r>
-            <a:br/>
-            <a:br/>
-            <a:r>
-              <a:t>Existe un fuerte componente de desempleo involuntario keynesiano por insuficiencia de demanda agregada.</a:t>
-            </a:r>
-            <a:br/>
-            <a:br/>
-            <a:r>
-              <a:t>Requiere políticas macroeconómicas y estabilizadores.</a:t>
-            </a:r>
-          </a:p>
-        </p:txBody>
-      </p:sp>
-      <p:sp>
-        <p:nvSpPr>
-          <p:cNvPr id="10" name="Rounded Rectangle 9"/>
-          <p:cNvSpPr/>
-          <p:nvPr/>
-        </p:nvSpPr>
-        <p:spPr>
-          <a:xfrm>
-            <a:off x="8138160" y="1645920"/>
-            <a:ext cx="3611880" cy="4389120"/>
-          </a:xfrm>
-          <a:prstGeom prst="roundRect">
-            <a:avLst/>
-          </a:prstGeom>
-          <a:solidFill>
-            <a:srgbClr val="F4F8F5"/>
-          </a:solidFill>
-          <a:ln w="19050">
-            <a:solidFill>
-              <a:srgbClr val="DCE5DF"/>
-            </a:solidFill>
-          </a:ln>
-        </p:spPr>
-        <p:style>
-          <a:lnRef idx="1">
-            <a:schemeClr val="accent1"/>
-          </a:lnRef>
-          <a:fillRef idx="3">
-            <a:schemeClr val="accent1"/>
-          </a:fillRef>
-          <a:effectRef idx="2">
-            <a:schemeClr val="accent1"/>
-          </a:effectRef>
-          <a:fontRef idx="minor">
-            <a:schemeClr val="lt1"/>
-          </a:fontRef>
-        </p:style>
-        <p:txBody>
-          <a:bodyPr wrap="square" lIns="201168" tIns="201168" rIns="201168" rtlCol="0" anchor="ctr"/>
-          <a:lstStyle/>
-          <a:p>
-            <a:pPr algn="ctr">
-              <a:spcAft>
-                <a:spcPts val="400"/>
-              </a:spcAft>
-              <a:defRPr sz="1500" b="1">
-                <a:solidFill>
-                  <a:srgbClr val="113927"/>
-                </a:solidFill>
-                <a:latin typeface="Outfit"/>
-              </a:defRPr>
-            </a:pPr>
-            <a:r>
-              <a:t>PUNTO C · SOBRECALENTAMIENTO</a:t>
-            </a:r>
-          </a:p>
-          <a:p>
-            <a:pPr>
-              <a:spcAft>
-                <a:spcPts val="1400"/>
-              </a:spcAft>
-              <a:defRPr sz="1200" b="1">
-                <a:solidFill>
-                  <a:srgbClr val="E98F71"/>
-                </a:solidFill>
-                <a:latin typeface="Outfit"/>
-              </a:defRPr>
-            </a:pPr>
-            <a:r>
-              <a:t>Sobre la Bisectriz (u &lt; v)</a:t>
-            </a:r>
-          </a:p>
-          <a:p>
-            <a:pPr>
-              <a:defRPr sz="1600">
-                <a:solidFill>
-                  <a:srgbClr val="2F3A30"/>
-                </a:solidFill>
-                <a:latin typeface="Calibri"/>
-              </a:defRPr>
-            </a:pPr>
-            <a:r>
-              <a:t>La tasa de vacantes supera al desempleo disponible en la economía.</a:t>
-            </a:r>
-            <a:br/>
-            <a:br/>
-            <a:r>
-              <a:t>Tensión crítica (θ &gt;&gt; 1): las empresas no encuentran mano de obra.</a:t>
-            </a:r>
-            <a:br/>
-            <a:br/>
-            <a:r>
-              <a:t>Riesgo de presiones salariales inflacionistas según la Curva de Phillips aceleracionista.</a:t>
-            </a:r>
-          </a:p>
-        </p:txBody>
-      </p:sp>
+              <a:t>11 / 17</a:t>
+            </a:r>
+          </a:p>
+        </p:txBody>
+      </p:sp>
+      <p:pic>
+        <p:nvPicPr>
+          <p:cNvPr id="8" name="Picture 7" descr="curva_beveridge_dual.png"/>
+          <p:cNvPicPr>
+            <a:picLocks noChangeAspect="1"/>
+          </p:cNvPicPr>
+          <p:nvPr/>
+        </p:nvPicPr>
+        <p:blipFill>
+          <a:blip r:embed="rId3"/>
+          <a:stretch>
+            <a:fillRect/>
+          </a:stretch>
+        </p:blipFill>
+        <p:spPr>
+          <a:xfrm>
+            <a:off x="1336039" y="1353312"/>
+            <a:ext cx="8671561" cy="4734369"/>
+          </a:xfrm>
+          <a:prstGeom prst="rect">
+            <a:avLst/>
+          </a:prstGeom>
+        </p:spPr>
+      </p:pic>
     </p:spTree>
   </p:cSld>
   <p:clrMapOvr>

</xml_diff>

<commit_message>
Material docente Sesion 06 EB (PAE), cronograma EPD y actualizacion Pasaporte Digital
</commit_message>
<xml_diff>
--- a/Temas EB/Sesiones EB/Sesion 05/Sesion 05 - La Curva de Beveridge y Emparejamiento Laboral.pptx
+++ b/Temas EB/Sesiones EB/Sesion 05/Sesion 05 - La Curva de Beveridge y Emparejamiento Laboral.pptx
@@ -13,12 +13,12 @@
     <p:sldId id="261" r:id="rId7"/>
     <p:sldId id="262" r:id="rId8"/>
     <p:sldId id="272" r:id="rId9"/>
-    <p:sldId id="265" r:id="rId10"/>
-    <p:sldId id="263" r:id="rId11"/>
-    <p:sldId id="264" r:id="rId12"/>
-    <p:sldId id="273" r:id="rId13"/>
-    <p:sldId id="266" r:id="rId14"/>
-    <p:sldId id="267" r:id="rId15"/>
+    <p:sldId id="267" r:id="rId10"/>
+    <p:sldId id="265" r:id="rId11"/>
+    <p:sldId id="263" r:id="rId12"/>
+    <p:sldId id="264" r:id="rId13"/>
+    <p:sldId id="273" r:id="rId14"/>
+    <p:sldId id="266" r:id="rId15"/>
     <p:sldId id="268" r:id="rId16"/>
     <p:sldId id="269" r:id="rId17"/>
     <p:sldId id="270" r:id="rId18"/>
@@ -319,7 +319,7 @@
           <a:p>
             <a:fld id="{5BCAD085-E8A6-8845-BD4E-CB4CCA059FC4}" type="datetimeFigureOut">
               <a:rPr lang="en-US" smtClean="0"/>
-              <a:t>9/24/2026</a:t>
+              <a:t>9/28/2026</a:t>
             </a:fld>
             <a:endParaRPr lang="en-US"/>
           </a:p>
@@ -487,7 +487,7 @@
           <a:p>
             <a:fld id="{5BCAD085-E8A6-8845-BD4E-CB4CCA059FC4}" type="datetimeFigureOut">
               <a:rPr lang="en-US" smtClean="0"/>
-              <a:t>9/24/2026</a:t>
+              <a:t>9/28/2026</a:t>
             </a:fld>
             <a:endParaRPr lang="en-US"/>
           </a:p>
@@ -665,7 +665,7 @@
           <a:p>
             <a:fld id="{5BCAD085-E8A6-8845-BD4E-CB4CCA059FC4}" type="datetimeFigureOut">
               <a:rPr lang="en-US" smtClean="0"/>
-              <a:t>9/24/2026</a:t>
+              <a:t>9/28/2026</a:t>
             </a:fld>
             <a:endParaRPr lang="en-US"/>
           </a:p>
@@ -833,7 +833,7 @@
           <a:p>
             <a:fld id="{5BCAD085-E8A6-8845-BD4E-CB4CCA059FC4}" type="datetimeFigureOut">
               <a:rPr lang="en-US" smtClean="0"/>
-              <a:t>9/24/2026</a:t>
+              <a:t>9/28/2026</a:t>
             </a:fld>
             <a:endParaRPr lang="en-US"/>
           </a:p>
@@ -1078,7 +1078,7 @@
           <a:p>
             <a:fld id="{5BCAD085-E8A6-8845-BD4E-CB4CCA059FC4}" type="datetimeFigureOut">
               <a:rPr lang="en-US" smtClean="0"/>
-              <a:t>9/24/2026</a:t>
+              <a:t>9/28/2026</a:t>
             </a:fld>
             <a:endParaRPr lang="en-US"/>
           </a:p>
@@ -1363,7 +1363,7 @@
           <a:p>
             <a:fld id="{5BCAD085-E8A6-8845-BD4E-CB4CCA059FC4}" type="datetimeFigureOut">
               <a:rPr lang="en-US" smtClean="0"/>
-              <a:t>9/24/2026</a:t>
+              <a:t>9/28/2026</a:t>
             </a:fld>
             <a:endParaRPr lang="en-US"/>
           </a:p>
@@ -1782,7 +1782,7 @@
           <a:p>
             <a:fld id="{5BCAD085-E8A6-8845-BD4E-CB4CCA059FC4}" type="datetimeFigureOut">
               <a:rPr lang="en-US" smtClean="0"/>
-              <a:t>9/24/2026</a:t>
+              <a:t>9/28/2026</a:t>
             </a:fld>
             <a:endParaRPr lang="en-US"/>
           </a:p>
@@ -1899,7 +1899,7 @@
           <a:p>
             <a:fld id="{5BCAD085-E8A6-8845-BD4E-CB4CCA059FC4}" type="datetimeFigureOut">
               <a:rPr lang="en-US" smtClean="0"/>
-              <a:t>9/24/2026</a:t>
+              <a:t>9/28/2026</a:t>
             </a:fld>
             <a:endParaRPr lang="en-US"/>
           </a:p>
@@ -1994,7 +1994,7 @@
           <a:p>
             <a:fld id="{5BCAD085-E8A6-8845-BD4E-CB4CCA059FC4}" type="datetimeFigureOut">
               <a:rPr lang="en-US" smtClean="0"/>
-              <a:t>9/24/2026</a:t>
+              <a:t>9/28/2026</a:t>
             </a:fld>
             <a:endParaRPr lang="en-US"/>
           </a:p>
@@ -2269,7 +2269,7 @@
           <a:p>
             <a:fld id="{5BCAD085-E8A6-8845-BD4E-CB4CCA059FC4}" type="datetimeFigureOut">
               <a:rPr lang="en-US" smtClean="0"/>
-              <a:t>9/24/2026</a:t>
+              <a:t>9/28/2026</a:t>
             </a:fld>
             <a:endParaRPr lang="en-US"/>
           </a:p>
@@ -2521,7 +2521,7 @@
           <a:p>
             <a:fld id="{5BCAD085-E8A6-8845-BD4E-CB4CCA059FC4}" type="datetimeFigureOut">
               <a:rPr lang="en-US" smtClean="0"/>
-              <a:t>9/24/2026</a:t>
+              <a:t>9/28/2026</a:t>
             </a:fld>
             <a:endParaRPr lang="en-US"/>
           </a:p>
@@ -2732,7 +2732,7 @@
           <a:p>
             <a:fld id="{5BCAD085-E8A6-8845-BD4E-CB4CCA059FC4}" type="datetimeFigureOut">
               <a:rPr lang="en-US" smtClean="0"/>
-              <a:t>9/24/2026</a:t>
+              <a:t>9/28/2026</a:t>
             </a:fld>
             <a:endParaRPr lang="en-US"/>
           </a:p>
@@ -3421,7 +3421,7 @@
         <p:spPr>
           <a:xfrm>
             <a:off x="548640" y="365760"/>
-            <a:ext cx="9144000" cy="274320"/>
+            <a:ext cx="9144000" cy="169277"/>
           </a:xfrm>
           <a:prstGeom prst="rect">
             <a:avLst/>
@@ -3443,7 +3443,8 @@
               </a:defRPr>
             </a:pPr>
             <a:r>
-              <a:t>BLOQUE 3 · TEORÍA Y DIAGNÓSTICO</a:t>
+              <a:rPr dirty="0"/>
+              <a:t>BLOQUE 3 · EVIDENCIA EMPÍRICA (AMPLIACIÓN L1)</a:t>
             </a:r>
           </a:p>
         </p:txBody>
@@ -3479,7 +3480,16 @@
               </a:defRPr>
             </a:pPr>
             <a:r>
-              <a:t>Geometría de Beveridge: Movimientos vs. Desplazamientos</a:t>
+              <a:rPr dirty="0"/>
+              <a:t>La Curva de Beveridge </a:t>
+            </a:r>
+            <a:r>
+              <a:rPr dirty="0" err="1"/>
+              <a:t>en</a:t>
+            </a:r>
+            <a:r>
+              <a:rPr dirty="0"/>
+              <a:t> España (1980–2024)</a:t>
             </a:r>
           </a:p>
         </p:txBody>
@@ -3515,7 +3525,7 @@
               </a:defRPr>
             </a:pPr>
             <a:r>
-              <a:t>Epígrafe 6.2 oficial: la distinción analítica entre ciclo económico y desajuste estructural</a:t>
+              <a:t>Figura 1.9 oficial de los apuntes: análisis de las tres fases históricas macroeconómicas</a:t>
             </a:r>
           </a:p>
         </p:txBody>
@@ -3611,190 +3621,35 @@
               </a:defRPr>
             </a:pPr>
             <a:r>
-              <a:t>9 / 17</a:t>
-            </a:r>
-          </a:p>
-        </p:txBody>
-      </p:sp>
-      <p:sp>
-        <p:nvSpPr>
-          <p:cNvPr id="8" name="Rounded Rectangle 7"/>
-          <p:cNvSpPr/>
-          <p:nvPr/>
-        </p:nvSpPr>
-        <p:spPr>
-          <a:xfrm>
-            <a:off x="548640" y="1645920"/>
-            <a:ext cx="5394960" cy="4389120"/>
-          </a:xfrm>
-          <a:prstGeom prst="roundRect">
-            <a:avLst/>
-          </a:prstGeom>
-          <a:solidFill>
-            <a:srgbClr val="FFFFFF"/>
-          </a:solidFill>
-          <a:ln w="19050">
-            <a:solidFill>
-              <a:srgbClr val="DCE5DF"/>
-            </a:solidFill>
-          </a:ln>
-        </p:spPr>
-        <p:style>
-          <a:lnRef idx="1">
-            <a:schemeClr val="accent1"/>
-          </a:lnRef>
-          <a:fillRef idx="3">
-            <a:schemeClr val="accent1"/>
-          </a:fillRef>
-          <a:effectRef idx="2">
-            <a:schemeClr val="accent1"/>
-          </a:effectRef>
-          <a:fontRef idx="minor">
-            <a:schemeClr val="lt1"/>
-          </a:fontRef>
-        </p:style>
-        <p:txBody>
-          <a:bodyPr wrap="square" lIns="228600" tIns="201168" rIns="228600" rtlCol="0" anchor="ctr"/>
-          <a:lstStyle/>
-          <a:p>
-            <a:pPr algn="ctr">
-              <a:spcAft>
-                <a:spcPts val="1000"/>
-              </a:spcAft>
-              <a:defRPr sz="1600" b="1">
-                <a:solidFill>
-                  <a:srgbClr val="113927"/>
-                </a:solidFill>
-                <a:latin typeface="Outfit"/>
-              </a:defRPr>
-            </a:pPr>
-            <a:r>
-              <a:t>1. MOVIMIENTOS A LO LARGO DE LA CURVA</a:t>
-            </a:r>
-          </a:p>
-          <a:p>
-            <a:pPr>
-              <a:defRPr sz="1600">
-                <a:solidFill>
-                  <a:srgbClr val="2F3A30"/>
-                </a:solidFill>
-                <a:latin typeface="Calibri"/>
-              </a:defRPr>
-            </a:pPr>
-            <a:r>
-              <a:t>• Causa Exclusiva: Shocks del Ciclo Económico (fluctuaciones de Demanda Agregada).</a:t>
-            </a:r>
-            <a:br/>
-            <a:br/>
-            <a:r>
-              <a:t>• Fase de Recesión: La caída de ventas hace que las empresas congelen vacantes y destruyan empleo: movimiento hacia abajo y a la derecha (u ↑, v ↓).</a:t>
-            </a:r>
-            <a:br/>
-            <a:br/>
-            <a:r>
-              <a:t>• Fase de Expansión: Aumenta la actividad, se publican más ofertas y se absorben parados: movimiento hacia arriba y a la izquierda (u ↓, v ↑).</a:t>
-            </a:r>
-            <a:br/>
-            <a:br/>
-            <a:r>
-              <a:t>• Pendiente Negativa: Relación inversa natural.</a:t>
-            </a:r>
-          </a:p>
-        </p:txBody>
-      </p:sp>
-      <p:sp>
-        <p:nvSpPr>
-          <p:cNvPr id="9" name="Rounded Rectangle 8"/>
-          <p:cNvSpPr/>
-          <p:nvPr/>
-        </p:nvSpPr>
-        <p:spPr>
-          <a:xfrm>
-            <a:off x="6217920" y="1645920"/>
-            <a:ext cx="5394960" cy="4389120"/>
-          </a:xfrm>
-          <a:prstGeom prst="roundRect">
-            <a:avLst/>
-          </a:prstGeom>
-          <a:solidFill>
-            <a:srgbClr val="FFFFFF"/>
-          </a:solidFill>
-          <a:ln w="19050">
-            <a:solidFill>
-              <a:srgbClr val="E98F71"/>
-            </a:solidFill>
-          </a:ln>
-        </p:spPr>
-        <p:style>
-          <a:lnRef idx="1">
-            <a:schemeClr val="accent1"/>
-          </a:lnRef>
-          <a:fillRef idx="3">
-            <a:schemeClr val="accent1"/>
-          </a:fillRef>
-          <a:effectRef idx="2">
-            <a:schemeClr val="accent1"/>
-          </a:effectRef>
-          <a:fontRef idx="minor">
-            <a:schemeClr val="lt1"/>
-          </a:fontRef>
-        </p:style>
-        <p:txBody>
-          <a:bodyPr wrap="square" lIns="228600" tIns="201168" rIns="228600" rtlCol="0" anchor="ctr"/>
-          <a:lstStyle/>
-          <a:p>
-            <a:pPr algn="ctr">
-              <a:spcAft>
-                <a:spcPts val="1000"/>
-              </a:spcAft>
-              <a:defRPr sz="1600" b="1">
-                <a:solidFill>
-                  <a:srgbClr val="113927"/>
-                </a:solidFill>
-                <a:latin typeface="Outfit"/>
-              </a:defRPr>
-            </a:pPr>
-            <a:r>
-              <a:t>2. DESPLAZAMIENTOS DE LA CURVA</a:t>
-            </a:r>
-          </a:p>
-          <a:p>
-            <a:pPr>
-              <a:defRPr sz="1600">
-                <a:solidFill>
-                  <a:srgbClr val="2F3A30"/>
-                </a:solidFill>
-                <a:latin typeface="Calibri"/>
-              </a:defRPr>
-            </a:pPr>
-            <a:r>
-              <a:t>• Causa Exclusiva: Cambios Estructurales en la Eficiencia del Emparejamiento (A).</a:t>
-            </a:r>
-            <a:br/>
-            <a:br/>
-            <a:r>
-              <a:t>• Desplazamiento Hacia el Exterior (BC1 ➔ BC2):</a:t>
-            </a:r>
-            <a:br/>
-            <a:r>
-              <a:t>  - Para una MISMA tasa de vacantes, hay MUCHO MÁS desempleo.</a:t>
-            </a:r>
-            <a:br/>
-            <a:r>
-              <a:t>  - Síntoma de desajuste formativo (skills mismatch), ineficiencia en el SAE/SEPE o histéresis.</a:t>
-            </a:r>
-            <a:br/>
-            <a:br/>
-            <a:r>
-              <a:t>• Desplazamiento Hacia el Origen (BC2 ➔ BC1):</a:t>
-            </a:r>
-            <a:br/>
-            <a:r>
-              <a:t>  - Aumento de la eficiencia (A ↑): mejor orientación, formación dual y digitalización.</a:t>
-            </a:r>
-          </a:p>
-        </p:txBody>
-      </p:sp>
+              <a:t>11 / 17</a:t>
+            </a:r>
+          </a:p>
+        </p:txBody>
+      </p:sp>
+      <p:pic>
+        <p:nvPicPr>
+          <p:cNvPr id="8" name="Picture 7" descr="curva_beveridge_dual.png"/>
+          <p:cNvPicPr>
+            <a:picLocks noChangeAspect="1"/>
+          </p:cNvPicPr>
+          <p:nvPr/>
+        </p:nvPicPr>
+        <p:blipFill>
+          <a:blip r:embed="rId3"/>
+          <a:stretch>
+            <a:fillRect/>
+          </a:stretch>
+        </p:blipFill>
+        <p:spPr>
+          <a:xfrm>
+            <a:off x="1336039" y="1353312"/>
+            <a:ext cx="8671561" cy="4734369"/>
+          </a:xfrm>
+          <a:prstGeom prst="rect">
+            <a:avLst/>
+          </a:prstGeom>
+        </p:spPr>
+      </p:pic>
     </p:spTree>
   </p:cSld>
   <p:clrMapOvr>
@@ -3851,7 +3706,7 @@
               </a:defRPr>
             </a:pPr>
             <a:r>
-              <a:t>BLOQUE 3 · INTERPRETACIÓN ECONÓMICA</a:t>
+              <a:t>BLOQUE 3 · TEORÍA Y DIAGNÓSTICO</a:t>
             </a:r>
           </a:p>
         </p:txBody>
@@ -3887,7 +3742,7 @@
               </a:defRPr>
             </a:pPr>
             <a:r>
-              <a:t>Puntos Notables en la Curva de Beveridge</a:t>
+              <a:t>Geometría de Beveridge: Movimientos vs. Desplazamientos</a:t>
             </a:r>
           </a:p>
         </p:txBody>
@@ -3923,7 +3778,7 @@
               </a:defRPr>
             </a:pPr>
             <a:r>
-              <a:t>Epígrafe 6.3 oficial: equilibrio natural (Punto A) vs. desequilibrios macroeconómicos</a:t>
+              <a:t>Epígrafe 6.2 oficial: la distinción analítica entre ciclo económico y desajuste estructural</a:t>
             </a:r>
           </a:p>
         </p:txBody>
@@ -4019,7 +3874,7 @@
               </a:defRPr>
             </a:pPr>
             <a:r>
-              <a:t>10 / 17</a:t>
+              <a:t>9 / 17</a:t>
             </a:r>
           </a:p>
         </p:txBody>
@@ -4033,13 +3888,13 @@
         <p:spPr>
           <a:xfrm>
             <a:off x="548640" y="1645920"/>
-            <a:ext cx="3611880" cy="4389120"/>
+            <a:ext cx="5394960" cy="4389120"/>
           </a:xfrm>
           <a:prstGeom prst="roundRect">
             <a:avLst/>
           </a:prstGeom>
           <a:solidFill>
-            <a:srgbClr val="F4F8F5"/>
+            <a:srgbClr val="FFFFFF"/>
           </a:solidFill>
           <a:ln w="19050">
             <a:solidFill>
@@ -4062,14 +3917,14 @@
           </a:fontRef>
         </p:style>
         <p:txBody>
-          <a:bodyPr wrap="square" lIns="201168" tIns="201168" rIns="201168" rtlCol="0" anchor="ctr"/>
+          <a:bodyPr wrap="square" lIns="228600" tIns="201168" rIns="228600" rtlCol="0" anchor="ctr"/>
           <a:lstStyle/>
           <a:p>
             <a:pPr algn="ctr">
               <a:spcAft>
-                <a:spcPts val="400"/>
+                <a:spcPts val="1000"/>
               </a:spcAft>
-              <a:defRPr sz="1500" b="1">
+              <a:defRPr sz="1600" b="1">
                 <a:solidFill>
                   <a:srgbClr val="113927"/>
                 </a:solidFill>
@@ -4077,23 +3932,7 @@
               </a:defRPr>
             </a:pPr>
             <a:r>
-              <a:t>PUNTO A · TASA NATURAL</a:t>
-            </a:r>
-          </a:p>
-          <a:p>
-            <a:pPr>
-              <a:spcAft>
-                <a:spcPts val="1400"/>
-              </a:spcAft>
-              <a:defRPr sz="1200" b="1">
-                <a:solidFill>
-                  <a:srgbClr val="E98F71"/>
-                </a:solidFill>
-                <a:latin typeface="Outfit"/>
-              </a:defRPr>
-            </a:pPr>
-            <a:r>
-              <a:t>Sobre la Bisectriz (u = v)</a:t>
+              <a:t>1. MOVIMIENTOS A LO LARGO DE LA CURVA</a:t>
             </a:r>
           </a:p>
           <a:p>
@@ -4106,17 +3945,22 @@
               </a:defRPr>
             </a:pPr>
             <a:r>
-              <a:t>La tasa de desempleo coincide con la de vacantes.</a:t>
+              <a:t>• Causa Exclusiva: Shocks del Ciclo Económico (fluctuaciones de Demanda Agregada).</a:t>
             </a:r>
             <a:br/>
             <a:br/>
             <a:r>
-              <a:t>Todo el desempleo observado es puramente friccional o de reasignación saludable; no hay componente cíclico.</a:t>
+              <a:t>• Fase de Recesión: La caída de ventas hace que las empresas congelen vacantes y destruyan empleo: movimiento hacia abajo y a la derecha (u ↑, v ↓).</a:t>
             </a:r>
             <a:br/>
             <a:br/>
             <a:r>
-              <a:t>Es el punto de referencia de equilibrio ideal para los responsables de política.</a:t>
+              <a:t>• Fase de Expansión: Aumenta la actividad, se publican más ofertas y se absorben parados: movimiento hacia arriba y a la izquierda (u ↓, v ↑).</a:t>
+            </a:r>
+            <a:br/>
+            <a:br/>
+            <a:r>
+              <a:t>• Pendiente Negativa: Relación inversa natural.</a:t>
             </a:r>
           </a:p>
         </p:txBody>
@@ -4129,18 +3973,18 @@
         </p:nvSpPr>
         <p:spPr>
           <a:xfrm>
-            <a:off x="4343400" y="1645920"/>
-            <a:ext cx="3611880" cy="4389120"/>
+            <a:off x="6217920" y="1645920"/>
+            <a:ext cx="5394960" cy="4389120"/>
           </a:xfrm>
           <a:prstGeom prst="roundRect">
             <a:avLst/>
           </a:prstGeom>
           <a:solidFill>
-            <a:srgbClr val="F4F8F5"/>
+            <a:srgbClr val="FFFFFF"/>
           </a:solidFill>
           <a:ln w="19050">
             <a:solidFill>
-              <a:srgbClr val="DCE5DF"/>
+              <a:srgbClr val="E98F71"/>
             </a:solidFill>
           </a:ln>
         </p:spPr>
@@ -4159,14 +4003,14 @@
           </a:fontRef>
         </p:style>
         <p:txBody>
-          <a:bodyPr wrap="square" lIns="201168" tIns="201168" rIns="201168" rtlCol="0" anchor="ctr"/>
+          <a:bodyPr wrap="square" lIns="228600" tIns="201168" rIns="228600" rtlCol="0" anchor="ctr"/>
           <a:lstStyle/>
           <a:p>
             <a:pPr algn="ctr">
               <a:spcAft>
-                <a:spcPts val="400"/>
+                <a:spcPts val="1000"/>
               </a:spcAft>
-              <a:defRPr sz="1500" b="1">
+              <a:defRPr sz="1600" b="1">
                 <a:solidFill>
                   <a:srgbClr val="113927"/>
                 </a:solidFill>
@@ -4174,23 +4018,7 @@
               </a:defRPr>
             </a:pPr>
             <a:r>
-              <a:t>PUNTO B · RECESIÓN SEVERA</a:t>
-            </a:r>
-          </a:p>
-          <a:p>
-            <a:pPr>
-              <a:spcAft>
-                <a:spcPts val="1400"/>
-              </a:spcAft>
-              <a:defRPr sz="1200" b="1">
-                <a:solidFill>
-                  <a:srgbClr val="E98F71"/>
-                </a:solidFill>
-                <a:latin typeface="Outfit"/>
-              </a:defRPr>
-            </a:pPr>
-            <a:r>
-              <a:t>Bajo la Bisectriz (u &gt; v)</a:t>
+              <a:t>2. DESPLAZAMIENTOS DE LA CURVA</a:t>
             </a:r>
           </a:p>
           <a:p>
@@ -4203,30 +4031,271 @@
               </a:defRPr>
             </a:pPr>
             <a:r>
-              <a:t>La tasa de desempleo supera ampliamente a la de vacantes ofertadas.</a:t>
+              <a:t>• Causa Exclusiva: Cambios Estructurales en la Eficiencia del Emparejamiento (A).</a:t>
             </a:r>
             <a:br/>
             <a:br/>
             <a:r>
-              <a:t>Existe un fuerte componente de desempleo involuntario keynesiano por insuficiencia de demanda agregada.</a:t>
+              <a:t>• Desplazamiento Hacia el Exterior (BC1 ➔ BC2):</a:t>
+            </a:r>
+            <a:br/>
+            <a:r>
+              <a:t>  - Para una MISMA tasa de vacantes, hay MUCHO MÁS desempleo.</a:t>
+            </a:r>
+            <a:br/>
+            <a:r>
+              <a:t>  - Síntoma de desajuste formativo (skills mismatch), ineficiencia en el SAE/SEPE o histéresis.</a:t>
             </a:r>
             <a:br/>
             <a:br/>
             <a:r>
-              <a:t>Requiere políticas macroeconómicas y estabilizadores.</a:t>
-            </a:r>
-          </a:p>
-        </p:txBody>
-      </p:sp>
-      <p:sp>
-        <p:nvSpPr>
-          <p:cNvPr id="10" name="Rounded Rectangle 9"/>
+              <a:t>• Desplazamiento Hacia el Origen (BC2 ➔ BC1):</a:t>
+            </a:r>
+            <a:br/>
+            <a:r>
+              <a:t>  - Aumento de la eficiencia (A ↑): mejor orientación, formación dual y digitalización.</a:t>
+            </a:r>
+          </a:p>
+        </p:txBody>
+      </p:sp>
+    </p:spTree>
+  </p:cSld>
+  <p:clrMapOvr>
+    <a:masterClrMapping/>
+  </p:clrMapOvr>
+</p:sld>
+</file>
+
+<file path=ppt/slides/slide12.xml><?xml version="1.0" encoding="utf-8"?>
+<p:sld xmlns:a="http://schemas.openxmlformats.org/drawingml/2006/main" xmlns:r="http://schemas.openxmlformats.org/officeDocument/2006/relationships" xmlns:p="http://schemas.openxmlformats.org/presentationml/2006/main">
+  <p:cSld>
+    <p:spTree>
+      <p:nvGrpSpPr>
+        <p:cNvPr id="1" name=""/>
+        <p:cNvGrpSpPr/>
+        <p:nvPr/>
+      </p:nvGrpSpPr>
+      <p:grpSpPr>
+        <a:xfrm>
+          <a:off x="0" y="0"/>
+          <a:ext cx="0" cy="0"/>
+          <a:chOff x="0" y="0"/>
+          <a:chExt cx="0" cy="0"/>
+        </a:xfrm>
+      </p:grpSpPr>
+      <p:sp>
+        <p:nvSpPr>
+          <p:cNvPr id="2" name="TextBox 1"/>
+          <p:cNvSpPr txBox="1"/>
+          <p:nvPr/>
+        </p:nvSpPr>
+        <p:spPr>
+          <a:xfrm>
+            <a:off x="548640" y="365760"/>
+            <a:ext cx="9144000" cy="274320"/>
+          </a:xfrm>
+          <a:prstGeom prst="rect">
+            <a:avLst/>
+          </a:prstGeom>
+          <a:noFill/>
+        </p:spPr>
+        <p:txBody>
+          <a:bodyPr wrap="square" lIns="0" tIns="0" rIns="0" bIns="0">
+            <a:spAutoFit/>
+          </a:bodyPr>
+          <a:lstStyle/>
+          <a:p>
+            <a:pPr>
+              <a:defRPr sz="1100" b="1">
+                <a:solidFill>
+                  <a:srgbClr val="E98F71"/>
+                </a:solidFill>
+                <a:latin typeface="Outfit"/>
+              </a:defRPr>
+            </a:pPr>
+            <a:r>
+              <a:t>BLOQUE 3 · INTERPRETACIÓN ECONÓMICA</a:t>
+            </a:r>
+          </a:p>
+        </p:txBody>
+      </p:sp>
+      <p:sp>
+        <p:nvSpPr>
+          <p:cNvPr id="3" name="TextBox 2"/>
+          <p:cNvSpPr txBox="1"/>
+          <p:nvPr/>
+        </p:nvSpPr>
+        <p:spPr>
+          <a:xfrm>
+            <a:off x="548640" y="621792"/>
+            <a:ext cx="9601200" cy="475488"/>
+          </a:xfrm>
+          <a:prstGeom prst="rect">
+            <a:avLst/>
+          </a:prstGeom>
+          <a:noFill/>
+        </p:spPr>
+        <p:txBody>
+          <a:bodyPr wrap="square" lIns="0" tIns="0" rIns="0" bIns="0">
+            <a:spAutoFit/>
+          </a:bodyPr>
+          <a:lstStyle/>
+          <a:p>
+            <a:pPr>
+              <a:defRPr sz="2400" b="1">
+                <a:solidFill>
+                  <a:srgbClr val="113927"/>
+                </a:solidFill>
+                <a:latin typeface="Outfit"/>
+              </a:defRPr>
+            </a:pPr>
+            <a:r>
+              <a:t>Puntos Notables en la Curva de Beveridge</a:t>
+            </a:r>
+          </a:p>
+        </p:txBody>
+      </p:sp>
+      <p:sp>
+        <p:nvSpPr>
+          <p:cNvPr id="4" name="TextBox 3"/>
+          <p:cNvSpPr txBox="1"/>
+          <p:nvPr/>
+        </p:nvSpPr>
+        <p:spPr>
+          <a:xfrm>
+            <a:off x="548640" y="1097280"/>
+            <a:ext cx="9601200" cy="347472"/>
+          </a:xfrm>
+          <a:prstGeom prst="rect">
+            <a:avLst/>
+          </a:prstGeom>
+          <a:noFill/>
+        </p:spPr>
+        <p:txBody>
+          <a:bodyPr wrap="square" lIns="0" tIns="0" rIns="0" bIns="0">
+            <a:spAutoFit/>
+          </a:bodyPr>
+          <a:lstStyle/>
+          <a:p>
+            <a:pPr>
+              <a:defRPr sz="1400">
+                <a:solidFill>
+                  <a:srgbClr val="76927A"/>
+                </a:solidFill>
+                <a:latin typeface="Calibri"/>
+              </a:defRPr>
+            </a:pPr>
+            <a:r>
+              <a:t>Epígrafe 6.3 oficial: equilibrio natural (Punto A) vs. desequilibrios macroeconómicos</a:t>
+            </a:r>
+          </a:p>
+        </p:txBody>
+      </p:sp>
+      <p:pic>
+        <p:nvPicPr>
+          <p:cNvPr id="5" name="Picture 4" descr="psll_lockup.png"/>
+          <p:cNvPicPr>
+            <a:picLocks noChangeAspect="1"/>
+          </p:cNvPicPr>
+          <p:nvPr/>
+        </p:nvPicPr>
+        <p:blipFill>
+          <a:blip r:embed="rId2"/>
+          <a:stretch>
+            <a:fillRect/>
+          </a:stretch>
+        </p:blipFill>
+        <p:spPr>
+          <a:xfrm>
+            <a:off x="10515600" y="365760"/>
+            <a:ext cx="1158544" cy="365760"/>
+          </a:xfrm>
+          <a:prstGeom prst="rect">
+            <a:avLst/>
+          </a:prstGeom>
+        </p:spPr>
+      </p:pic>
+      <p:sp>
+        <p:nvSpPr>
+          <p:cNvPr id="6" name="TextBox 5"/>
+          <p:cNvSpPr txBox="1"/>
+          <p:nvPr/>
+        </p:nvSpPr>
+        <p:spPr>
+          <a:xfrm>
+            <a:off x="548640" y="6400800"/>
+            <a:ext cx="9144000" cy="274320"/>
+          </a:xfrm>
+          <a:prstGeom prst="rect">
+            <a:avLst/>
+          </a:prstGeom>
+          <a:noFill/>
+        </p:spPr>
+        <p:txBody>
+          <a:bodyPr wrap="none" lIns="0" tIns="0" rIns="0" bIns="0">
+            <a:spAutoFit/>
+          </a:bodyPr>
+          <a:lstStyle/>
+          <a:p>
+            <a:pPr>
+              <a:defRPr sz="1000">
+                <a:solidFill>
+                  <a:srgbClr val="76927A"/>
+                </a:solidFill>
+                <a:latin typeface="Calibri"/>
+              </a:defRPr>
+            </a:pPr>
+            <a:r>
+              <a:t>Políticas Sociolaborales y de Empleo · Grado en RRLL y RRHH / Doble Grado DER-RRLL · UPO</a:t>
+            </a:r>
+          </a:p>
+        </p:txBody>
+      </p:sp>
+      <p:sp>
+        <p:nvSpPr>
+          <p:cNvPr id="7" name="TextBox 6"/>
+          <p:cNvSpPr txBox="1"/>
+          <p:nvPr/>
+        </p:nvSpPr>
+        <p:spPr>
+          <a:xfrm>
+            <a:off x="10515600" y="6400800"/>
+            <a:ext cx="1097280" cy="274320"/>
+          </a:xfrm>
+          <a:prstGeom prst="rect">
+            <a:avLst/>
+          </a:prstGeom>
+          <a:noFill/>
+        </p:spPr>
+        <p:txBody>
+          <a:bodyPr wrap="none" lIns="0" tIns="0" rIns="0" bIns="0">
+            <a:spAutoFit/>
+          </a:bodyPr>
+          <a:lstStyle/>
+          <a:p>
+            <a:pPr algn="r">
+              <a:defRPr sz="1000">
+                <a:solidFill>
+                  <a:srgbClr val="76927A"/>
+                </a:solidFill>
+                <a:latin typeface="Calibri"/>
+              </a:defRPr>
+            </a:pPr>
+            <a:r>
+              <a:t>10 / 17</a:t>
+            </a:r>
+          </a:p>
+        </p:txBody>
+      </p:sp>
+      <p:sp>
+        <p:nvSpPr>
+          <p:cNvPr id="8" name="Rounded Rectangle 7"/>
           <p:cNvSpPr/>
           <p:nvPr/>
         </p:nvSpPr>
         <p:spPr>
           <a:xfrm>
-            <a:off x="8138160" y="1645920"/>
+            <a:off x="548640" y="1645920"/>
             <a:ext cx="3611880" cy="4389120"/>
           </a:xfrm>
           <a:prstGeom prst="roundRect">
@@ -4271,6 +4340,200 @@
               </a:defRPr>
             </a:pPr>
             <a:r>
+              <a:t>PUNTO A · TASA NATURAL</a:t>
+            </a:r>
+          </a:p>
+          <a:p>
+            <a:pPr>
+              <a:spcAft>
+                <a:spcPts val="1400"/>
+              </a:spcAft>
+              <a:defRPr sz="1200" b="1">
+                <a:solidFill>
+                  <a:srgbClr val="E98F71"/>
+                </a:solidFill>
+                <a:latin typeface="Outfit"/>
+              </a:defRPr>
+            </a:pPr>
+            <a:r>
+              <a:t>Sobre la Bisectriz (u = v)</a:t>
+            </a:r>
+          </a:p>
+          <a:p>
+            <a:pPr>
+              <a:defRPr sz="1600">
+                <a:solidFill>
+                  <a:srgbClr val="2F3A30"/>
+                </a:solidFill>
+                <a:latin typeface="Calibri"/>
+              </a:defRPr>
+            </a:pPr>
+            <a:r>
+              <a:t>La tasa de desempleo coincide con la de vacantes.</a:t>
+            </a:r>
+            <a:br/>
+            <a:br/>
+            <a:r>
+              <a:t>Todo el desempleo observado es puramente friccional o de reasignación saludable; no hay componente cíclico.</a:t>
+            </a:r>
+            <a:br/>
+            <a:br/>
+            <a:r>
+              <a:t>Es el punto de referencia de equilibrio ideal para los responsables de política.</a:t>
+            </a:r>
+          </a:p>
+        </p:txBody>
+      </p:sp>
+      <p:sp>
+        <p:nvSpPr>
+          <p:cNvPr id="9" name="Rounded Rectangle 8"/>
+          <p:cNvSpPr/>
+          <p:nvPr/>
+        </p:nvSpPr>
+        <p:spPr>
+          <a:xfrm>
+            <a:off x="4343400" y="1645920"/>
+            <a:ext cx="3611880" cy="4389120"/>
+          </a:xfrm>
+          <a:prstGeom prst="roundRect">
+            <a:avLst/>
+          </a:prstGeom>
+          <a:solidFill>
+            <a:srgbClr val="F4F8F5"/>
+          </a:solidFill>
+          <a:ln w="19050">
+            <a:solidFill>
+              <a:srgbClr val="DCE5DF"/>
+            </a:solidFill>
+          </a:ln>
+        </p:spPr>
+        <p:style>
+          <a:lnRef idx="1">
+            <a:schemeClr val="accent1"/>
+          </a:lnRef>
+          <a:fillRef idx="3">
+            <a:schemeClr val="accent1"/>
+          </a:fillRef>
+          <a:effectRef idx="2">
+            <a:schemeClr val="accent1"/>
+          </a:effectRef>
+          <a:fontRef idx="minor">
+            <a:schemeClr val="lt1"/>
+          </a:fontRef>
+        </p:style>
+        <p:txBody>
+          <a:bodyPr wrap="square" lIns="201168" tIns="201168" rIns="201168" rtlCol="0" anchor="ctr"/>
+          <a:lstStyle/>
+          <a:p>
+            <a:pPr algn="ctr">
+              <a:spcAft>
+                <a:spcPts val="400"/>
+              </a:spcAft>
+              <a:defRPr sz="1500" b="1">
+                <a:solidFill>
+                  <a:srgbClr val="113927"/>
+                </a:solidFill>
+                <a:latin typeface="Outfit"/>
+              </a:defRPr>
+            </a:pPr>
+            <a:r>
+              <a:t>PUNTO B · RECESIÓN SEVERA</a:t>
+            </a:r>
+          </a:p>
+          <a:p>
+            <a:pPr>
+              <a:spcAft>
+                <a:spcPts val="1400"/>
+              </a:spcAft>
+              <a:defRPr sz="1200" b="1">
+                <a:solidFill>
+                  <a:srgbClr val="E98F71"/>
+                </a:solidFill>
+                <a:latin typeface="Outfit"/>
+              </a:defRPr>
+            </a:pPr>
+            <a:r>
+              <a:t>Bajo la Bisectriz (u &gt; v)</a:t>
+            </a:r>
+          </a:p>
+          <a:p>
+            <a:pPr>
+              <a:defRPr sz="1600">
+                <a:solidFill>
+                  <a:srgbClr val="2F3A30"/>
+                </a:solidFill>
+                <a:latin typeface="Calibri"/>
+              </a:defRPr>
+            </a:pPr>
+            <a:r>
+              <a:t>La tasa de desempleo supera ampliamente a la de vacantes ofertadas.</a:t>
+            </a:r>
+            <a:br/>
+            <a:br/>
+            <a:r>
+              <a:t>Existe un fuerte componente de desempleo involuntario keynesiano por insuficiencia de demanda agregada.</a:t>
+            </a:r>
+            <a:br/>
+            <a:br/>
+            <a:r>
+              <a:t>Requiere políticas macroeconómicas y estabilizadores.</a:t>
+            </a:r>
+          </a:p>
+        </p:txBody>
+      </p:sp>
+      <p:sp>
+        <p:nvSpPr>
+          <p:cNvPr id="10" name="Rounded Rectangle 9"/>
+          <p:cNvSpPr/>
+          <p:nvPr/>
+        </p:nvSpPr>
+        <p:spPr>
+          <a:xfrm>
+            <a:off x="8138160" y="1645920"/>
+            <a:ext cx="3611880" cy="4389120"/>
+          </a:xfrm>
+          <a:prstGeom prst="roundRect">
+            <a:avLst/>
+          </a:prstGeom>
+          <a:solidFill>
+            <a:srgbClr val="F4F8F5"/>
+          </a:solidFill>
+          <a:ln w="19050">
+            <a:solidFill>
+              <a:srgbClr val="DCE5DF"/>
+            </a:solidFill>
+          </a:ln>
+        </p:spPr>
+        <p:style>
+          <a:lnRef idx="1">
+            <a:schemeClr val="accent1"/>
+          </a:lnRef>
+          <a:fillRef idx="3">
+            <a:schemeClr val="accent1"/>
+          </a:fillRef>
+          <a:effectRef idx="2">
+            <a:schemeClr val="accent1"/>
+          </a:effectRef>
+          <a:fontRef idx="minor">
+            <a:schemeClr val="lt1"/>
+          </a:fontRef>
+        </p:style>
+        <p:txBody>
+          <a:bodyPr wrap="square" lIns="201168" tIns="201168" rIns="201168" rtlCol="0" anchor="ctr"/>
+          <a:lstStyle/>
+          <a:p>
+            <a:pPr algn="ctr">
+              <a:spcAft>
+                <a:spcPts val="400"/>
+              </a:spcAft>
+              <a:defRPr sz="1500" b="1">
+                <a:solidFill>
+                  <a:srgbClr val="113927"/>
+                </a:solidFill>
+                <a:latin typeface="Outfit"/>
+              </a:defRPr>
+            </a:pPr>
+            <a:r>
               <a:t>PUNTO C · SOBRECALENTAMIENTO</a:t>
             </a:r>
           </a:p>
@@ -4323,7 +4586,7 @@
 </p:sld>
 </file>
 
-<file path=ppt/slides/slide12.xml><?xml version="1.0" encoding="utf-8"?>
+<file path=ppt/slides/slide13.xml><?xml version="1.0" encoding="utf-8"?>
 <p:sld xmlns:a="http://schemas.openxmlformats.org/drawingml/2006/main" xmlns:r="http://schemas.openxmlformats.org/officeDocument/2006/relationships" xmlns:p="http://schemas.openxmlformats.org/presentationml/2006/main">
   <p:cSld>
     <p:spTree>
@@ -4721,413 +4984,6 @@
         <p14:creationId xmlns:p14="http://schemas.microsoft.com/office/powerpoint/2010/main" val="3455451888"/>
       </p:ext>
     </p:extLst>
-  </p:cSld>
-  <p:clrMapOvr>
-    <a:masterClrMapping/>
-  </p:clrMapOvr>
-</p:sld>
-</file>
-
-<file path=ppt/slides/slide13.xml><?xml version="1.0" encoding="utf-8"?>
-<p:sld xmlns:a="http://schemas.openxmlformats.org/drawingml/2006/main" xmlns:r="http://schemas.openxmlformats.org/officeDocument/2006/relationships" xmlns:p="http://schemas.openxmlformats.org/presentationml/2006/main">
-  <p:cSld>
-    <p:spTree>
-      <p:nvGrpSpPr>
-        <p:cNvPr id="1" name=""/>
-        <p:cNvGrpSpPr/>
-        <p:nvPr/>
-      </p:nvGrpSpPr>
-      <p:grpSpPr>
-        <a:xfrm>
-          <a:off x="0" y="0"/>
-          <a:ext cx="0" cy="0"/>
-          <a:chOff x="0" y="0"/>
-          <a:chExt cx="0" cy="0"/>
-        </a:xfrm>
-      </p:grpSpPr>
-      <p:sp>
-        <p:nvSpPr>
-          <p:cNvPr id="2" name="TextBox 1"/>
-          <p:cNvSpPr txBox="1"/>
-          <p:nvPr/>
-        </p:nvSpPr>
-        <p:spPr>
-          <a:xfrm>
-            <a:off x="548640" y="365760"/>
-            <a:ext cx="9144000" cy="274320"/>
-          </a:xfrm>
-          <a:prstGeom prst="rect">
-            <a:avLst/>
-          </a:prstGeom>
-          <a:noFill/>
-        </p:spPr>
-        <p:txBody>
-          <a:bodyPr wrap="square" lIns="0" tIns="0" rIns="0" bIns="0">
-            <a:spAutoFit/>
-          </a:bodyPr>
-          <a:lstStyle/>
-          <a:p>
-            <a:pPr>
-              <a:defRPr sz="1100" b="1">
-                <a:solidFill>
-                  <a:srgbClr val="E98F71"/>
-                </a:solidFill>
-                <a:latin typeface="Outfit"/>
-              </a:defRPr>
-            </a:pPr>
-            <a:r>
-              <a:t>BLOQUE 3.5 · CUANTIFICACIÓN ANALÍTICA</a:t>
-            </a:r>
-          </a:p>
-        </p:txBody>
-      </p:sp>
-      <p:sp>
-        <p:nvSpPr>
-          <p:cNvPr id="3" name="TextBox 2"/>
-          <p:cNvSpPr txBox="1"/>
-          <p:nvPr/>
-        </p:nvSpPr>
-        <p:spPr>
-          <a:xfrm>
-            <a:off x="548640" y="621792"/>
-            <a:ext cx="9601200" cy="475488"/>
-          </a:xfrm>
-          <a:prstGeom prst="rect">
-            <a:avLst/>
-          </a:prstGeom>
-          <a:noFill/>
-        </p:spPr>
-        <p:txBody>
-          <a:bodyPr wrap="square" lIns="0" tIns="0" rIns="0" bIns="0">
-            <a:spAutoFit/>
-          </a:bodyPr>
-          <a:lstStyle/>
-          <a:p>
-            <a:pPr>
-              <a:defRPr sz="2400" b="1">
-                <a:solidFill>
-                  <a:srgbClr val="113927"/>
-                </a:solidFill>
-                <a:latin typeface="Outfit"/>
-              </a:defRPr>
-            </a:pPr>
-            <a:r>
-              <a:t>El Coste Macroeconómico de la Ineficiencia Laboral</a:t>
-            </a:r>
-          </a:p>
-        </p:txBody>
-      </p:sp>
-      <p:sp>
-        <p:nvSpPr>
-          <p:cNvPr id="4" name="TextBox 3"/>
-          <p:cNvSpPr txBox="1"/>
-          <p:nvPr/>
-        </p:nvSpPr>
-        <p:spPr>
-          <a:xfrm>
-            <a:off x="548640" y="1097280"/>
-            <a:ext cx="9601200" cy="347472"/>
-          </a:xfrm>
-          <a:prstGeom prst="rect">
-            <a:avLst/>
-          </a:prstGeom>
-          <a:noFill/>
-        </p:spPr>
-        <p:txBody>
-          <a:bodyPr wrap="square" lIns="0" tIns="0" rIns="0" bIns="0">
-            <a:spAutoFit/>
-          </a:bodyPr>
-          <a:lstStyle/>
-          <a:p>
-            <a:pPr>
-              <a:defRPr sz="1400">
-                <a:solidFill>
-                  <a:srgbClr val="76927A"/>
-                </a:solidFill>
-                <a:latin typeface="Calibri"/>
-              </a:defRPr>
-            </a:pPr>
-            <a:r>
-              <a:t>Resultados del modelo dinámico de equilibrio general (DGEM) · FEDEA / Nada es Gratis</a:t>
-            </a:r>
-          </a:p>
-        </p:txBody>
-      </p:sp>
-      <p:pic>
-        <p:nvPicPr>
-          <p:cNvPr id="5" name="Picture 4" descr="psll_lockup.png"/>
-          <p:cNvPicPr>
-            <a:picLocks noChangeAspect="1"/>
-          </p:cNvPicPr>
-          <p:nvPr/>
-        </p:nvPicPr>
-        <p:blipFill>
-          <a:blip r:embed="rId2"/>
-          <a:stretch>
-            <a:fillRect/>
-          </a:stretch>
-        </p:blipFill>
-        <p:spPr>
-          <a:xfrm>
-            <a:off x="10515600" y="365760"/>
-            <a:ext cx="1158544" cy="365760"/>
-          </a:xfrm>
-          <a:prstGeom prst="rect">
-            <a:avLst/>
-          </a:prstGeom>
-        </p:spPr>
-      </p:pic>
-      <p:sp>
-        <p:nvSpPr>
-          <p:cNvPr id="6" name="TextBox 5"/>
-          <p:cNvSpPr txBox="1"/>
-          <p:nvPr/>
-        </p:nvSpPr>
-        <p:spPr>
-          <a:xfrm>
-            <a:off x="548640" y="6400800"/>
-            <a:ext cx="9144000" cy="274320"/>
-          </a:xfrm>
-          <a:prstGeom prst="rect">
-            <a:avLst/>
-          </a:prstGeom>
-          <a:noFill/>
-        </p:spPr>
-        <p:txBody>
-          <a:bodyPr wrap="none" lIns="0" tIns="0" rIns="0" bIns="0">
-            <a:spAutoFit/>
-          </a:bodyPr>
-          <a:lstStyle/>
-          <a:p>
-            <a:pPr>
-              <a:defRPr sz="1000">
-                <a:solidFill>
-                  <a:srgbClr val="76927A"/>
-                </a:solidFill>
-                <a:latin typeface="Calibri"/>
-              </a:defRPr>
-            </a:pPr>
-            <a:r>
-              <a:t>Políticas Sociolaborales y de Empleo · Grado en RRLL y RRHH / Doble Grado DER-RRLL · UPO</a:t>
-            </a:r>
-          </a:p>
-        </p:txBody>
-      </p:sp>
-      <p:sp>
-        <p:nvSpPr>
-          <p:cNvPr id="7" name="TextBox 6"/>
-          <p:cNvSpPr txBox="1"/>
-          <p:nvPr/>
-        </p:nvSpPr>
-        <p:spPr>
-          <a:xfrm>
-            <a:off x="10515600" y="6400800"/>
-            <a:ext cx="1097280" cy="274320"/>
-          </a:xfrm>
-          <a:prstGeom prst="rect">
-            <a:avLst/>
-          </a:prstGeom>
-          <a:noFill/>
-        </p:spPr>
-        <p:txBody>
-          <a:bodyPr wrap="none" lIns="0" tIns="0" rIns="0" bIns="0">
-            <a:spAutoFit/>
-          </a:bodyPr>
-          <a:lstStyle/>
-          <a:p>
-            <a:pPr algn="r">
-              <a:defRPr sz="1000">
-                <a:solidFill>
-                  <a:srgbClr val="76927A"/>
-                </a:solidFill>
-                <a:latin typeface="Calibri"/>
-              </a:defRPr>
-            </a:pPr>
-            <a:r>
-              <a:t>12 / 17</a:t>
-            </a:r>
-          </a:p>
-        </p:txBody>
-      </p:sp>
-      <p:sp>
-        <p:nvSpPr>
-          <p:cNvPr id="8" name="Rounded Rectangle 7"/>
-          <p:cNvSpPr/>
-          <p:nvPr/>
-        </p:nvSpPr>
-        <p:spPr>
-          <a:xfrm>
-            <a:off x="548640" y="1645920"/>
-            <a:ext cx="5394960" cy="4389120"/>
-          </a:xfrm>
-          <a:prstGeom prst="roundRect">
-            <a:avLst/>
-          </a:prstGeom>
-          <a:solidFill>
-            <a:srgbClr val="F4F8F5"/>
-          </a:solidFill>
-          <a:ln w="19050">
-            <a:solidFill>
-              <a:srgbClr val="DCE5DF"/>
-            </a:solidFill>
-          </a:ln>
-        </p:spPr>
-        <p:style>
-          <a:lnRef idx="1">
-            <a:schemeClr val="accent1"/>
-          </a:lnRef>
-          <a:fillRef idx="3">
-            <a:schemeClr val="accent1"/>
-          </a:fillRef>
-          <a:effectRef idx="2">
-            <a:schemeClr val="accent1"/>
-          </a:effectRef>
-          <a:fontRef idx="minor">
-            <a:schemeClr val="lt1"/>
-          </a:fontRef>
-        </p:style>
-        <p:txBody>
-          <a:bodyPr wrap="square" lIns="228600" tIns="201168" rIns="228600" rtlCol="0" anchor="ctr"/>
-          <a:lstStyle/>
-          <a:p>
-            <a:pPr algn="ctr">
-              <a:spcAft>
-                <a:spcPts val="1000"/>
-              </a:spcAft>
-              <a:defRPr sz="1600" b="1">
-                <a:solidFill>
-                  <a:srgbClr val="113927"/>
-                </a:solidFill>
-                <a:latin typeface="Outfit"/>
-              </a:defRPr>
-            </a:pPr>
-            <a:r>
-              <a:t>1. CUANTIFICACIÓN DEL IMPACTO</a:t>
-            </a:r>
-          </a:p>
-          <a:p>
-            <a:pPr>
-              <a:defRPr sz="1600">
-                <a:solidFill>
-                  <a:srgbClr val="2F3A30"/>
-                </a:solidFill>
-                <a:latin typeface="Calibri"/>
-              </a:defRPr>
-            </a:pPr>
-            <a:r>
-              <a:t>• Impacto sobre el Empleo:</a:t>
-            </a:r>
-            <a:br/>
-            <a:r>
-              <a:t>La caída en la eficiencia de emparejamiento (A) explica hasta el 31% de la destrucción total de puestos de trabajo durante la crisis.</a:t>
-            </a:r>
-            <a:br/>
-            <a:br/>
-            <a:r>
-              <a:t>• Impacto sobre el PIB:</a:t>
-            </a:r>
-            <a:br/>
-            <a:r>
-              <a:t>El colapso en A explica el 55% de la disminución del Producto Interior Bruto en el punto más crítico de la recesión.</a:t>
-            </a:r>
-            <a:br/>
-            <a:br/>
-            <a:r>
-              <a:t>• Horas Trabajadas: El modelo explica el aumento anómalo de horas medias trabajadas por empleado durante la crisis.</a:t>
-            </a:r>
-          </a:p>
-        </p:txBody>
-      </p:sp>
-      <p:sp>
-        <p:nvSpPr>
-          <p:cNvPr id="9" name="Rounded Rectangle 8"/>
-          <p:cNvSpPr/>
-          <p:nvPr/>
-        </p:nvSpPr>
-        <p:spPr>
-          <a:xfrm>
-            <a:off x="6217920" y="1645920"/>
-            <a:ext cx="5394960" cy="4389120"/>
-          </a:xfrm>
-          <a:prstGeom prst="roundRect">
-            <a:avLst/>
-          </a:prstGeom>
-          <a:solidFill>
-            <a:srgbClr val="FFFFFF"/>
-          </a:solidFill>
-          <a:ln w="19050">
-            <a:solidFill>
-              <a:srgbClr val="76927A"/>
-            </a:solidFill>
-          </a:ln>
-        </p:spPr>
-        <p:style>
-          <a:lnRef idx="1">
-            <a:schemeClr val="accent1"/>
-          </a:lnRef>
-          <a:fillRef idx="3">
-            <a:schemeClr val="accent1"/>
-          </a:fillRef>
-          <a:effectRef idx="2">
-            <a:schemeClr val="accent1"/>
-          </a:effectRef>
-          <a:fontRef idx="minor">
-            <a:schemeClr val="lt1"/>
-          </a:fontRef>
-        </p:style>
-        <p:txBody>
-          <a:bodyPr wrap="square" lIns="228600" tIns="201168" rIns="228600" rtlCol="0" anchor="ctr"/>
-          <a:lstStyle/>
-          <a:p>
-            <a:pPr algn="ctr">
-              <a:spcAft>
-                <a:spcPts val="1000"/>
-              </a:spcAft>
-              <a:defRPr sz="1600" b="1">
-                <a:solidFill>
-                  <a:srgbClr val="113927"/>
-                </a:solidFill>
-                <a:latin typeface="Outfit"/>
-              </a:defRPr>
-            </a:pPr>
-            <a:r>
-              <a:t>2. LECCIÓN CLAVE DE POLÍTICA PÚBLICA</a:t>
-            </a:r>
-          </a:p>
-          <a:p>
-            <a:pPr>
-              <a:defRPr sz="1600">
-                <a:solidFill>
-                  <a:srgbClr val="2F3A30"/>
-                </a:solidFill>
-                <a:latin typeface="Calibri"/>
-              </a:defRPr>
-            </a:pPr>
-            <a:r>
-              <a:t>• El Error del Diagnóstico Exclusivo:</a:t>
-            </a:r>
-            <a:br/>
-            <a:r>
-              <a:t>Tradicionalmente se atribuyó la crisis laboral española solo a la rigidez de los costes de despido o a la negociación colectiva.</a:t>
-            </a:r>
-            <a:br/>
-            <a:br/>
-            <a:r>
-              <a:t>• La Importancia de la Intermediación:</a:t>
-            </a:r>
-            <a:br/>
-            <a:r>
-              <a:t>Este estudio demostró que la ineficiencia en las políticas activas y los servicios públicos de empleo (SAE/SEPE) multiplicó la recesión.</a:t>
-            </a:r>
-            <a:br/>
-            <a:br/>
-            <a:r>
-              <a:t>• Desafío Inmediato: Reducir la volatilidad estructural conectando educación y empresa.</a:t>
-            </a:r>
-          </a:p>
-        </p:txBody>
-      </p:sp>
-    </p:spTree>
   </p:cSld>
   <p:clrMapOvr>
     <a:masterClrMapping/>
@@ -5183,7 +5039,7 @@
               </a:defRPr>
             </a:pPr>
             <a:r>
-              <a:t>BLOQUE 4 · LABORATORIO ACTIVO Y SIMULADOR (20 MIN)</a:t>
+              <a:t>BLOQUE 3.5 · CUANTIFICACIÓN ANALÍTICA</a:t>
             </a:r>
           </a:p>
         </p:txBody>
@@ -5219,7 +5075,7 @@
               </a:defRPr>
             </a:pPr>
             <a:r>
-              <a:t>Simulador Móvil: Curva de Beveridge y Emparejamiento</a:t>
+              <a:t>El Coste Macroeconómico de la Ineficiencia Laboral</a:t>
             </a:r>
           </a:p>
         </p:txBody>
@@ -5255,7 +5111,7 @@
               </a:defRPr>
             </a:pPr>
             <a:r>
-              <a:t>Misión técnica interactiva: rol de Analistas de la Consejería de Empleo desde el smartphone</a:t>
+              <a:t>Resultados del modelo dinámico de equilibrio general (DGEM) · FEDEA / Nada es Gratis</a:t>
             </a:r>
           </a:p>
         </p:txBody>
@@ -5351,7 +5207,7 @@
               </a:defRPr>
             </a:pPr>
             <a:r>
-              <a:t>13 / 17</a:t>
+              <a:t>12 / 17</a:t>
             </a:r>
           </a:p>
         </p:txBody>
@@ -5365,17 +5221,17 @@
         <p:spPr>
           <a:xfrm>
             <a:off x="548640" y="1645920"/>
-            <a:ext cx="6858000" cy="4389120"/>
+            <a:ext cx="5394960" cy="4389120"/>
           </a:xfrm>
           <a:prstGeom prst="roundRect">
             <a:avLst/>
           </a:prstGeom>
           <a:solidFill>
-            <a:srgbClr val="FFFFFF"/>
+            <a:srgbClr val="F4F8F5"/>
           </a:solidFill>
           <a:ln w="19050">
             <a:solidFill>
-              <a:srgbClr val="76927A"/>
+              <a:srgbClr val="DCE5DF"/>
             </a:solidFill>
           </a:ln>
         </p:spPr>
@@ -5394,22 +5250,22 @@
           </a:fontRef>
         </p:style>
         <p:txBody>
-          <a:bodyPr wrap="square" lIns="256032" tIns="201168" rIns="256032" rtlCol="0" anchor="ctr"/>
+          <a:bodyPr wrap="square" lIns="228600" tIns="201168" rIns="228600" rtlCol="0" anchor="ctr"/>
           <a:lstStyle/>
           <a:p>
             <a:pPr algn="ctr">
               <a:spcAft>
-                <a:spcPts val="800"/>
+                <a:spcPts val="1000"/>
               </a:spcAft>
-              <a:defRPr sz="1200" b="1">
-                <a:solidFill>
-                  <a:srgbClr val="E98F71"/>
+              <a:defRPr sz="1600" b="1">
+                <a:solidFill>
+                  <a:srgbClr val="113927"/>
                 </a:solidFill>
                 <a:latin typeface="Outfit"/>
               </a:defRPr>
             </a:pPr>
             <a:r>
-              <a:t>MISIÓN TÉCNICA · GABINETE DE LA CONSEJERÍA DE EMPLEO</a:t>
+              <a:t>1. CUANTIFICACIÓN DEL IMPACTO</a:t>
             </a:r>
           </a:p>
           <a:p>
@@ -5422,22 +5278,25 @@
               </a:defRPr>
             </a:pPr>
             <a:r>
-              <a:t>1. Apertura de la App en el Móvil: Escanear el código QR contiguo para abrir el simulador interactivo en HTML5 Canvas.</a:t>
+              <a:t>• Impacto sobre el Empleo:</a:t>
+            </a:r>
+            <a:br/>
+            <a:r>
+              <a:t>La caída en la eficiencia de emparejamiento (A) explica hasta el 31% de la destrucción total de puestos de trabajo durante la crisis.</a:t>
             </a:r>
             <a:br/>
             <a:br/>
             <a:r>
-              <a:t>2. Experimento 1 (Ciclo vs Estructura): Mover el control de Demanda Agregada manteniendo A constante. Comprobar cómo la economía se desplaza a lo largo de la curva UV.</a:t>
+              <a:t>• Impacto sobre el PIB:</a:t>
+            </a:r>
+            <a:br/>
+            <a:r>
+              <a:t>El colapso en A explica el 55% de la disminución del Producto Interior Bruto en el punto más crítico de la recesión.</a:t>
             </a:r>
             <a:br/>
             <a:br/>
             <a:r>
-              <a:t>3. Experimento 2 (Shock de Desajuste): Activar el escenario de Skills Mismatch y caída de A. Observar cómo la curva entera se desplaza hacia el exterior.</a:t>
-            </a:r>
-            <a:br/>
-            <a:br/>
-            <a:r>
-              <a:t>4. Cumplimentar en parejas la Hoja de Laboratorio Activo.</a:t>
+              <a:t>• Horas Trabajadas: El modelo explica el aumento anómalo de horas medias trabajadas por empleado durante la crisis.</a:t>
             </a:r>
           </a:p>
         </p:txBody>
@@ -5450,18 +5309,18 @@
         </p:nvSpPr>
         <p:spPr>
           <a:xfrm>
-            <a:off x="7680960" y="1645920"/>
-            <a:ext cx="3931920" cy="4389120"/>
+            <a:off x="6217920" y="1645920"/>
+            <a:ext cx="5394960" cy="4389120"/>
           </a:xfrm>
           <a:prstGeom prst="roundRect">
             <a:avLst/>
           </a:prstGeom>
           <a:solidFill>
-            <a:srgbClr val="F4F8F5"/>
+            <a:srgbClr val="FFFFFF"/>
           </a:solidFill>
           <a:ln w="19050">
             <a:solidFill>
-              <a:srgbClr val="E98F71"/>
+              <a:srgbClr val="76927A"/>
             </a:solidFill>
           </a:ln>
         </p:spPr>
@@ -5480,90 +5339,28 @@
           </a:fontRef>
         </p:style>
         <p:txBody>
-          <a:bodyPr wrap="square" lIns="182880" tIns="201168" rIns="182880" rtlCol="0" anchor="ctr"/>
-          <a:lstStyle/>
-          <a:p>
-            <a:pPr algn="ctr">
-              <a:spcAft>
-                <a:spcPts val="600"/>
-              </a:spcAft>
-              <a:defRPr sz="1100" b="1">
-                <a:solidFill>
-                  <a:srgbClr val="113927"/>
-                </a:solidFill>
-                <a:latin typeface="Outfit"/>
-              </a:defRPr>
-            </a:pPr>
-            <a:r>
-              <a:t>ACCESO DIRECTO A LA MICRO-APP</a:t>
-            </a:r>
-          </a:p>
+          <a:bodyPr wrap="square" lIns="228600" tIns="201168" rIns="228600" rtlCol="0" anchor="ctr"/>
+          <a:lstStyle/>
           <a:p>
             <a:pPr algn="ctr">
               <a:spcAft>
                 <a:spcPts val="1000"/>
               </a:spcAft>
-              <a:defRPr sz="1500" b="1">
-                <a:solidFill>
-                  <a:srgbClr val="E98F71"/>
+              <a:defRPr sz="1600" b="1">
+                <a:solidFill>
+                  <a:srgbClr val="113927"/>
                 </a:solidFill>
                 <a:latin typeface="Outfit"/>
               </a:defRPr>
             </a:pPr>
             <a:r>
-              <a:t>Simulador Beveridge &amp; DMP</a:t>
-            </a:r>
-          </a:p>
-        </p:txBody>
-      </p:sp>
-      <p:pic>
-        <p:nvPicPr>
-          <p:cNvPr id="10" name="Picture 9" descr="qr_app_sesion05.png"/>
-          <p:cNvPicPr>
-            <a:picLocks noChangeAspect="1"/>
-          </p:cNvPicPr>
-          <p:nvPr/>
-        </p:nvPicPr>
-        <p:blipFill>
-          <a:blip r:embed="rId3"/>
-          <a:stretch>
-            <a:fillRect/>
-          </a:stretch>
-        </p:blipFill>
-        <p:spPr>
-          <a:xfrm>
-            <a:off x="8412480" y="2560320"/>
-            <a:ext cx="2468880" cy="2468880"/>
-          </a:xfrm>
-          <a:prstGeom prst="rect">
-            <a:avLst/>
-          </a:prstGeom>
-        </p:spPr>
-      </p:pic>
-      <p:sp>
-        <p:nvSpPr>
-          <p:cNvPr id="11" name="TextBox 10"/>
-          <p:cNvSpPr txBox="1"/>
-          <p:nvPr/>
-        </p:nvSpPr>
-        <p:spPr>
-          <a:xfrm>
-            <a:off x="7772400" y="5166360"/>
-            <a:ext cx="3749039" cy="731520"/>
-          </a:xfrm>
-          <a:prstGeom prst="rect">
-            <a:avLst/>
-          </a:prstGeom>
-          <a:noFill/>
-        </p:spPr>
-        <p:txBody>
-          <a:bodyPr wrap="none">
-            <a:spAutoFit/>
-          </a:bodyPr>
-          <a:lstStyle/>
-          <a:p>
-            <a:pPr algn="ctr">
-              <a:defRPr sz="1300">
+              <a:rPr dirty="0"/>
+              <a:t>2. LECCIÓN CLAVE DE POLÍTICA PÚBLICA</a:t>
+            </a:r>
+          </a:p>
+          <a:p>
+            <a:pPr>
+              <a:defRPr sz="1600">
                 <a:solidFill>
                   <a:srgbClr val="2F3A30"/>
                 </a:solidFill>
@@ -5571,11 +5368,322 @@
               </a:defRPr>
             </a:pPr>
             <a:r>
-              <a:t>mhidper.github.io/micro_apps</a:t>
-            </a:r>
-            <a:br/>
-            <a:r>
-              <a:t>(Simulador interactivo · 15 min)</a:t>
+              <a:rPr dirty="0"/>
+              <a:t>• El Error del </a:t>
+            </a:r>
+            <a:r>
+              <a:rPr dirty="0" err="1"/>
+              <a:t>Diagnóstico</a:t>
+            </a:r>
+            <a:r>
+              <a:rPr dirty="0"/>
+              <a:t> </a:t>
+            </a:r>
+            <a:r>
+              <a:rPr dirty="0" err="1"/>
+              <a:t>Exclusivo</a:t>
+            </a:r>
+            <a:r>
+              <a:rPr dirty="0"/>
+              <a:t>:</a:t>
+            </a:r>
+            <a:br>
+              <a:rPr dirty="0"/>
+            </a:br>
+            <a:r>
+              <a:rPr dirty="0" err="1"/>
+              <a:t>Tradicionalmente</a:t>
+            </a:r>
+            <a:r>
+              <a:rPr dirty="0"/>
+              <a:t> se </a:t>
+            </a:r>
+            <a:r>
+              <a:rPr dirty="0" err="1"/>
+              <a:t>atribuyó</a:t>
+            </a:r>
+            <a:r>
+              <a:rPr dirty="0"/>
+              <a:t> la crisis </a:t>
+            </a:r>
+            <a:r>
+              <a:rPr dirty="0" err="1"/>
+              <a:t>laboral</a:t>
+            </a:r>
+            <a:r>
+              <a:rPr dirty="0"/>
+              <a:t> </a:t>
+            </a:r>
+            <a:r>
+              <a:rPr dirty="0" err="1"/>
+              <a:t>española</a:t>
+            </a:r>
+            <a:r>
+              <a:rPr dirty="0"/>
+              <a:t> solo a la </a:t>
+            </a:r>
+            <a:r>
+              <a:rPr dirty="0" err="1"/>
+              <a:t>rigidez</a:t>
+            </a:r>
+            <a:r>
+              <a:rPr dirty="0"/>
+              <a:t> de </a:t>
+            </a:r>
+            <a:r>
+              <a:rPr dirty="0" err="1"/>
+              <a:t>los</a:t>
+            </a:r>
+            <a:r>
+              <a:rPr dirty="0"/>
+              <a:t> </a:t>
+            </a:r>
+            <a:r>
+              <a:rPr dirty="0" err="1"/>
+              <a:t>costes</a:t>
+            </a:r>
+            <a:r>
+              <a:rPr dirty="0"/>
+              <a:t> de </a:t>
+            </a:r>
+            <a:r>
+              <a:rPr dirty="0" err="1"/>
+              <a:t>despido</a:t>
+            </a:r>
+            <a:r>
+              <a:rPr dirty="0"/>
+              <a:t> o a la </a:t>
+            </a:r>
+            <a:r>
+              <a:rPr dirty="0" err="1"/>
+              <a:t>negociación</a:t>
+            </a:r>
+            <a:r>
+              <a:rPr dirty="0"/>
+              <a:t> </a:t>
+            </a:r>
+            <a:r>
+              <a:rPr dirty="0" err="1"/>
+              <a:t>colectiva</a:t>
+            </a:r>
+            <a:r>
+              <a:rPr dirty="0"/>
+              <a:t>.</a:t>
+            </a:r>
+            <a:br>
+              <a:rPr dirty="0"/>
+            </a:br>
+            <a:br>
+              <a:rPr dirty="0"/>
+            </a:br>
+            <a:r>
+              <a:rPr dirty="0"/>
+              <a:t>• La </a:t>
+            </a:r>
+            <a:r>
+              <a:rPr dirty="0" err="1"/>
+              <a:t>Importancia</a:t>
+            </a:r>
+            <a:r>
+              <a:rPr dirty="0"/>
+              <a:t> de la </a:t>
+            </a:r>
+            <a:r>
+              <a:rPr dirty="0" err="1"/>
+              <a:t>Intermediación</a:t>
+            </a:r>
+            <a:r>
+              <a:rPr dirty="0"/>
+              <a:t>:</a:t>
+            </a:r>
+            <a:br>
+              <a:rPr dirty="0"/>
+            </a:br>
+            <a:r>
+              <a:rPr lang="es-ES" dirty="0"/>
+              <a:t>Un</a:t>
+            </a:r>
+            <a:r>
+              <a:rPr dirty="0"/>
+              <a:t> </a:t>
+            </a:r>
+            <a:r>
+              <a:rPr dirty="0" err="1"/>
+              <a:t>estudio</a:t>
+            </a:r>
+            <a:r>
+              <a:rPr dirty="0"/>
+              <a:t> </a:t>
+            </a:r>
+            <a:r>
+              <a:rPr dirty="0" err="1"/>
+              <a:t>demostró</a:t>
+            </a:r>
+            <a:r>
+              <a:rPr dirty="0"/>
+              <a:t> </a:t>
+            </a:r>
+            <a:r>
+              <a:rPr dirty="0" err="1"/>
+              <a:t>que</a:t>
+            </a:r>
+            <a:r>
+              <a:rPr dirty="0"/>
+              <a:t> la </a:t>
+            </a:r>
+            <a:r>
+              <a:rPr dirty="0" err="1"/>
+              <a:t>ineficiencia</a:t>
+            </a:r>
+            <a:r>
+              <a:rPr dirty="0"/>
+              <a:t> </a:t>
+            </a:r>
+            <a:r>
+              <a:rPr dirty="0" err="1"/>
+              <a:t>en</a:t>
+            </a:r>
+            <a:r>
+              <a:rPr dirty="0"/>
+              <a:t> las </a:t>
+            </a:r>
+            <a:r>
+              <a:rPr dirty="0" err="1"/>
+              <a:t>políticas</a:t>
+            </a:r>
+            <a:r>
+              <a:rPr dirty="0"/>
+              <a:t> </a:t>
+            </a:r>
+            <a:r>
+              <a:rPr dirty="0" err="1"/>
+              <a:t>activas</a:t>
+            </a:r>
+            <a:r>
+              <a:rPr dirty="0"/>
+              <a:t> y </a:t>
+            </a:r>
+            <a:r>
+              <a:rPr dirty="0" err="1"/>
+              <a:t>los</a:t>
+            </a:r>
+            <a:r>
+              <a:rPr dirty="0"/>
+              <a:t> </a:t>
+            </a:r>
+            <a:r>
+              <a:rPr dirty="0" err="1"/>
+              <a:t>servicios</a:t>
+            </a:r>
+            <a:r>
+              <a:rPr dirty="0"/>
+              <a:t> </a:t>
+            </a:r>
+            <a:r>
+              <a:rPr dirty="0" err="1"/>
+              <a:t>públicos</a:t>
+            </a:r>
+            <a:r>
+              <a:rPr dirty="0"/>
+              <a:t> de </a:t>
+            </a:r>
+            <a:r>
+              <a:rPr dirty="0" err="1"/>
+              <a:t>empleo</a:t>
+            </a:r>
+            <a:r>
+              <a:rPr dirty="0"/>
+              <a:t> (SAE/SEPE) </a:t>
+            </a:r>
+            <a:r>
+              <a:rPr dirty="0" err="1"/>
+              <a:t>multiplicó</a:t>
+            </a:r>
+            <a:r>
+              <a:rPr dirty="0"/>
+              <a:t> la </a:t>
+            </a:r>
+            <a:r>
+              <a:rPr dirty="0" err="1"/>
+              <a:t>recesión</a:t>
+            </a:r>
+            <a:r>
+              <a:rPr dirty="0"/>
+              <a:t>.</a:t>
+            </a:r>
+            <a:br>
+              <a:rPr dirty="0"/>
+            </a:br>
+            <a:br>
+              <a:rPr dirty="0"/>
+            </a:br>
+            <a:r>
+              <a:rPr dirty="0"/>
+              <a:t>• </a:t>
+            </a:r>
+            <a:r>
+              <a:rPr dirty="0" err="1"/>
+              <a:t>Desafío</a:t>
+            </a:r>
+            <a:r>
+              <a:rPr dirty="0"/>
+              <a:t> </a:t>
+            </a:r>
+            <a:r>
+              <a:rPr dirty="0" err="1"/>
+              <a:t>Inmediato</a:t>
+            </a:r>
+            <a:r>
+              <a:rPr dirty="0"/>
+              <a:t>: </a:t>
+            </a:r>
+            <a:r>
+              <a:rPr dirty="0" err="1"/>
+              <a:t>Reducir</a:t>
+            </a:r>
+            <a:r>
+              <a:rPr dirty="0"/>
+              <a:t> la </a:t>
+            </a:r>
+            <a:r>
+              <a:rPr dirty="0" err="1"/>
+              <a:t>volatilidad</a:t>
+            </a:r>
+            <a:r>
+              <a:rPr dirty="0"/>
+              <a:t> </a:t>
+            </a:r>
+            <a:r>
+              <a:rPr dirty="0" err="1"/>
+              <a:t>estructural</a:t>
+            </a:r>
+            <a:r>
+              <a:rPr dirty="0"/>
+              <a:t> </a:t>
+            </a:r>
+            <a:r>
+              <a:rPr dirty="0" err="1"/>
+              <a:t>conectando</a:t>
+            </a:r>
+            <a:r>
+              <a:rPr dirty="0"/>
+              <a:t> </a:t>
+            </a:r>
+            <a:r>
+              <a:rPr dirty="0" err="1"/>
+              <a:t>educación</a:t>
+            </a:r>
+            <a:r>
+              <a:rPr dirty="0"/>
+              <a:t> y </a:t>
+            </a:r>
+            <a:r>
+              <a:rPr dirty="0" err="1"/>
+              <a:t>empresa</a:t>
+            </a:r>
+            <a:r>
+              <a:rPr dirty="0"/>
+              <a:t>.</a:t>
             </a:r>
           </a:p>
         </p:txBody>
@@ -5943,6 +6051,7 @@
               </a:defRPr>
             </a:pPr>
             <a:r>
+              <a:rPr dirty="0"/>
               <a:t>2. CLÁUSULA ANTI-SUSTITUCIÓN</a:t>
             </a:r>
           </a:p>
@@ -5956,26 +6065,224 @@
               </a:defRPr>
             </a:pPr>
             <a:r>
-              <a:t>• El Riesgo de Sustitución: Despedir o no renovar a un trabajador veterano para contratar a un parado subvencionado por la Junta.</a:t>
-            </a:r>
-            <a:br/>
-            <a:br/>
-            <a:r>
-              <a:t>• Solución Técnica de la Orden Emplea-T:</a:t>
-            </a:r>
-            <a:br/>
-            <a:r>
-              <a:t>  - Exigir incremento neto de la plantilla media de los 12 meses anteriores.</a:t>
-            </a:r>
-            <a:br/>
-            <a:r>
-              <a:t>  - Compromiso de mantenimiento del puesto subvencionado durante al menos 12 o 24 meses.</a:t>
-            </a:r>
-            <a:br/>
-            <a:br/>
-            <a:r>
-              <a:t>• Clave para EPD: Auditar el cumplimiento de estas cláusulas en los microdatos.</a:t>
-            </a:r>
+              <a:rPr dirty="0"/>
+              <a:t>• El Riesgo de </a:t>
+            </a:r>
+            <a:r>
+              <a:rPr dirty="0" err="1"/>
+              <a:t>Sustitución</a:t>
+            </a:r>
+            <a:r>
+              <a:rPr dirty="0"/>
+              <a:t>: </a:t>
+            </a:r>
+            <a:r>
+              <a:rPr dirty="0" err="1"/>
+              <a:t>Despedir</a:t>
+            </a:r>
+            <a:r>
+              <a:rPr dirty="0"/>
+              <a:t> o no </a:t>
+            </a:r>
+            <a:r>
+              <a:rPr dirty="0" err="1"/>
+              <a:t>renovar</a:t>
+            </a:r>
+            <a:r>
+              <a:rPr dirty="0"/>
+              <a:t> a un </a:t>
+            </a:r>
+            <a:r>
+              <a:rPr dirty="0" err="1"/>
+              <a:t>trabajador</a:t>
+            </a:r>
+            <a:r>
+              <a:rPr dirty="0"/>
+              <a:t> </a:t>
+            </a:r>
+            <a:r>
+              <a:rPr dirty="0" err="1"/>
+              <a:t>veterano</a:t>
+            </a:r>
+            <a:r>
+              <a:rPr dirty="0"/>
+              <a:t> para </a:t>
+            </a:r>
+            <a:r>
+              <a:rPr dirty="0" err="1"/>
+              <a:t>contratar</a:t>
+            </a:r>
+            <a:r>
+              <a:rPr dirty="0"/>
+              <a:t> a un </a:t>
+            </a:r>
+            <a:r>
+              <a:rPr dirty="0" err="1"/>
+              <a:t>parado</a:t>
+            </a:r>
+            <a:r>
+              <a:rPr dirty="0"/>
+              <a:t> </a:t>
+            </a:r>
+            <a:r>
+              <a:rPr dirty="0" err="1"/>
+              <a:t>subvencionado</a:t>
+            </a:r>
+            <a:r>
+              <a:rPr dirty="0"/>
+              <a:t> </a:t>
+            </a:r>
+            <a:r>
+              <a:rPr dirty="0" err="1"/>
+              <a:t>por</a:t>
+            </a:r>
+            <a:r>
+              <a:rPr dirty="0"/>
+              <a:t> la Junta.</a:t>
+            </a:r>
+            <a:br>
+              <a:rPr dirty="0"/>
+            </a:br>
+            <a:br>
+              <a:rPr dirty="0"/>
+            </a:br>
+            <a:r>
+              <a:rPr dirty="0"/>
+              <a:t>• </a:t>
+            </a:r>
+            <a:r>
+              <a:rPr dirty="0" err="1"/>
+              <a:t>Solución</a:t>
+            </a:r>
+            <a:r>
+              <a:rPr dirty="0"/>
+              <a:t> Técnica de la Orden </a:t>
+            </a:r>
+            <a:r>
+              <a:rPr dirty="0" err="1"/>
+              <a:t>Emplea</a:t>
+            </a:r>
+            <a:r>
+              <a:rPr dirty="0"/>
+              <a:t>-T:</a:t>
+            </a:r>
+            <a:br>
+              <a:rPr dirty="0"/>
+            </a:br>
+            <a:r>
+              <a:rPr dirty="0"/>
+              <a:t>  - </a:t>
+            </a:r>
+            <a:r>
+              <a:rPr dirty="0" err="1"/>
+              <a:t>Exigir</a:t>
+            </a:r>
+            <a:r>
+              <a:rPr dirty="0"/>
+              <a:t> </a:t>
+            </a:r>
+            <a:r>
+              <a:rPr dirty="0" err="1"/>
+              <a:t>incremento</a:t>
+            </a:r>
+            <a:r>
+              <a:rPr dirty="0"/>
+              <a:t> </a:t>
+            </a:r>
+            <a:r>
+              <a:rPr dirty="0" err="1"/>
+              <a:t>neto</a:t>
+            </a:r>
+            <a:r>
+              <a:rPr dirty="0"/>
+              <a:t> de la </a:t>
+            </a:r>
+            <a:r>
+              <a:rPr dirty="0" err="1"/>
+              <a:t>plantilla</a:t>
+            </a:r>
+            <a:r>
+              <a:rPr dirty="0"/>
+              <a:t> media de </a:t>
+            </a:r>
+            <a:r>
+              <a:rPr dirty="0" err="1"/>
+              <a:t>los</a:t>
+            </a:r>
+            <a:r>
+              <a:rPr dirty="0"/>
+              <a:t> 12 meses </a:t>
+            </a:r>
+            <a:r>
+              <a:rPr dirty="0" err="1"/>
+              <a:t>anteriores</a:t>
+            </a:r>
+            <a:r>
+              <a:rPr dirty="0"/>
+              <a:t>.</a:t>
+            </a:r>
+            <a:br>
+              <a:rPr dirty="0"/>
+            </a:br>
+            <a:r>
+              <a:rPr dirty="0"/>
+              <a:t>  - </a:t>
+            </a:r>
+            <a:r>
+              <a:rPr dirty="0" err="1"/>
+              <a:t>Compromiso</a:t>
+            </a:r>
+            <a:r>
+              <a:rPr dirty="0"/>
+              <a:t> de </a:t>
+            </a:r>
+            <a:r>
+              <a:rPr dirty="0" err="1"/>
+              <a:t>mantenimiento</a:t>
+            </a:r>
+            <a:r>
+              <a:rPr dirty="0"/>
+              <a:t> del </a:t>
+            </a:r>
+            <a:r>
+              <a:rPr dirty="0" err="1"/>
+              <a:t>puesto</a:t>
+            </a:r>
+            <a:r>
+              <a:rPr dirty="0"/>
+              <a:t> </a:t>
+            </a:r>
+            <a:r>
+              <a:rPr dirty="0" err="1"/>
+              <a:t>subvencionado</a:t>
+            </a:r>
+            <a:r>
+              <a:rPr dirty="0"/>
+              <a:t> </a:t>
+            </a:r>
+            <a:r>
+              <a:rPr dirty="0" err="1"/>
+              <a:t>durante</a:t>
+            </a:r>
+            <a:r>
+              <a:rPr dirty="0"/>
+              <a:t> al </a:t>
+            </a:r>
+            <a:r>
+              <a:rPr dirty="0" err="1"/>
+              <a:t>menos</a:t>
+            </a:r>
+            <a:r>
+              <a:rPr dirty="0"/>
+              <a:t> 12 o 24 meses.</a:t>
+            </a:r>
+            <a:br>
+              <a:rPr dirty="0"/>
+            </a:br>
+            <a:br>
+              <a:rPr dirty="0"/>
+            </a:br>
+            <a:endParaRPr dirty="0"/>
           </a:p>
         </p:txBody>
       </p:sp>
@@ -6650,173 +6957,296 @@
           </a:p>
         </p:txBody>
       </p:sp>
-      <p:sp>
-        <p:nvSpPr>
-          <p:cNvPr id="8" name="Rounded Rectangle 7"/>
-          <p:cNvSpPr/>
-          <p:nvPr/>
-        </p:nvSpPr>
-        <p:spPr>
-          <a:xfrm>
-            <a:off x="548640" y="1645920"/>
-            <a:ext cx="5394960" cy="4389120"/>
-          </a:xfrm>
-          <a:prstGeom prst="roundRect">
-            <a:avLst/>
-          </a:prstGeom>
-          <a:solidFill>
-            <a:srgbClr val="FFFFFF"/>
-          </a:solidFill>
-          <a:ln w="19050">
-            <a:solidFill>
-              <a:srgbClr val="DCE5DF"/>
-            </a:solidFill>
-          </a:ln>
-        </p:spPr>
-        <p:style>
-          <a:lnRef idx="1">
-            <a:schemeClr val="accent1"/>
-          </a:lnRef>
-          <a:fillRef idx="3">
-            <a:schemeClr val="accent1"/>
-          </a:fillRef>
-          <a:effectRef idx="2">
-            <a:schemeClr val="accent1"/>
-          </a:effectRef>
-          <a:fontRef idx="minor">
-            <a:schemeClr val="lt1"/>
-          </a:fontRef>
-        </p:style>
-        <p:txBody>
-          <a:bodyPr wrap="square" lIns="228600" tIns="201168" rIns="228600" rtlCol="0" anchor="ctr"/>
-          <a:lstStyle/>
-          <a:p>
-            <a:pPr algn="ctr">
-              <a:spcAft>
-                <a:spcPts val="1000"/>
-              </a:spcAft>
-              <a:defRPr sz="1500" b="1">
-                <a:solidFill>
-                  <a:srgbClr val="113927"/>
-                </a:solidFill>
-                <a:latin typeface="Outfit"/>
-              </a:defRPr>
-            </a:pPr>
-            <a:r>
-              <a:t>PREGUNTA 1 · CONCEPTUAL (500 PTS)</a:t>
-            </a:r>
-          </a:p>
-          <a:p>
-            <a:pPr>
-              <a:defRPr sz="1600">
-                <a:solidFill>
-                  <a:srgbClr val="2F3A30"/>
-                </a:solidFill>
-                <a:latin typeface="Calibri"/>
-              </a:defRPr>
-            </a:pPr>
-            <a:r>
-              <a:t>A partir de la condición de flujo estacionario y la función de emparejamiento m = A·U^α·V^(1-α):</a:t>
-            </a:r>
-            <a:br/>
-            <a:br/>
-            <a:r>
-              <a:t>a) Demuestre analíticamente por qué la tasa natural de desempleo de equilibrio a largo plazo es u* = s / (s + f) y defina con precisión las variables s y f.</a:t>
-            </a:r>
-            <a:br/>
-            <a:br/>
-            <a:r>
-              <a:t>b) Utilizando el marco de la Curva de Beveridge, distinga conceptualmente entre un movimiento a lo largo de la curva y un desplazamiento hacia el exterior, indicando qué variables provocan cada uno.</a:t>
-            </a:r>
-          </a:p>
-        </p:txBody>
-      </p:sp>
-      <p:sp>
-        <p:nvSpPr>
-          <p:cNvPr id="9" name="Rounded Rectangle 8"/>
-          <p:cNvSpPr/>
-          <p:nvPr/>
-        </p:nvSpPr>
-        <p:spPr>
-          <a:xfrm>
-            <a:off x="6217920" y="1645920"/>
-            <a:ext cx="5394960" cy="4389120"/>
-          </a:xfrm>
-          <a:prstGeom prst="roundRect">
-            <a:avLst/>
-          </a:prstGeom>
-          <a:solidFill>
-            <a:srgbClr val="FFFFFF"/>
-          </a:solidFill>
-          <a:ln w="19050">
-            <a:solidFill>
-              <a:srgbClr val="E98F71"/>
-            </a:solidFill>
-          </a:ln>
-        </p:spPr>
-        <p:style>
-          <a:lnRef idx="1">
-            <a:schemeClr val="accent1"/>
-          </a:lnRef>
-          <a:fillRef idx="3">
-            <a:schemeClr val="accent1"/>
-          </a:fillRef>
-          <a:effectRef idx="2">
-            <a:schemeClr val="accent1"/>
-          </a:effectRef>
-          <a:fontRef idx="minor">
-            <a:schemeClr val="lt1"/>
-          </a:fontRef>
-        </p:style>
-        <p:txBody>
-          <a:bodyPr wrap="square" lIns="228600" tIns="201168" rIns="228600" rtlCol="0" anchor="ctr"/>
-          <a:lstStyle/>
-          <a:p>
-            <a:pPr algn="ctr">
-              <a:spcAft>
-                <a:spcPts val="1000"/>
-              </a:spcAft>
-              <a:defRPr sz="1500" b="1">
-                <a:solidFill>
-                  <a:srgbClr val="113927"/>
-                </a:solidFill>
-                <a:latin typeface="Outfit"/>
-              </a:defRPr>
-            </a:pPr>
-            <a:r>
-              <a:t>PREGUNTA 2 · APLICADA (500 PTS)</a:t>
-            </a:r>
-          </a:p>
-          <a:p>
-            <a:pPr>
-              <a:defRPr sz="1600">
-                <a:solidFill>
-                  <a:srgbClr val="2F3A30"/>
-                </a:solidFill>
-                <a:latin typeface="Calibri"/>
-              </a:defRPr>
-            </a:pPr>
-            <a:r>
-              <a:t>En España coexisten 155.000 vacantes sin cubrir (v ≈ 0,75%) y una tasa de paro del 11,3%:</a:t>
-            </a:r>
-            <a:br/>
-            <a:br/>
-            <a:r>
-              <a:t>a) Represente gráficamente la situación en el plano (U,V), sitúe la posición respecto a la bisectriz y determine si el problema es cíclico o estructural.</a:t>
-            </a:r>
-            <a:br/>
-            <a:br/>
-            <a:r>
-              <a:t>b) Si el gobierno inyecta 10.000 M€ en estímulos fiscales de consumo creyendo que el paro es puramente cíclico: ¿qué ocurrirá con vacantes, paro e inflación?</a:t>
-            </a:r>
-            <a:br/>
-            <a:br/>
-            <a:r>
-              <a:t>c) En el Programa Emplea-T, proponga medidas que eleven A y explique cómo evitar el peso muerto (deadweight).</a:t>
-            </a:r>
-          </a:p>
-        </p:txBody>
-      </p:sp>
+      <mc:AlternateContent xmlns:mc="http://schemas.openxmlformats.org/markup-compatibility/2006" xmlns:a14="http://schemas.microsoft.com/office/drawing/2010/main">
+        <mc:Choice Requires="a14">
+          <p:sp>
+            <p:nvSpPr>
+              <p:cNvPr id="8" name="Rounded Rectangle 7"/>
+              <p:cNvSpPr/>
+              <p:nvPr/>
+            </p:nvSpPr>
+            <p:spPr>
+              <a:xfrm>
+                <a:off x="548639" y="1645920"/>
+                <a:ext cx="10761617" cy="4389120"/>
+              </a:xfrm>
+              <a:prstGeom prst="roundRect">
+                <a:avLst/>
+              </a:prstGeom>
+              <a:solidFill>
+                <a:srgbClr val="FFFFFF"/>
+              </a:solidFill>
+              <a:ln w="19050">
+                <a:solidFill>
+                  <a:srgbClr val="DCE5DF"/>
+                </a:solidFill>
+              </a:ln>
+            </p:spPr>
+            <p:style>
+              <a:lnRef idx="1">
+                <a:schemeClr val="accent1"/>
+              </a:lnRef>
+              <a:fillRef idx="3">
+                <a:schemeClr val="accent1"/>
+              </a:fillRef>
+              <a:effectRef idx="2">
+                <a:schemeClr val="accent1"/>
+              </a:effectRef>
+              <a:fontRef idx="minor">
+                <a:schemeClr val="lt1"/>
+              </a:fontRef>
+            </p:style>
+            <p:txBody>
+              <a:bodyPr wrap="square" lIns="228600" tIns="201168" rIns="228600" rtlCol="0" anchor="ctr"/>
+              <a:lstStyle/>
+              <a:p>
+                <a:pPr>
+                  <a:defRPr sz="1600">
+                    <a:solidFill>
+                      <a:srgbClr val="2F3A30"/>
+                    </a:solidFill>
+                    <a:latin typeface="Calibri"/>
+                  </a:defRPr>
+                </a:pPr>
+                <a:r>
+                  <a:rPr sz="2400" dirty="0"/>
+                  <a:t>A </a:t>
+                </a:r>
+                <a:r>
+                  <a:rPr sz="2400" dirty="0" err="1"/>
+                  <a:t>partir</a:t>
+                </a:r>
+                <a:r>
+                  <a:rPr sz="2400" dirty="0"/>
+                  <a:t> de la </a:t>
+                </a:r>
+                <a:r>
+                  <a:rPr sz="2400" dirty="0" err="1"/>
+                  <a:t>condición</a:t>
+                </a:r>
+                <a:r>
+                  <a:rPr sz="2400" dirty="0"/>
+                  <a:t> de </a:t>
+                </a:r>
+                <a:r>
+                  <a:rPr sz="2400" dirty="0" err="1"/>
+                  <a:t>flujo</a:t>
+                </a:r>
+                <a:r>
+                  <a:rPr sz="2400" dirty="0"/>
+                  <a:t> </a:t>
+                </a:r>
+                <a:r>
+                  <a:rPr sz="2400" dirty="0" err="1"/>
+                  <a:t>estacionario</a:t>
+                </a:r>
+                <a:r>
+                  <a:rPr sz="2400" dirty="0"/>
+                  <a:t> y la </a:t>
+                </a:r>
+                <a:r>
+                  <a:rPr sz="2400" dirty="0" err="1"/>
+                  <a:t>función</a:t>
+                </a:r>
+                <a:r>
+                  <a:rPr sz="2400" dirty="0"/>
+                  <a:t> de </a:t>
+                </a:r>
+                <a:r>
+                  <a:rPr sz="2400" dirty="0" err="1"/>
+                  <a:t>emparejamiento</a:t>
+                </a:r>
+                <a:r>
+                  <a:rPr sz="2400" dirty="0"/>
+                  <a:t> </a:t>
+                </a:r>
+                <a:br>
+                  <a:rPr lang="es-ES" sz="2400" i="1" dirty="0">
+                    <a:latin typeface="Cambria Math" panose="02040503050406030204" pitchFamily="18" charset="0"/>
+                  </a:rPr>
+                </a:br>
+                <a:r>
+                  <a:rPr sz="2400" dirty="0"/>
+                  <a:t>a) </a:t>
+                </a:r>
+                <a:r>
+                  <a:rPr lang="es-ES" sz="2400" dirty="0"/>
+                  <a:t>Explique qué significa la expresión </a:t>
+                </a:r>
+                <a:r>
+                  <a:rPr sz="2400" dirty="0"/>
+                  <a:t>u* = s / (s + f) y </a:t>
+                </a:r>
+                <a:r>
+                  <a:rPr sz="2400" dirty="0" err="1"/>
+                  <a:t>defina</a:t>
+                </a:r>
+                <a:r>
+                  <a:rPr sz="2400" dirty="0"/>
+                  <a:t> con </a:t>
+                </a:r>
+                <a:r>
+                  <a:rPr sz="2400" dirty="0" err="1"/>
+                  <a:t>precisión</a:t>
+                </a:r>
+                <a:r>
+                  <a:rPr sz="2400" dirty="0"/>
+                  <a:t> </a:t>
+                </a:r>
+                <a:r>
+                  <a:rPr lang="es-ES" sz="2400" dirty="0"/>
+                  <a:t>qué nos cuentan</a:t>
+                </a:r>
+                <a:r>
+                  <a:rPr sz="2400" dirty="0"/>
+                  <a:t> s y f.</a:t>
+                </a:r>
+                <a:br>
+                  <a:rPr sz="2400" dirty="0"/>
+                </a:br>
+                <a:br>
+                  <a:rPr sz="2400" dirty="0"/>
+                </a:br>
+                <a:r>
+                  <a:rPr sz="2400" dirty="0"/>
+                  <a:t>b) </a:t>
+                </a:r>
+                <a:r>
+                  <a:rPr sz="2400" dirty="0" err="1"/>
+                  <a:t>Utilizando</a:t>
+                </a:r>
+                <a:r>
+                  <a:rPr sz="2400" dirty="0"/>
+                  <a:t> el </a:t>
+                </a:r>
+                <a:r>
+                  <a:rPr sz="2400" dirty="0" err="1"/>
+                  <a:t>marco</a:t>
+                </a:r>
+                <a:r>
+                  <a:rPr sz="2400" dirty="0"/>
+                  <a:t> de la Curva de Beveridge, </a:t>
+                </a:r>
+                <a:r>
+                  <a:rPr sz="2400" dirty="0" err="1"/>
+                  <a:t>distinga</a:t>
+                </a:r>
+                <a:r>
+                  <a:rPr sz="2400" dirty="0"/>
+                  <a:t> </a:t>
+                </a:r>
+                <a:r>
+                  <a:rPr sz="2400" dirty="0" err="1"/>
+                  <a:t>conceptualmente</a:t>
+                </a:r>
+                <a:r>
+                  <a:rPr sz="2400" dirty="0"/>
+                  <a:t> entre un </a:t>
+                </a:r>
+                <a:r>
+                  <a:rPr sz="2400" dirty="0" err="1"/>
+                  <a:t>movimiento</a:t>
+                </a:r>
+                <a:r>
+                  <a:rPr sz="2400" dirty="0"/>
+                  <a:t> a lo largo de la curva y un </a:t>
+                </a:r>
+                <a:r>
+                  <a:rPr sz="2400" dirty="0" err="1"/>
+                  <a:t>desplazamiento</a:t>
+                </a:r>
+                <a:r>
+                  <a:rPr sz="2400" dirty="0"/>
+                  <a:t> </a:t>
+                </a:r>
+                <a:r>
+                  <a:rPr sz="2400" dirty="0" err="1"/>
+                  <a:t>hacia</a:t>
+                </a:r>
+                <a:r>
+                  <a:rPr sz="2400" dirty="0"/>
+                  <a:t> el exterior, </a:t>
+                </a:r>
+                <a:r>
+                  <a:rPr sz="2400" dirty="0" err="1"/>
+                  <a:t>indicando</a:t>
+                </a:r>
+                <a:r>
+                  <a:rPr sz="2400" dirty="0"/>
+                  <a:t> </a:t>
+                </a:r>
+                <a:r>
+                  <a:rPr sz="2400" dirty="0" err="1"/>
+                  <a:t>qué</a:t>
+                </a:r>
+                <a:r>
+                  <a:rPr sz="2400" dirty="0"/>
+                  <a:t> variables </a:t>
+                </a:r>
+                <a:r>
+                  <a:rPr sz="2400" dirty="0" err="1"/>
+                  <a:t>provocan</a:t>
+                </a:r>
+                <a:r>
+                  <a:rPr sz="2400" dirty="0"/>
+                  <a:t> </a:t>
+                </a:r>
+                <a:r>
+                  <a:rPr sz="2400" dirty="0" err="1"/>
+                  <a:t>cada</a:t>
+                </a:r>
+                <a:r>
+                  <a:rPr sz="2400" dirty="0"/>
+                  <a:t> uno.</a:t>
+                </a:r>
+              </a:p>
+            </p:txBody>
+          </p:sp>
+        </mc:Choice>
+        <mc:Fallback xmlns="">
+          <p:sp>
+            <p:nvSpPr>
+              <p:cNvPr id="8" name="Rounded Rectangle 7"/>
+              <p:cNvSpPr>
+                <a:spLocks noRot="1" noChangeAspect="1" noMove="1" noResize="1" noEditPoints="1" noAdjustHandles="1" noChangeArrowheads="1" noChangeShapeType="1" noTextEdit="1"/>
+              </p:cNvSpPr>
+              <p:nvPr/>
+            </p:nvSpPr>
+            <p:spPr>
+              <a:xfrm>
+                <a:off x="548639" y="1645920"/>
+                <a:ext cx="10761617" cy="4389120"/>
+              </a:xfrm>
+              <a:prstGeom prst="roundRect">
+                <a:avLst/>
+              </a:prstGeom>
+              <a:blipFill>
+                <a:blip r:embed="rId3"/>
+                <a:stretch>
+                  <a:fillRect/>
+                </a:stretch>
+              </a:blipFill>
+              <a:ln w="19050">
+                <a:solidFill>
+                  <a:srgbClr val="DCE5DF"/>
+                </a:solidFill>
+              </a:ln>
+            </p:spPr>
+            <p:txBody>
+              <a:bodyPr/>
+              <a:lstStyle/>
+              <a:p>
+                <a:r>
+                  <a:rPr lang="es-ES">
+                    <a:noFill/>
+                  </a:rPr>
+                  <a:t> </a:t>
+                </a:r>
+              </a:p>
+            </p:txBody>
+          </p:sp>
+        </mc:Fallback>
+      </mc:AlternateContent>
     </p:spTree>
   </p:cSld>
   <p:clrMapOvr>
@@ -8163,6 +8593,7 @@
               </a:defRPr>
             </a:pPr>
             <a:r>
+              <a:rPr dirty="0"/>
               <a:t>TITULAR ECONÓMICO REAL · EXPANSIÓN / CINCO DÍAS</a:t>
             </a:r>
           </a:p>
@@ -8179,7 +8610,144 @@
               </a:defRPr>
             </a:pPr>
             <a:r>
-              <a:t>«Las empresas declaran más de 155.000 vacantes sin cubrir mientras el desempleo supera los 2,6 millones: hostelería, construcción, transporte y tecnología alertan de un bloqueo estructural»</a:t>
+              <a:rPr dirty="0"/>
+              <a:t>«Las </a:t>
+            </a:r>
+            <a:r>
+              <a:rPr dirty="0" err="1"/>
+              <a:t>empresas</a:t>
+            </a:r>
+            <a:r>
+              <a:rPr dirty="0"/>
+              <a:t> </a:t>
+            </a:r>
+            <a:r>
+              <a:rPr dirty="0" err="1"/>
+              <a:t>declaran</a:t>
+            </a:r>
+            <a:r>
+              <a:rPr dirty="0"/>
+              <a:t> </a:t>
+            </a:r>
+            <a:r>
+              <a:rPr dirty="0" err="1"/>
+              <a:t>más</a:t>
+            </a:r>
+            <a:r>
+              <a:rPr dirty="0"/>
+              <a:t> de 155.000 </a:t>
+            </a:r>
+            <a:r>
+              <a:rPr dirty="0" err="1"/>
+              <a:t>vacantes</a:t>
+            </a:r>
+            <a:r>
+              <a:rPr dirty="0"/>
+              <a:t> sin </a:t>
+            </a:r>
+            <a:r>
+              <a:rPr dirty="0" err="1"/>
+              <a:t>cubrir</a:t>
+            </a:r>
+            <a:r>
+              <a:rPr dirty="0"/>
+              <a:t> </a:t>
+            </a:r>
+            <a:r>
+              <a:rPr dirty="0" err="1"/>
+              <a:t>mientras</a:t>
+            </a:r>
+            <a:r>
+              <a:rPr dirty="0"/>
+              <a:t> el </a:t>
+            </a:r>
+            <a:r>
+              <a:rPr dirty="0" err="1"/>
+              <a:t>desempleo</a:t>
+            </a:r>
+            <a:r>
+              <a:rPr dirty="0"/>
+              <a:t> </a:t>
+            </a:r>
+            <a:r>
+              <a:rPr dirty="0" err="1"/>
+              <a:t>supera</a:t>
+            </a:r>
+            <a:r>
+              <a:rPr dirty="0"/>
+              <a:t> </a:t>
+            </a:r>
+            <a:r>
+              <a:rPr dirty="0" err="1"/>
+              <a:t>los</a:t>
+            </a:r>
+            <a:r>
+              <a:rPr dirty="0"/>
+              <a:t> 2,6 </a:t>
+            </a:r>
+            <a:r>
+              <a:rPr dirty="0" err="1"/>
+              <a:t>millones</a:t>
+            </a:r>
+            <a:r>
+              <a:rPr dirty="0"/>
+              <a:t>: </a:t>
+            </a:r>
+            <a:r>
+              <a:rPr dirty="0" err="1"/>
+              <a:t>hostelería</a:t>
+            </a:r>
+            <a:r>
+              <a:rPr dirty="0"/>
+              <a:t>, </a:t>
+            </a:r>
+            <a:r>
+              <a:rPr dirty="0" err="1"/>
+              <a:t>construcción</a:t>
+            </a:r>
+            <a:r>
+              <a:rPr dirty="0"/>
+              <a:t>, </a:t>
+            </a:r>
+            <a:r>
+              <a:rPr dirty="0" err="1"/>
+              <a:t>transporte</a:t>
+            </a:r>
+            <a:r>
+              <a:rPr dirty="0"/>
+              <a:t> y </a:t>
+            </a:r>
+            <a:r>
+              <a:rPr dirty="0" err="1"/>
+              <a:t>tecnología</a:t>
+            </a:r>
+            <a:r>
+              <a:rPr dirty="0"/>
+              <a:t> </a:t>
+            </a:r>
+            <a:r>
+              <a:rPr dirty="0" err="1"/>
+              <a:t>alertan</a:t>
+            </a:r>
+            <a:r>
+              <a:rPr dirty="0"/>
+              <a:t> de un </a:t>
+            </a:r>
+            <a:r>
+              <a:rPr dirty="0" err="1"/>
+              <a:t>bloqueo</a:t>
+            </a:r>
+            <a:r>
+              <a:rPr dirty="0"/>
+              <a:t> </a:t>
+            </a:r>
+            <a:r>
+              <a:rPr dirty="0" err="1"/>
+              <a:t>estructural</a:t>
+            </a:r>
+            <a:r>
+              <a:rPr dirty="0"/>
+              <a:t>»</a:t>
             </a:r>
           </a:p>
           <a:p>
@@ -8192,12 +8760,234 @@
               </a:defRPr>
             </a:pPr>
             <a:r>
-              <a:t>• Choque Empírico: España encabeza el desempleo en la Unión Europea (11,3% frente al 6,0% de media comunitaria), pero paralelamente registra el récord histórico de puestos de trabajo vacantes (INE-ETCL).</a:t>
-            </a:r>
-            <a:br/>
-            <a:br/>
-            <a:r>
-              <a:t>• El Enigma Técnico: Si el modelo competitivo básico asume que el mercado se vacía con el salario, ¿por qué no se cubren las vacantes? ¿Falta demanda o falla el emparejamiento?</a:t>
+              <a:rPr dirty="0"/>
+              <a:t>• Choque </a:t>
+            </a:r>
+            <a:r>
+              <a:rPr dirty="0" err="1"/>
+              <a:t>Empírico</a:t>
+            </a:r>
+            <a:r>
+              <a:rPr dirty="0"/>
+              <a:t>: España </a:t>
+            </a:r>
+            <a:r>
+              <a:rPr dirty="0" err="1"/>
+              <a:t>encabeza</a:t>
+            </a:r>
+            <a:r>
+              <a:rPr dirty="0"/>
+              <a:t> el </a:t>
+            </a:r>
+            <a:r>
+              <a:rPr dirty="0" err="1"/>
+              <a:t>desempleo</a:t>
+            </a:r>
+            <a:r>
+              <a:rPr dirty="0"/>
+              <a:t> </a:t>
+            </a:r>
+            <a:r>
+              <a:rPr dirty="0" err="1"/>
+              <a:t>en</a:t>
+            </a:r>
+            <a:r>
+              <a:rPr dirty="0"/>
+              <a:t> la Unión Europea (11,3% </a:t>
+            </a:r>
+            <a:r>
+              <a:rPr dirty="0" err="1"/>
+              <a:t>frente</a:t>
+            </a:r>
+            <a:r>
+              <a:rPr dirty="0"/>
+              <a:t> al 6,0% de media </a:t>
+            </a:r>
+            <a:r>
+              <a:rPr dirty="0" err="1"/>
+              <a:t>comunitaria</a:t>
+            </a:r>
+            <a:r>
+              <a:rPr dirty="0"/>
+              <a:t>), </a:t>
+            </a:r>
+            <a:r>
+              <a:rPr dirty="0" err="1"/>
+              <a:t>pero</a:t>
+            </a:r>
+            <a:r>
+              <a:rPr dirty="0"/>
+              <a:t> </a:t>
+            </a:r>
+            <a:r>
+              <a:rPr dirty="0" err="1"/>
+              <a:t>paralelamente</a:t>
+            </a:r>
+            <a:r>
+              <a:rPr dirty="0"/>
+              <a:t> </a:t>
+            </a:r>
+            <a:r>
+              <a:rPr dirty="0" err="1"/>
+              <a:t>registra</a:t>
+            </a:r>
+            <a:r>
+              <a:rPr dirty="0"/>
+              <a:t> el </a:t>
+            </a:r>
+            <a:r>
+              <a:rPr dirty="0" err="1"/>
+              <a:t>récord</a:t>
+            </a:r>
+            <a:r>
+              <a:rPr dirty="0"/>
+              <a:t> histórico de </a:t>
+            </a:r>
+            <a:r>
+              <a:rPr dirty="0" err="1"/>
+              <a:t>puestos</a:t>
+            </a:r>
+            <a:r>
+              <a:rPr dirty="0"/>
+              <a:t> de </a:t>
+            </a:r>
+            <a:r>
+              <a:rPr dirty="0" err="1"/>
+              <a:t>trabajo</a:t>
+            </a:r>
+            <a:r>
+              <a:rPr dirty="0"/>
+              <a:t> </a:t>
+            </a:r>
+            <a:r>
+              <a:rPr dirty="0" err="1"/>
+              <a:t>vacantes</a:t>
+            </a:r>
+            <a:r>
+              <a:rPr dirty="0"/>
+              <a:t> (INE-ETCL).</a:t>
+            </a:r>
+            <a:br>
+              <a:rPr dirty="0"/>
+            </a:br>
+            <a:br>
+              <a:rPr dirty="0"/>
+            </a:br>
+            <a:r>
+              <a:rPr dirty="0"/>
+              <a:t>• El Enigma Técnico: Si el </a:t>
+            </a:r>
+            <a:r>
+              <a:rPr dirty="0" err="1"/>
+              <a:t>modelo</a:t>
+            </a:r>
+            <a:r>
+              <a:rPr dirty="0"/>
+              <a:t> </a:t>
+            </a:r>
+            <a:r>
+              <a:rPr dirty="0" err="1"/>
+              <a:t>competitivo</a:t>
+            </a:r>
+            <a:r>
+              <a:rPr dirty="0"/>
+              <a:t> </a:t>
+            </a:r>
+            <a:r>
+              <a:rPr dirty="0" err="1"/>
+              <a:t>básico</a:t>
+            </a:r>
+            <a:r>
+              <a:rPr dirty="0"/>
+              <a:t> </a:t>
+            </a:r>
+            <a:r>
+              <a:rPr dirty="0" err="1"/>
+              <a:t>asume</a:t>
+            </a:r>
+            <a:r>
+              <a:rPr dirty="0"/>
+              <a:t> </a:t>
+            </a:r>
+            <a:r>
+              <a:rPr dirty="0" err="1"/>
+              <a:t>que</a:t>
+            </a:r>
+            <a:r>
+              <a:rPr dirty="0"/>
+              <a:t> el mercado se </a:t>
+            </a:r>
+            <a:r>
+              <a:rPr dirty="0" err="1"/>
+              <a:t>vacía</a:t>
+            </a:r>
+            <a:r>
+              <a:rPr dirty="0"/>
+              <a:t> con el </a:t>
+            </a:r>
+            <a:r>
+              <a:rPr dirty="0" err="1"/>
+              <a:t>salario</a:t>
+            </a:r>
+            <a:r>
+              <a:rPr dirty="0"/>
+              <a:t>, ¿</a:t>
+            </a:r>
+            <a:r>
+              <a:rPr dirty="0" err="1"/>
+              <a:t>por</a:t>
+            </a:r>
+            <a:r>
+              <a:rPr dirty="0"/>
+              <a:t> </a:t>
+            </a:r>
+            <a:r>
+              <a:rPr dirty="0" err="1"/>
+              <a:t>qué</a:t>
+            </a:r>
+            <a:r>
+              <a:rPr dirty="0"/>
+              <a:t> no se </a:t>
+            </a:r>
+            <a:r>
+              <a:rPr dirty="0" err="1"/>
+              <a:t>cubren</a:t>
+            </a:r>
+            <a:r>
+              <a:rPr dirty="0"/>
+              <a:t> las </a:t>
+            </a:r>
+            <a:r>
+              <a:rPr dirty="0" err="1"/>
+              <a:t>vacantes</a:t>
+            </a:r>
+            <a:r>
+              <a:rPr dirty="0"/>
+              <a:t>? ¿Falta </a:t>
+            </a:r>
+            <a:r>
+              <a:rPr dirty="0" err="1"/>
+              <a:t>demanda</a:t>
+            </a:r>
+            <a:r>
+              <a:rPr dirty="0"/>
+              <a:t> o </a:t>
+            </a:r>
+            <a:r>
+              <a:rPr dirty="0" err="1"/>
+              <a:t>falla</a:t>
+            </a:r>
+            <a:r>
+              <a:rPr dirty="0"/>
+              <a:t> el </a:t>
+            </a:r>
+            <a:r>
+              <a:rPr dirty="0" err="1"/>
+              <a:t>emparejamiento</a:t>
+            </a:r>
+            <a:r>
+              <a:rPr dirty="0"/>
+              <a:t>?</a:t>
             </a:r>
           </a:p>
         </p:txBody>
@@ -8254,31 +9044,59 @@
                 <a:latin typeface="Outfit"/>
               </a:defRPr>
             </a:pPr>
-            <a:r>
-              <a:t>SONDEO EN VIVO · FORMS INSTITUCIONAL</a:t>
-            </a:r>
-          </a:p>
+            <a:endParaRPr dirty="0"/>
+          </a:p>
+        </p:txBody>
+      </p:sp>
+      <p:sp>
+        <p:nvSpPr>
+          <p:cNvPr id="11" name="TextBox 10"/>
+          <p:cNvSpPr txBox="1"/>
+          <p:nvPr/>
+        </p:nvSpPr>
+        <p:spPr>
+          <a:xfrm>
+            <a:off x="7772400" y="5166360"/>
+            <a:ext cx="3749039" cy="731520"/>
+          </a:xfrm>
+          <a:prstGeom prst="rect">
+            <a:avLst/>
+          </a:prstGeom>
+          <a:noFill/>
+        </p:spPr>
+        <p:txBody>
+          <a:bodyPr wrap="none">
+            <a:spAutoFit/>
+          </a:bodyPr>
+          <a:lstStyle/>
           <a:p>
             <a:pPr algn="ctr">
-              <a:spcAft>
-                <a:spcPts val="1000"/>
-              </a:spcAft>
-              <a:defRPr sz="1500" b="1">
-                <a:solidFill>
-                  <a:srgbClr val="E98F71"/>
-                </a:solidFill>
-                <a:latin typeface="Outfit"/>
-              </a:defRPr>
-            </a:pPr>
-            <a:r>
-              <a:t>¿Cuál es la causa principal del bloqueo?</a:t>
+              <a:defRPr sz="1300">
+                <a:solidFill>
+                  <a:srgbClr val="2F3A30"/>
+                </a:solidFill>
+                <a:latin typeface="Calibri"/>
+              </a:defRPr>
+            </a:pPr>
+            <a:r>
+              <a:t>Escanea con tu móvil (@alu.upo.es)</a:t>
+            </a:r>
+            <a:br/>
+            <a:r>
+              <a:t>4 hipótesis a debate en clase</a:t>
             </a:r>
           </a:p>
         </p:txBody>
       </p:sp>
       <p:pic>
         <p:nvPicPr>
-          <p:cNvPr id="10" name="Picture 9" descr="qr_sondeo_sesion05.png"/>
+          <p:cNvPr id="12" name="Imagen 11" descr="Código QR">
+            <a:extLst>
+              <a:ext uri="{FF2B5EF4-FFF2-40B4-BE49-F238E27FC236}">
+                <a16:creationId xmlns:a16="http://schemas.microsoft.com/office/drawing/2014/main" id="{94E4042F-AD31-C0B7-6E1A-DD42A06CA96E}"/>
+              </a:ext>
+            </a:extLst>
+          </p:cNvPr>
           <p:cNvPicPr>
             <a:picLocks noChangeAspect="1"/>
           </p:cNvPicPr>
@@ -8292,54 +9110,14 @@
         </p:blipFill>
         <p:spPr>
           <a:xfrm>
-            <a:off x="8412480" y="2560320"/>
-            <a:ext cx="2468880" cy="2468880"/>
+            <a:off x="8270748" y="2052828"/>
+            <a:ext cx="2843784" cy="2843784"/>
           </a:xfrm>
           <a:prstGeom prst="rect">
             <a:avLst/>
           </a:prstGeom>
         </p:spPr>
       </p:pic>
-      <p:sp>
-        <p:nvSpPr>
-          <p:cNvPr id="11" name="TextBox 10"/>
-          <p:cNvSpPr txBox="1"/>
-          <p:nvPr/>
-        </p:nvSpPr>
-        <p:spPr>
-          <a:xfrm>
-            <a:off x="7772400" y="5166360"/>
-            <a:ext cx="3749039" cy="731520"/>
-          </a:xfrm>
-          <a:prstGeom prst="rect">
-            <a:avLst/>
-          </a:prstGeom>
-          <a:noFill/>
-        </p:spPr>
-        <p:txBody>
-          <a:bodyPr wrap="none">
-            <a:spAutoFit/>
-          </a:bodyPr>
-          <a:lstStyle/>
-          <a:p>
-            <a:pPr algn="ctr">
-              <a:defRPr sz="1300">
-                <a:solidFill>
-                  <a:srgbClr val="2F3A30"/>
-                </a:solidFill>
-                <a:latin typeface="Calibri"/>
-              </a:defRPr>
-            </a:pPr>
-            <a:r>
-              <a:t>Escanea con tu móvil (@alu.upo.es)</a:t>
-            </a:r>
-            <a:br/>
-            <a:r>
-              <a:t>4 hipótesis a debate en clase</a:t>
-            </a:r>
-          </a:p>
-        </p:txBody>
-      </p:sp>
     </p:spTree>
   </p:cSld>
   <p:clrMapOvr>
@@ -11462,7 +12240,7 @@
         </p:blipFill>
         <p:spPr>
           <a:xfrm>
-            <a:off x="548640" y="1536192"/>
+            <a:off x="2137954" y="1536192"/>
             <a:ext cx="7772400" cy="3611880"/>
           </a:xfrm>
           <a:prstGeom prst="rect">
@@ -11478,7 +12256,7 @@
         </p:nvSpPr>
         <p:spPr>
           <a:xfrm>
-            <a:off x="548640" y="5230368"/>
+            <a:off x="2137954" y="5230368"/>
             <a:ext cx="7772400" cy="1005840"/>
           </a:xfrm>
           <a:prstGeom prst="roundRect">
@@ -11548,527 +12326,6 @@
             </a:r>
             <a:r>
               <a:t>, la pista se llena de puntos que chocan y rebotan sin emparejarse (desplazamiento hacia fuera).</a:t>
-            </a:r>
-          </a:p>
-        </p:txBody>
-      </p:sp>
-      <p:sp>
-        <p:nvSpPr>
-          <p:cNvPr id="8" name="Rounded Rectangle 7"/>
-          <p:cNvSpPr/>
-          <p:nvPr/>
-        </p:nvSpPr>
-        <p:spPr>
-          <a:xfrm>
-            <a:off x="8503920" y="1536192"/>
-            <a:ext cx="3154680" cy="4700016"/>
-          </a:xfrm>
-          <a:prstGeom prst="roundRect">
-            <a:avLst/>
-          </a:prstGeom>
-          <a:solidFill>
-            <a:srgbClr val="FFFFFF"/>
-          </a:solidFill>
-          <a:ln w="19050">
-            <a:solidFill>
-              <a:srgbClr val="113927"/>
-            </a:solidFill>
-          </a:ln>
-        </p:spPr>
-        <p:style>
-          <a:lnRef idx="1">
-            <a:schemeClr val="accent1"/>
-          </a:lnRef>
-          <a:fillRef idx="3">
-            <a:schemeClr val="accent1"/>
-          </a:fillRef>
-          <a:effectRef idx="2">
-            <a:schemeClr val="accent1"/>
-          </a:effectRef>
-          <a:fontRef idx="minor">
-            <a:schemeClr val="lt1"/>
-          </a:fontRef>
-        </p:style>
-        <p:txBody>
-          <a:bodyPr wrap="square" lIns="146304" tIns="128016" rIns="146304" bIns="91440" rtlCol="0" anchor="ctr"/>
-          <a:lstStyle/>
-          <a:p>
-            <a:pPr algn="ctr">
-              <a:defRPr sz="1400" b="1">
-                <a:solidFill>
-                  <a:srgbClr val="113927"/>
-                </a:solidFill>
-                <a:latin typeface="Outfit"/>
-              </a:defRPr>
-            </a:pPr>
-            <a:r>
-              <a:rPr dirty="0"/>
-              <a:t>LABORATORIO EN VIVO</a:t>
-            </a:r>
-          </a:p>
-          <a:p>
-            <a:pPr algn="ctr">
-              <a:defRPr sz="1200" b="1">
-                <a:solidFill>
-                  <a:srgbClr val="76927A"/>
-                </a:solidFill>
-                <a:latin typeface="Calibri"/>
-              </a:defRPr>
-            </a:pPr>
-            <a:r>
-              <a:rPr dirty="0"/>
-              <a:t>Micro-App: Pista de Baile ABM</a:t>
-            </a:r>
-          </a:p>
-        </p:txBody>
-      </p:sp>
-      <p:pic>
-        <p:nvPicPr>
-          <p:cNvPr id="9" name="Picture 8" descr="image.png"/>
-          <p:cNvPicPr>
-            <a:picLocks noChangeAspect="1"/>
-          </p:cNvPicPr>
-          <p:nvPr/>
-        </p:nvPicPr>
-        <p:blipFill>
-          <a:blip r:embed="rId4"/>
-          <a:stretch>
-            <a:fillRect/>
-          </a:stretch>
-        </p:blipFill>
-        <p:spPr>
-          <a:xfrm>
-            <a:off x="9253728" y="1929384"/>
-            <a:ext cx="1645920" cy="1645920"/>
-          </a:xfrm>
-          <a:prstGeom prst="rect">
-            <a:avLst/>
-          </a:prstGeom>
-        </p:spPr>
-      </p:pic>
-      <p:sp>
-        <p:nvSpPr>
-          <p:cNvPr id="10" name="TextBox 9"/>
-          <p:cNvSpPr txBox="1"/>
-          <p:nvPr/>
-        </p:nvSpPr>
-        <p:spPr>
-          <a:xfrm>
-            <a:off x="8595360" y="4297680"/>
-            <a:ext cx="2971800" cy="2194560"/>
-          </a:xfrm>
-          <a:prstGeom prst="rect">
-            <a:avLst/>
-          </a:prstGeom>
-          <a:noFill/>
-        </p:spPr>
-        <p:txBody>
-          <a:bodyPr wrap="square" lIns="0" tIns="0" rIns="0" bIns="0">
-            <a:spAutoFit/>
-          </a:bodyPr>
-          <a:lstStyle/>
-          <a:p>
-            <a:pPr>
-              <a:spcAft>
-                <a:spcPts val="200"/>
-              </a:spcAft>
-              <a:defRPr sz="1100">
-                <a:latin typeface="Calibri"/>
-              </a:defRPr>
-            </a:pPr>
-            <a:r>
-              <a:rPr b="1" dirty="0">
-                <a:solidFill>
-                  <a:srgbClr val="113927"/>
-                </a:solidFill>
-              </a:rPr>
-              <a:t>🔴 Puntos Rojos: </a:t>
-            </a:r>
-            <a:r>
-              <a:rPr dirty="0" err="1">
-                <a:solidFill>
-                  <a:srgbClr val="2F3A30"/>
-                </a:solidFill>
-              </a:rPr>
-              <a:t>Trabajadores</a:t>
-            </a:r>
-            <a:r>
-              <a:rPr dirty="0">
-                <a:solidFill>
-                  <a:srgbClr val="2F3A30"/>
-                </a:solidFill>
-              </a:rPr>
-              <a:t> </a:t>
-            </a:r>
-            <a:r>
-              <a:rPr dirty="0" err="1">
-                <a:solidFill>
-                  <a:srgbClr val="2F3A30"/>
-                </a:solidFill>
-              </a:rPr>
-              <a:t>desempleados</a:t>
-            </a:r>
-            <a:r>
-              <a:rPr dirty="0">
-                <a:solidFill>
-                  <a:srgbClr val="2F3A30"/>
-                </a:solidFill>
-              </a:rPr>
-              <a:t> (U).</a:t>
-            </a:r>
-          </a:p>
-          <a:p>
-            <a:pPr>
-              <a:spcAft>
-                <a:spcPts val="200"/>
-              </a:spcAft>
-              <a:defRPr sz="1100">
-                <a:latin typeface="Calibri"/>
-              </a:defRPr>
-            </a:pPr>
-            <a:r>
-              <a:rPr b="1" dirty="0">
-                <a:solidFill>
-                  <a:srgbClr val="113927"/>
-                </a:solidFill>
-              </a:rPr>
-              <a:t>🔵 Puntos </a:t>
-            </a:r>
-            <a:r>
-              <a:rPr b="1" dirty="0" err="1">
-                <a:solidFill>
-                  <a:srgbClr val="113927"/>
-                </a:solidFill>
-              </a:rPr>
-              <a:t>Azules</a:t>
-            </a:r>
-            <a:r>
-              <a:rPr b="1" dirty="0">
-                <a:solidFill>
-                  <a:srgbClr val="113927"/>
-                </a:solidFill>
-              </a:rPr>
-              <a:t>: </a:t>
-            </a:r>
-            <a:r>
-              <a:rPr dirty="0">
-                <a:solidFill>
-                  <a:srgbClr val="2F3A30"/>
-                </a:solidFill>
-              </a:rPr>
-              <a:t>Empresas con </a:t>
-            </a:r>
-            <a:r>
-              <a:rPr dirty="0" err="1">
-                <a:solidFill>
-                  <a:srgbClr val="2F3A30"/>
-                </a:solidFill>
-              </a:rPr>
-              <a:t>vacantes</a:t>
-            </a:r>
-            <a:r>
-              <a:rPr dirty="0">
-                <a:solidFill>
-                  <a:srgbClr val="2F3A30"/>
-                </a:solidFill>
-              </a:rPr>
-              <a:t> (V).</a:t>
-            </a:r>
-          </a:p>
-          <a:p>
-            <a:pPr>
-              <a:spcAft>
-                <a:spcPts val="200"/>
-              </a:spcAft>
-              <a:defRPr sz="1100">
-                <a:latin typeface="Calibri"/>
-              </a:defRPr>
-            </a:pPr>
-            <a:r>
-              <a:rPr b="1" dirty="0">
-                <a:solidFill>
-                  <a:srgbClr val="113927"/>
-                </a:solidFill>
-              </a:rPr>
-              <a:t>🟢 Pareja </a:t>
-            </a:r>
-            <a:r>
-              <a:rPr b="1" dirty="0" err="1">
-                <a:solidFill>
-                  <a:srgbClr val="113927"/>
-                </a:solidFill>
-              </a:rPr>
-              <a:t>Enlazada</a:t>
-            </a:r>
-            <a:r>
-              <a:rPr b="1" dirty="0">
-                <a:solidFill>
-                  <a:srgbClr val="113927"/>
-                </a:solidFill>
-              </a:rPr>
-              <a:t>: </a:t>
-            </a:r>
-            <a:r>
-              <a:rPr dirty="0" err="1">
-                <a:solidFill>
-                  <a:srgbClr val="2F3A30"/>
-                </a:solidFill>
-              </a:rPr>
-              <a:t>Contratación</a:t>
-            </a:r>
-            <a:r>
-              <a:rPr dirty="0">
-                <a:solidFill>
-                  <a:srgbClr val="2F3A30"/>
-                </a:solidFill>
-              </a:rPr>
-              <a:t> </a:t>
-            </a:r>
-            <a:r>
-              <a:rPr dirty="0" err="1">
-                <a:solidFill>
-                  <a:srgbClr val="2F3A30"/>
-                </a:solidFill>
-              </a:rPr>
-              <a:t>exitosa</a:t>
-            </a:r>
-            <a:r>
-              <a:rPr dirty="0">
-                <a:solidFill>
-                  <a:srgbClr val="2F3A30"/>
-                </a:solidFill>
-              </a:rPr>
-              <a:t> (M).</a:t>
-            </a:r>
-          </a:p>
-          <a:p>
-            <a:pPr>
-              <a:spcAft>
-                <a:spcPts val="200"/>
-              </a:spcAft>
-              <a:defRPr sz="1100">
-                <a:latin typeface="Calibri"/>
-              </a:defRPr>
-            </a:pPr>
-            <a:r>
-              <a:rPr b="1" dirty="0">
-                <a:solidFill>
-                  <a:srgbClr val="113927"/>
-                </a:solidFill>
-              </a:rPr>
-              <a:t>🎯 </a:t>
-            </a:r>
-            <a:r>
-              <a:rPr b="1" dirty="0" err="1">
-                <a:solidFill>
-                  <a:srgbClr val="113927"/>
-                </a:solidFill>
-              </a:rPr>
-              <a:t>Parámetro</a:t>
-            </a:r>
-            <a:r>
-              <a:rPr b="1" dirty="0">
-                <a:solidFill>
-                  <a:srgbClr val="113927"/>
-                </a:solidFill>
-              </a:rPr>
-              <a:t> A: </a:t>
-            </a:r>
-            <a:r>
-              <a:rPr dirty="0" err="1">
-                <a:solidFill>
-                  <a:srgbClr val="2F3A30"/>
-                </a:solidFill>
-              </a:rPr>
-              <a:t>Ajuste</a:t>
-            </a:r>
-            <a:r>
-              <a:rPr dirty="0">
-                <a:solidFill>
-                  <a:srgbClr val="2F3A30"/>
-                </a:solidFill>
-              </a:rPr>
-              <a:t> de </a:t>
-            </a:r>
-            <a:r>
-              <a:rPr dirty="0" err="1">
-                <a:solidFill>
-                  <a:srgbClr val="2F3A30"/>
-                </a:solidFill>
-              </a:rPr>
-              <a:t>habilidades</a:t>
-            </a:r>
-            <a:r>
-              <a:rPr dirty="0">
-                <a:solidFill>
-                  <a:srgbClr val="2F3A30"/>
-                </a:solidFill>
-              </a:rPr>
-              <a:t> y </a:t>
-            </a:r>
-            <a:r>
-              <a:rPr dirty="0" err="1">
-                <a:solidFill>
-                  <a:srgbClr val="2F3A30"/>
-                </a:solidFill>
-              </a:rPr>
-              <a:t>competencias</a:t>
-            </a:r>
-            <a:r>
-              <a:rPr dirty="0">
-                <a:solidFill>
-                  <a:srgbClr val="2F3A30"/>
-                </a:solidFill>
-              </a:rPr>
-              <a:t>.</a:t>
-            </a:r>
-          </a:p>
-          <a:p>
-            <a:pPr>
-              <a:spcAft>
-                <a:spcPts val="200"/>
-              </a:spcAft>
-              <a:defRPr sz="1100">
-                <a:latin typeface="Calibri"/>
-              </a:defRPr>
-            </a:pPr>
-            <a:r>
-              <a:rPr b="1" dirty="0">
-                <a:solidFill>
-                  <a:srgbClr val="113927"/>
-                </a:solidFill>
-              </a:rPr>
-              <a:t>💡 </a:t>
-            </a:r>
-            <a:r>
-              <a:rPr b="1" dirty="0" err="1">
-                <a:solidFill>
-                  <a:srgbClr val="113927"/>
-                </a:solidFill>
-              </a:rPr>
-              <a:t>Prueba</a:t>
-            </a:r>
-            <a:r>
-              <a:rPr b="1" dirty="0">
-                <a:solidFill>
-                  <a:srgbClr val="113927"/>
-                </a:solidFill>
-              </a:rPr>
-              <a:t> el shock: </a:t>
-            </a:r>
-            <a:r>
-              <a:rPr dirty="0" err="1">
-                <a:solidFill>
-                  <a:srgbClr val="2F3A30"/>
-                </a:solidFill>
-              </a:rPr>
-              <a:t>Pulsa</a:t>
-            </a:r>
-            <a:r>
-              <a:rPr dirty="0">
-                <a:solidFill>
-                  <a:srgbClr val="2F3A30"/>
-                </a:solidFill>
-              </a:rPr>
-              <a:t> '</a:t>
-            </a:r>
-            <a:r>
-              <a:rPr dirty="0" err="1">
-                <a:solidFill>
-                  <a:srgbClr val="2F3A30"/>
-                </a:solidFill>
-              </a:rPr>
-              <a:t>Recesión</a:t>
-            </a:r>
-            <a:r>
-              <a:rPr dirty="0">
-                <a:solidFill>
-                  <a:srgbClr val="2F3A30"/>
-                </a:solidFill>
-              </a:rPr>
-              <a:t>' y 'Mismatch' </a:t>
-            </a:r>
-            <a:r>
-              <a:rPr dirty="0" err="1">
-                <a:solidFill>
-                  <a:srgbClr val="2F3A30"/>
-                </a:solidFill>
-              </a:rPr>
-              <a:t>en</a:t>
-            </a:r>
-            <a:r>
-              <a:rPr dirty="0">
-                <a:solidFill>
-                  <a:srgbClr val="2F3A30"/>
-                </a:solidFill>
-              </a:rPr>
-              <a:t> </a:t>
-            </a:r>
-            <a:r>
-              <a:rPr dirty="0" err="1">
-                <a:solidFill>
-                  <a:srgbClr val="2F3A30"/>
-                </a:solidFill>
-              </a:rPr>
-              <a:t>tu</a:t>
-            </a:r>
-            <a:r>
-              <a:rPr dirty="0">
-                <a:solidFill>
-                  <a:srgbClr val="2F3A30"/>
-                </a:solidFill>
-              </a:rPr>
-              <a:t> </a:t>
-            </a:r>
-            <a:r>
-              <a:rPr dirty="0" err="1">
-                <a:solidFill>
-                  <a:srgbClr val="2F3A30"/>
-                </a:solidFill>
-              </a:rPr>
-              <a:t>móvil</a:t>
-            </a:r>
-            <a:r>
-              <a:rPr dirty="0">
-                <a:solidFill>
-                  <a:srgbClr val="2F3A30"/>
-                </a:solidFill>
-              </a:rPr>
-              <a:t>.</a:t>
-            </a:r>
-          </a:p>
-          <a:p>
-            <a:pPr algn="ctr">
-              <a:spcBef>
-                <a:spcPts val="400"/>
-              </a:spcBef>
-            </a:pPr>
-            <a:r>
-              <a:rPr sz="1100" b="1" dirty="0">
-                <a:solidFill>
-                  <a:srgbClr val="E98F71"/>
-                </a:solidFill>
-                <a:latin typeface="Calibri"/>
-              </a:rPr>
-              <a:t>mhidper.github.io/</a:t>
-            </a:r>
-            <a:r>
-              <a:rPr sz="1100" b="1" dirty="0" err="1">
-                <a:solidFill>
-                  <a:srgbClr val="E98F71"/>
-                </a:solidFill>
-                <a:latin typeface="Calibri"/>
-              </a:rPr>
-              <a:t>micro_apps</a:t>
-            </a:r>
-            <a:r>
-              <a:rPr sz="1100" b="1" dirty="0">
-                <a:solidFill>
-                  <a:srgbClr val="E98F71"/>
-                </a:solidFill>
-                <a:latin typeface="Calibri"/>
-              </a:rPr>
-              <a:t>/</a:t>
             </a:r>
           </a:p>
         </p:txBody>
@@ -12179,7 +12436,7 @@
         <p:spPr>
           <a:xfrm>
             <a:off x="548640" y="365760"/>
-            <a:ext cx="9144000" cy="169277"/>
+            <a:ext cx="9144000" cy="274320"/>
           </a:xfrm>
           <a:prstGeom prst="rect">
             <a:avLst/>
@@ -12201,8 +12458,7 @@
               </a:defRPr>
             </a:pPr>
             <a:r>
-              <a:rPr dirty="0"/>
-              <a:t>BLOQUE 3 · EVIDENCIA EMPÍRICA (AMPLIACIÓN L1)</a:t>
+              <a:t>BLOQUE 4 · LABORATORIO ACTIVO Y SIMULADOR (20 MIN)</a:t>
             </a:r>
           </a:p>
         </p:txBody>
@@ -12238,16 +12494,7 @@
               </a:defRPr>
             </a:pPr>
             <a:r>
-              <a:rPr dirty="0"/>
-              <a:t>La Curva de Beveridge </a:t>
-            </a:r>
-            <a:r>
-              <a:rPr dirty="0" err="1"/>
-              <a:t>en</a:t>
-            </a:r>
-            <a:r>
-              <a:rPr dirty="0"/>
-              <a:t> España (1980–2024)</a:t>
+              <a:t>Simulador Móvil: Curva de Beveridge y Emparejamiento</a:t>
             </a:r>
           </a:p>
         </p:txBody>
@@ -12283,7 +12530,7 @@
               </a:defRPr>
             </a:pPr>
             <a:r>
-              <a:t>Figura 1.9 oficial de los apuntes: análisis de las tres fases históricas macroeconómicas</a:t>
+              <a:t>Misión técnica interactiva: rol de Analistas de la Consejería de Empleo desde el smartphone</a:t>
             </a:r>
           </a:p>
         </p:txBody>
@@ -12379,14 +12626,174 @@
               </a:defRPr>
             </a:pPr>
             <a:r>
-              <a:t>11 / 17</a:t>
+              <a:t>13 / 17</a:t>
+            </a:r>
+          </a:p>
+        </p:txBody>
+      </p:sp>
+      <p:sp>
+        <p:nvSpPr>
+          <p:cNvPr id="8" name="Rounded Rectangle 7"/>
+          <p:cNvSpPr/>
+          <p:nvPr/>
+        </p:nvSpPr>
+        <p:spPr>
+          <a:xfrm>
+            <a:off x="548640" y="1645920"/>
+            <a:ext cx="6858000" cy="4389120"/>
+          </a:xfrm>
+          <a:prstGeom prst="roundRect">
+            <a:avLst/>
+          </a:prstGeom>
+          <a:solidFill>
+            <a:srgbClr val="FFFFFF"/>
+          </a:solidFill>
+          <a:ln w="19050">
+            <a:solidFill>
+              <a:srgbClr val="76927A"/>
+            </a:solidFill>
+          </a:ln>
+        </p:spPr>
+        <p:style>
+          <a:lnRef idx="1">
+            <a:schemeClr val="accent1"/>
+          </a:lnRef>
+          <a:fillRef idx="3">
+            <a:schemeClr val="accent1"/>
+          </a:fillRef>
+          <a:effectRef idx="2">
+            <a:schemeClr val="accent1"/>
+          </a:effectRef>
+          <a:fontRef idx="minor">
+            <a:schemeClr val="lt1"/>
+          </a:fontRef>
+        </p:style>
+        <p:txBody>
+          <a:bodyPr wrap="square" lIns="256032" tIns="201168" rIns="256032" rtlCol="0" anchor="ctr"/>
+          <a:lstStyle/>
+          <a:p>
+            <a:pPr algn="ctr">
+              <a:spcAft>
+                <a:spcPts val="800"/>
+              </a:spcAft>
+              <a:defRPr sz="1200" b="1">
+                <a:solidFill>
+                  <a:srgbClr val="E98F71"/>
+                </a:solidFill>
+                <a:latin typeface="Outfit"/>
+              </a:defRPr>
+            </a:pPr>
+            <a:r>
+              <a:t>MISIÓN TÉCNICA · GABINETE DE LA CONSEJERÍA DE EMPLEO</a:t>
+            </a:r>
+          </a:p>
+          <a:p>
+            <a:pPr>
+              <a:defRPr sz="1600">
+                <a:solidFill>
+                  <a:srgbClr val="2F3A30"/>
+                </a:solidFill>
+                <a:latin typeface="Calibri"/>
+              </a:defRPr>
+            </a:pPr>
+            <a:r>
+              <a:t>1. Apertura de la App en el Móvil: Escanear el código QR contiguo para abrir el simulador interactivo en HTML5 Canvas.</a:t>
+            </a:r>
+            <a:br/>
+            <a:br/>
+            <a:r>
+              <a:t>2. Experimento 1 (Ciclo vs Estructura): Mover el control de Demanda Agregada manteniendo A constante. Comprobar cómo la economía se desplaza a lo largo de la curva UV.</a:t>
+            </a:r>
+            <a:br/>
+            <a:br/>
+            <a:r>
+              <a:t>3. Experimento 2 (Shock de Desajuste): Activar el escenario de Skills Mismatch y caída de A. Observar cómo la curva entera se desplaza hacia el exterior.</a:t>
+            </a:r>
+            <a:br/>
+            <a:br/>
+            <a:r>
+              <a:t>4. Cumplimentar en parejas la Hoja de Laboratorio Activo.</a:t>
+            </a:r>
+          </a:p>
+        </p:txBody>
+      </p:sp>
+      <p:sp>
+        <p:nvSpPr>
+          <p:cNvPr id="9" name="Rounded Rectangle 8"/>
+          <p:cNvSpPr/>
+          <p:nvPr/>
+        </p:nvSpPr>
+        <p:spPr>
+          <a:xfrm>
+            <a:off x="7680960" y="1645920"/>
+            <a:ext cx="3931920" cy="4389120"/>
+          </a:xfrm>
+          <a:prstGeom prst="roundRect">
+            <a:avLst/>
+          </a:prstGeom>
+          <a:solidFill>
+            <a:srgbClr val="F4F8F5"/>
+          </a:solidFill>
+          <a:ln w="19050">
+            <a:solidFill>
+              <a:srgbClr val="E98F71"/>
+            </a:solidFill>
+          </a:ln>
+        </p:spPr>
+        <p:style>
+          <a:lnRef idx="1">
+            <a:schemeClr val="accent1"/>
+          </a:lnRef>
+          <a:fillRef idx="3">
+            <a:schemeClr val="accent1"/>
+          </a:fillRef>
+          <a:effectRef idx="2">
+            <a:schemeClr val="accent1"/>
+          </a:effectRef>
+          <a:fontRef idx="minor">
+            <a:schemeClr val="lt1"/>
+          </a:fontRef>
+        </p:style>
+        <p:txBody>
+          <a:bodyPr wrap="square" lIns="182880" tIns="201168" rIns="182880" rtlCol="0" anchor="ctr"/>
+          <a:lstStyle/>
+          <a:p>
+            <a:pPr algn="ctr">
+              <a:spcAft>
+                <a:spcPts val="600"/>
+              </a:spcAft>
+              <a:defRPr sz="1100" b="1">
+                <a:solidFill>
+                  <a:srgbClr val="113927"/>
+                </a:solidFill>
+                <a:latin typeface="Outfit"/>
+              </a:defRPr>
+            </a:pPr>
+            <a:r>
+              <a:t>ACCESO DIRECTO A LA MICRO-APP</a:t>
+            </a:r>
+          </a:p>
+          <a:p>
+            <a:pPr algn="ctr">
+              <a:spcAft>
+                <a:spcPts val="1000"/>
+              </a:spcAft>
+              <a:defRPr sz="1500" b="1">
+                <a:solidFill>
+                  <a:srgbClr val="E98F71"/>
+                </a:solidFill>
+                <a:latin typeface="Outfit"/>
+              </a:defRPr>
+            </a:pPr>
+            <a:r>
+              <a:t>Simulador Beveridge &amp; DMP</a:t>
             </a:r>
           </a:p>
         </p:txBody>
       </p:sp>
       <p:pic>
         <p:nvPicPr>
-          <p:cNvPr id="8" name="Picture 7" descr="curva_beveridge_dual.png"/>
+          <p:cNvPr id="10" name="Picture 9" descr="qr_app_sesion05.png"/>
           <p:cNvPicPr>
             <a:picLocks noChangeAspect="1"/>
           </p:cNvPicPr>
@@ -12400,14 +12807,54 @@
         </p:blipFill>
         <p:spPr>
           <a:xfrm>
-            <a:off x="1336039" y="1353312"/>
-            <a:ext cx="8671561" cy="4734369"/>
+            <a:off x="8412480" y="2560320"/>
+            <a:ext cx="2468880" cy="2468880"/>
           </a:xfrm>
           <a:prstGeom prst="rect">
             <a:avLst/>
           </a:prstGeom>
         </p:spPr>
       </p:pic>
+      <p:sp>
+        <p:nvSpPr>
+          <p:cNvPr id="11" name="TextBox 10"/>
+          <p:cNvSpPr txBox="1"/>
+          <p:nvPr/>
+        </p:nvSpPr>
+        <p:spPr>
+          <a:xfrm>
+            <a:off x="7772400" y="5166360"/>
+            <a:ext cx="3749039" cy="731520"/>
+          </a:xfrm>
+          <a:prstGeom prst="rect">
+            <a:avLst/>
+          </a:prstGeom>
+          <a:noFill/>
+        </p:spPr>
+        <p:txBody>
+          <a:bodyPr wrap="none">
+            <a:spAutoFit/>
+          </a:bodyPr>
+          <a:lstStyle/>
+          <a:p>
+            <a:pPr algn="ctr">
+              <a:defRPr sz="1300">
+                <a:solidFill>
+                  <a:srgbClr val="2F3A30"/>
+                </a:solidFill>
+                <a:latin typeface="Calibri"/>
+              </a:defRPr>
+            </a:pPr>
+            <a:r>
+              <a:t>mhidper.github.io/micro_apps</a:t>
+            </a:r>
+            <a:br/>
+            <a:r>
+              <a:t>(Simulador interactivo · 15 min)</a:t>
+            </a:r>
+          </a:p>
+        </p:txBody>
+      </p:sp>
     </p:spTree>
   </p:cSld>
   <p:clrMapOvr>

</xml_diff>